<commit_message>
slides: recut model-agent pages, add closing ledger page
Pages four and five were cut along "the flow" and "a zoom on phase C", which
left A/B/D as one-liners while C got a whole page. Recut them as "how a task
runs" and "why its numbers can be trusted": every phase now states what it
produces, and the invariants that make a reported gain credible sit together
on page five instead of being split across both.

Pages seven and eight gain the connective tissue the sequence was missing --
the eyebrows now mark the return to the model layer, the scenarios name the
input shape that drives the share shift, and point two hands off to page
eight explicitly.

Page nine closes back to page one's proposition, which the deck previously
left open by ending on a list of unfinished items.
</commit_message>
<xml_diff>
--- a/slides/m100_agent_deck.pptx
+++ b/slides/m100_agent_deck.pptx
@@ -13,6 +13,7 @@
     <p:sldId id="261" r:id="rId13"/>
     <p:sldId id="262" r:id="rId14"/>
     <p:sldId id="263" r:id="rId15"/>
+    <p:sldId id="264" r:id="rId16"/>
   </p:sldIdLst>
   <p:sldSz cx="12191695" cy="6858000" type="screen4x3"/>
   <p:notesSz cx="6858000" cy="9144000"/>
@@ -522,7 +523,7 @@
                 <a:ea typeface="Microsoft YaHei"/>
                 <a:cs typeface="Microsoft YaHei"/>
               </a:rPr>
-              <a:t>【1 / 8 · 适配成本 · 约 85 秒（1:25）】</a:t>
+              <a:t>【1 / 9 · 适配成本 · 约 85 秒（1:25）】</a:t>
             </a:r>
           </a:p>
           <a:p>
@@ -749,7 +750,7 @@
                 <a:ea typeface="Microsoft YaHei"/>
                 <a:cs typeface="Microsoft YaHei"/>
               </a:rPr>
-              <a:t>【2 / 8 · 软件栈 · 约 65 秒（1:05）】</a:t>
+              <a:t>【2 / 9 · 软件栈 · 约 65 秒（1:05）】</a:t>
             </a:r>
           </a:p>
           <a:p>
@@ -976,7 +977,7 @@
                 <a:ea typeface="Microsoft YaHei"/>
                 <a:cs typeface="Microsoft YaHei"/>
               </a:rPr>
-              <a:t>【3 / 8 · 两个 Agent 纵览 · 约 110 秒（1:50）】</a:t>
+              <a:t>【3 / 9 · 两个 Agent 纵览 · 约 110 秒（1:50）】</a:t>
             </a:r>
           </a:p>
           <a:p>
@@ -1221,7 +1222,7 @@
                 <a:ea typeface="Microsoft YaHei"/>
                 <a:cs typeface="Microsoft YaHei"/>
               </a:rPr>
-              <a:t>【4 / 8 · 模型层 · 执行迭代 · 约 105 秒（1:45）】</a:t>
+              <a:t>【4 / 9 · 模型层 · 一次任务怎么跑完 · 约 140 秒（2:20）】</a:t>
             </a:r>
           </a:p>
           <a:p>
@@ -1239,7 +1240,7 @@
                 <a:ea typeface="Microsoft YaHei"/>
                 <a:cs typeface="Microsoft YaHei"/>
               </a:rPr>
-              <a:t>这一页是模型层的工作方式：人定目标，Agent 在固定约束内迭代，结果交回人验收。</a:t>
+              <a:t>这一页讲模型层的一次任务是怎么跑完的：人定目标，Agent 跑完四个阶段，结果交回人验收。</a:t>
             </a:r>
           </a:p>
           <a:p>
@@ -1257,7 +1258,7 @@
                 <a:ea typeface="Microsoft YaHei"/>
                 <a:cs typeface="Microsoft YaHei"/>
               </a:rPr>
-              <a:t>最上面一行是三个阶段：架构接入做新架构的逐层验收，性能调优在实测环境下迭代，持续优化按 Trace 长期迭代。今天重点是中间这条。</a:t>
+              <a:t>顶上这一行先交代范围。三条命令线共用同一套契约——架构接入、性能调优、持续优化；今天讲中间这条。</a:t>
             </a:r>
           </a:p>
           <a:p>
@@ -1293,7 +1294,25 @@
                 <a:ea typeface="Microsoft YaHei"/>
                 <a:cs typeface="Microsoft YaHei"/>
               </a:rPr>
-              <a:t>中间整段无人值守。A 先完成预检再验收基线；B 独立采样 Trace，只用于诊断，不计入收益；C 是候选迭代，小步改动、逐轮验证收益，右边那个回环标注的就是它；D 最终复验，重测基线与候选，独立复验一遍。</a:t>
+              <a:t>中间整段无人值守，四个阶段，每个阶段都有明确产出，这是看懂这条链的关键。A 先完成预检再跑全量评测，产出基线指标和一套可复现的启动方式；B 用独立进程采 Trace，不参与计时，产出热点清单，只用来选方向，不计入任何收益；C 是候选迭代，小步改动、逐个按三道条件验收，产出通过筛选的候选和各自收益，下一页整页展开；D 最终复验，重测基线再独立复验每个候选，产出可交付的那一个。</a:t>
+            </a:r>
+          </a:p>
+          <a:p>
+            <a:pPr>
+              <a:spcAft>
+                <a:spcPts val="600"/>
+              </a:spcAft>
+            </a:pPr>
+            <a:r>
+              <a:rPr sz="1200" b="0">
+                <a:solidFill>
+                  <a:srgbClr val="16202A"/>
+                </a:solidFill>
+                <a:latin typeface="Microsoft YaHei"/>
+                <a:ea typeface="Microsoft YaHei"/>
+                <a:cs typeface="Microsoft YaHei"/>
+              </a:rPr>
+              <a:t>D 为什么不能省：C 阶段的收益是在筛选过程中测出来的，基线和候选分处不同时间段。重新测一遍基线、再独立复验一次，数才算数。</a:t>
             </a:r>
           </a:p>
           <a:p>
@@ -1484,7 +1503,7 @@
                 <a:ea typeface="Microsoft YaHei"/>
                 <a:cs typeface="Microsoft YaHei"/>
               </a:rPr>
-              <a:t>【5 / 8 · 模型层 · 候选验收 · 约 100 秒（1:40）】</a:t>
+              <a:t>【5 / 9 · 模型层 · 候选验收与可信度 · 约 135 秒（2:15）】</a:t>
             </a:r>
           </a:p>
           <a:p>
@@ -1502,7 +1521,7 @@
                 <a:ea typeface="Microsoft YaHei"/>
                 <a:cs typeface="Microsoft YaHei"/>
               </a:rPr>
-              <a:t>这一页放大上一页的 C 阶段：里面每一个候选，都要走完左边这条流水线。</a:t>
+              <a:t>上一页 C 阶段里的每一个候选，都要走完这一页。但这一页真正回答的是另一个问题：Agent 报出来的收益，凭什么可信。</a:t>
             </a:r>
           </a:p>
           <a:p>
@@ -1538,7 +1557,7 @@
                 <a:ea typeface="Microsoft YaHei"/>
                 <a:cs typeface="Microsoft YaHei"/>
               </a:rPr>
-              <a:t>然后三道条件，顺序按成本由低到高。第一道看输出有没有变，判据是贪心 token 完全一致；第二道看质量，正确率与解析率都不许降；第三道看是不是确实更快，收益要大于 3%、回归不超过 5%，重复压测取中位，还要大于噪声极差。任一道不过就停止后续测试，不再占用设备时间，但失败证据保留。</a:t>
+              <a:t>然后三道条件，顺序按成本由低到高。第一道看输出有没有变，判据是贪心 token 完全一致；第二道看质量，正确率与解析率都不许降；第三道看是不是确实更快，收益要大于 3%、回归不超过 5%，重复压测取中位，还要大于噪声极差。任一道不过就停止后续测试，不再占用设备时间，但失败证据保留。为什么按这个顺序——越靠前的越便宜，先用几秒钟的对比挡掉大部分不合格的候选。</a:t>
             </a:r>
           </a:p>
           <a:p>
@@ -1556,7 +1575,7 @@
                 <a:ea typeface="Microsoft YaHei"/>
                 <a:cs typeface="Microsoft YaHei"/>
               </a:rPr>
-              <a:t>下面两条保证候选之间可比：输入、精度、上下文与缓存条件全部固定，prompt 的 token 数必须等于冻结值；诊断和正式压测分开，收益由关闭 profiler 的独立复测确认——不能靠减少实际工作量换速度。</a:t>
+              <a:t>下面三条是这一页的落点，三条防止自欺的约束。第一，口径先冻结：模型、负载、阈值与预算随任务写定，改了之后已有结果不再沿用。第二，测的是同一个候选：隔离副本、记录产物身份、启动时核对，不会出现测 A 报 B。第三，不能靠少干活变快：输入、精度、上下文与缓存全部冻结，prompt 的 token 数必须等于冻结值，诊断和正式压测分开跑。</a:t>
             </a:r>
           </a:p>
           <a:p>
@@ -1574,7 +1593,7 @@
                 <a:ea typeface="Microsoft YaHei"/>
                 <a:cs typeface="Microsoft YaHei"/>
               </a:rPr>
-              <a:t>右边放这条流水线判出来的结果。口径要强调：只有独立复验通过的收益才进入最终交付，筛选阶段看起来有收益、复验没过的，一个都不算。</a:t>
+              <a:t>右边放这条流水线判出来的实际结果。最后一条口径：只有独立复验通过的收益才进入最终交付，筛选阶段看起来有收益、复验没过的，一个都不算。</a:t>
             </a:r>
           </a:p>
           <a:p>
@@ -1729,7 +1748,7 @@
                 <a:ea typeface="Microsoft YaHei"/>
                 <a:cs typeface="Microsoft YaHei"/>
               </a:rPr>
-              <a:t>【6 / 8 · 算子层 · 生成与迭代 · 约 100 秒（1:40）】</a:t>
+              <a:t>【6 / 9 · 算子层 · 生成与迭代 · 约 100 秒（1:40）】</a:t>
             </a:r>
           </a:p>
           <a:p>
@@ -1974,7 +1993,7 @@
                 <a:ea typeface="Microsoft YaHei"/>
                 <a:cs typeface="Microsoft YaHei"/>
               </a:rPr>
-              <a:t>【7 / 8 · 局部加速到整体收益 · 约 105 秒（1:45）】</a:t>
+              <a:t>【7 / 9 · 回到模型层看收益 · 约 115 秒（1:55）】</a:t>
             </a:r>
           </a:p>
           <a:p>
@@ -2028,7 +2047,7 @@
                 <a:ea typeface="Microsoft YaHei"/>
                 <a:cs typeface="Microsoft YaHei"/>
               </a:rPr>
-              <a:t>两个场景，区别只在算子占比。场景 A 偏 GEMM，GEMM 占 80%、Attention 占 10%；场景 B 里 Attention 涨到 40%，GEMM 降到 50%。</a:t>
+              <a:t>两个场景，区别只在算子占比，而占比是由输入形状决定的。场景 A 是短输入，GEMM 占 80%、Attention 占 10%；场景 B 是长上下文，Attention 涨到 40%，GEMM 降到 50%。</a:t>
             </a:r>
           </a:p>
           <a:p>
@@ -2064,7 +2083,7 @@
                 <a:ea typeface="Microsoft YaHei"/>
                 <a:cs typeface="Microsoft YaHei"/>
               </a:rPr>
-              <a:t>右边三条是为什么要回到模型看收益。第一，占比决定直接收益，占比小的算子再快也带不动整步。第二，整步耗时还不是服务容量，排队、批次、缓存和时延目标都会改变最终结果。第三，每轮优化之后瓶颈可能转移，下一轮要按新的 Trace 重排优先级。</a:t>
+              <a:t>右边三条是为什么要回到模型看收益。第一，占比决定直接收益，占比小的算子再快也带不动整步。第二，整步耗时还不是服务容量，排队、批次、缓存和时延目标都会改变最终结果——下一页给出完整的换算办法。第三，每轮优化之后瓶颈可能转移，下一轮要按新的 Trace 重排优先级。</a:t>
             </a:r>
           </a:p>
           <a:p>
@@ -2237,7 +2256,7 @@
                 <a:ea typeface="Microsoft YaHei"/>
                 <a:cs typeface="Microsoft YaHei"/>
               </a:rPr>
-              <a:t>【8 / 8 · 算子耗时到服务容量 · 约 105 秒（1:45）】</a:t>
+              <a:t>【8 / 9 · 算子耗时到服务容量 · 约 110 秒（1:50）】</a:t>
             </a:r>
           </a:p>
           <a:p>
@@ -2255,7 +2274,7 @@
                 <a:ea typeface="Microsoft YaHei"/>
                 <a:cs typeface="Microsoft YaHei"/>
               </a:rPr>
-              <a:t>最后一页讲方法：从算子耗时一路算到单机容量，这条链怎么用。</a:t>
+              <a:t>上一页留了个问题：怎么系统地判断该先优化哪个算子。这一页就是那个办法——从算子耗时一路算到单机容量。</a:t>
             </a:r>
           </a:p>
           <a:p>
@@ -2327,7 +2346,7 @@
                 <a:ea typeface="Microsoft YaHei"/>
                 <a:cs typeface="Microsoft YaHei"/>
               </a:rPr>
-              <a:t>一句话收尾：这条链只用于排优先级；任何进入交付的收益，都以整模型实测为准。</a:t>
+              <a:t>一句话过渡：这条链只用于排优先级；任何进入交付的收益，都以整模型实测为准。</a:t>
             </a:r>
           </a:p>
           <a:p>
@@ -2382,6 +2401,251 @@
                 <a:cs typeface="Microsoft YaHei"/>
               </a:rPr>
               <a:t>容量定义是满足 SLO 的最大请求到达率，依赖具体的 TTFT / TPOT 目标；换一组业务目标，排序可能变化。</a:t>
+            </a:r>
+          </a:p>
+          <a:p>
+            <a:pPr>
+              <a:spcAft>
+                <a:spcPts val="600"/>
+              </a:spcAft>
+            </a:pPr>
+            <a:r>
+              <a:rPr sz="1200" b="0">
+                <a:solidFill>
+                  <a:srgbClr val="66727F"/>
+                </a:solidFill>
+                <a:latin typeface="Microsoft YaHei"/>
+                <a:ea typeface="Microsoft YaHei"/>
+                <a:cs typeface="Microsoft YaHei"/>
+              </a:rPr>
+              <a:t>这条链按单实例算容量。多机与 PD 分离下还要叠加跨机通信与路由，不在本页范围内。</a:t>
+            </a:r>
+          </a:p>
+        </p:txBody>
+      </p:sp>
+      <p:sp>
+        <p:nvSpPr>
+          <p:cNvPr id="4" name="Slide Number Placeholder 3"/>
+          <p:cNvSpPr>
+            <a:spLocks noGrp="1"/>
+          </p:cNvSpPr>
+          <p:nvPr>
+            <p:ph type="sldNum" idx="5" sz="quarter"/>
+          </p:nvPr>
+        </p:nvSpPr>
+        <p:spPr/>
+      </p:sp>
+    </p:spTree>
+  </p:cSld>
+  <p:clrMapOvr>
+    <a:masterClrMapping/>
+  </p:clrMapOvr>
+</p:notes>
+</file>
+
+<file path=ppt/notesSlides/notesSlide9.xml><?xml version="1.0" encoding="utf-8"?>
+<p:notes xmlns:a="http://schemas.openxmlformats.org/drawingml/2006/main" xmlns:p="http://schemas.openxmlformats.org/presentationml/2006/main" xmlns:r="http://schemas.openxmlformats.org/officeDocument/2006/relationships">
+  <p:cSld>
+    <p:spTree>
+      <p:nvGrpSpPr>
+        <p:cNvPr id="1" name=""/>
+        <p:cNvGrpSpPr/>
+        <p:nvPr/>
+      </p:nvGrpSpPr>
+      <p:grpSpPr>
+        <a:xfrm>
+          <a:off x="0" y="0"/>
+          <a:ext cx="0" cy="0"/>
+          <a:chOff x="0" y="0"/>
+          <a:chExt cx="0" cy="0"/>
+        </a:xfrm>
+      </p:grpSpPr>
+      <p:sp>
+        <p:nvSpPr>
+          <p:cNvPr id="2" name="Slide Image Placeholder 1"/>
+          <p:cNvSpPr>
+            <a:spLocks noGrp="1"/>
+          </p:cNvSpPr>
+          <p:nvPr>
+            <p:ph type="sldImg" idx="2"/>
+          </p:nvPr>
+        </p:nvSpPr>
+        <p:spPr/>
+      </p:sp>
+      <p:sp>
+        <p:nvSpPr>
+          <p:cNvPr id="3" name="Notes Placeholder 2"/>
+          <p:cNvSpPr>
+            <a:spLocks noGrp="1"/>
+          </p:cNvSpPr>
+          <p:nvPr>
+            <p:ph type="body" idx="3" sz="quarter"/>
+          </p:nvPr>
+        </p:nvSpPr>
+        <p:spPr/>
+        <p:txBody>
+          <a:bodyPr/>
+          <a:lstStyle/>
+          <a:p>
+            <a:pPr>
+              <a:spcAft>
+                <a:spcPts val="600"/>
+              </a:spcAft>
+            </a:pPr>
+            <a:r>
+              <a:rPr sz="1200" b="1">
+                <a:solidFill>
+                  <a:srgbClr val="66727F"/>
+                </a:solidFill>
+                <a:latin typeface="Microsoft YaHei"/>
+                <a:ea typeface="Microsoft YaHei"/>
+                <a:cs typeface="Microsoft YaHei"/>
+              </a:rPr>
+              <a:t>【9 / 9 · 现状与下一步 · 约 75 秒（1:15）】</a:t>
+            </a:r>
+          </a:p>
+          <a:p>
+            <a:pPr>
+              <a:spcAft>
+                <a:spcPts val="600"/>
+              </a:spcAft>
+            </a:pPr>
+            <a:r>
+              <a:rPr sz="1200" b="0">
+                <a:solidFill>
+                  <a:srgbClr val="16202A"/>
+                </a:solidFill>
+                <a:latin typeface="Microsoft YaHei"/>
+                <a:ea typeface="Microsoft YaHei"/>
+                <a:cs typeface="Microsoft YaHei"/>
+              </a:rPr>
+              <a:t>最后回到第 1 页的命题，如实对一次账。</a:t>
+            </a:r>
+          </a:p>
+          <a:p>
+            <a:pPr>
+              <a:spcAft>
+                <a:spcPts val="600"/>
+              </a:spcAft>
+            </a:pPr>
+            <a:r>
+              <a:rPr sz="1200" b="0">
+                <a:solidFill>
+                  <a:srgbClr val="16202A"/>
+                </a:solidFill>
+                <a:latin typeface="Microsoft YaHei"/>
+                <a:ea typeface="Microsoft YaHei"/>
+                <a:cs typeface="Microsoft YaHei"/>
+              </a:rPr>
+              <a:t>左边这列已经能自动跑：基线建立与全量评测、候选迭代与三道条件验收、Trace 采集与热点定位、失败证据与逐轮回放。这几件人不在回路里，跑完才看结果。</a:t>
+            </a:r>
+          </a:p>
+          <a:p>
+            <a:pPr>
+              <a:spcAft>
+                <a:spcPts val="600"/>
+              </a:spcAft>
+            </a:pPr>
+            <a:r>
+              <a:rPr sz="1200" b="0">
+                <a:solidFill>
+                  <a:srgbClr val="16202A"/>
+                </a:solidFill>
+                <a:latin typeface="Microsoft YaHei"/>
+                <a:ea typeface="Microsoft YaHei"/>
+                <a:cs typeface="Microsoft YaHei"/>
+              </a:rPr>
+              <a:t>中间这列仍然靠人：定目标和冻结验收口径、新架构的接入判断、未知缺陷的根因定位，以及交付与否的最终决定。这几项短期内不打算交出去。</a:t>
+            </a:r>
+          </a:p>
+          <a:p>
+            <a:pPr>
+              <a:spcAft>
+                <a:spcPts val="600"/>
+              </a:spcAft>
+            </a:pPr>
+            <a:r>
+              <a:rPr sz="1200" b="0">
+                <a:solidFill>
+                  <a:srgbClr val="16202A"/>
+                </a:solidFill>
+                <a:latin typeface="Microsoft YaHei"/>
+                <a:ea typeface="Microsoft YaHei"/>
+                <a:cs typeface="Microsoft YaHei"/>
+              </a:rPr>
+              <a:t>右边这列还没做：换算链在 M100 上校准、模型层与算子层的自动交接、规则与补丁沉淀为可复用知识，以及适配成本本身的量化对账。顺序是定的——先校准再谈预测，没有校准的预测只能排序，不能报数。</a:t>
+            </a:r>
+          </a:p>
+          <a:p>
+            <a:pPr>
+              <a:spcAft>
+                <a:spcPts val="600"/>
+              </a:spcAft>
+            </a:pPr>
+            <a:r>
+              <a:rPr sz="1200" b="0">
+                <a:solidFill>
+                  <a:srgbClr val="16202A"/>
+                </a:solidFill>
+                <a:latin typeface="Microsoft YaHei"/>
+                <a:ea typeface="Microsoft YaHei"/>
+                <a:cs typeface="Microsoft YaHei"/>
+              </a:rPr>
+              <a:t>命题没有变：把重复判断交给 Agent，一个模型一个模型往下压。</a:t>
+            </a:r>
+          </a:p>
+          <a:p>
+            <a:pPr>
+              <a:spcAft>
+                <a:spcPts val="600"/>
+              </a:spcAft>
+            </a:pPr>
+            <a:r>
+              <a:rPr sz="1200" b="1">
+                <a:solidFill>
+                  <a:srgbClr val="66727F"/>
+                </a:solidFill>
+                <a:latin typeface="Microsoft YaHei"/>
+                <a:ea typeface="Microsoft YaHei"/>
+                <a:cs typeface="Microsoft YaHei"/>
+              </a:rPr>
+              <a:t>被问到再说 ——</a:t>
+            </a:r>
+          </a:p>
+          <a:p>
+            <a:pPr>
+              <a:spcAft>
+                <a:spcPts val="600"/>
+              </a:spcAft>
+            </a:pPr>
+            <a:r>
+              <a:rPr sz="1200" b="0">
+                <a:solidFill>
+                  <a:srgbClr val="66727F"/>
+                </a:solidFill>
+                <a:latin typeface="Microsoft YaHei"/>
+                <a:ea typeface="Microsoft YaHei"/>
+                <a:cs typeface="Microsoft YaHei"/>
+              </a:rPr>
+              <a:t>左列那四项已经在 M100 上跑通，但样本是单模型；规模化之后哪些规则需要调整，现在没有数据，不要说成已经验证。</a:t>
+            </a:r>
+          </a:p>
+          <a:p>
+            <a:pPr>
+              <a:spcAft>
+                <a:spcPts val="600"/>
+              </a:spcAft>
+            </a:pPr>
+            <a:r>
+              <a:rPr sz="1200" b="0">
+                <a:solidFill>
+                  <a:srgbClr val="66727F"/>
+                </a:solidFill>
+                <a:latin typeface="Microsoft YaHei"/>
+                <a:ea typeface="Microsoft YaHei"/>
+                <a:cs typeface="Microsoft YaHei"/>
+              </a:rPr>
+              <a:t>适配成本的量化对账还没做。第 1 页那三个待填的数就是对账口径——人周、算子缺口数、复验轮次。被问到省了多少成本时，如实说这个数还没有。</a:t>
             </a:r>
           </a:p>
         </p:txBody>
@@ -6948,7 +7212,7 @@
                 <a:ea typeface="Microsoft YaHei"/>
                 <a:cs typeface="Microsoft YaHei"/>
               </a:rPr>
-              <a:t>1 / 8</a:t>
+              <a:t>1 / 9</a:t>
             </a:r>
           </a:p>
         </p:txBody>
@@ -8499,7 +8763,7 @@
                 <a:ea typeface="Microsoft YaHei"/>
                 <a:cs typeface="Microsoft YaHei"/>
               </a:rPr>
-              <a:t>2 / 8</a:t>
+              <a:t>2 / 9</a:t>
             </a:r>
           </a:p>
         </p:txBody>
@@ -10623,7 +10887,7 @@
                 <a:ea typeface="Microsoft YaHei"/>
                 <a:cs typeface="Microsoft YaHei"/>
               </a:rPr>
-              <a:t>3 / 8</a:t>
+              <a:t>3 / 9</a:t>
             </a:r>
           </a:p>
         </p:txBody>
@@ -10688,7 +10952,7 @@
                 <a:ea typeface="Microsoft YaHei"/>
                 <a:cs typeface="Microsoft YaHei"/>
               </a:rPr>
-              <a:t>模型层 · 人与 AGENT 的分工</a:t>
+              <a:t>模型层 · 一次任务怎么跑完</a:t>
             </a:r>
           </a:p>
         </p:txBody>
@@ -10782,21 +11046,167 @@
                 <a:ea typeface="Microsoft YaHei"/>
                 <a:cs typeface="Microsoft YaHei"/>
               </a:rPr>
-              <a:t>已有流程可自动执行；新架构、未知缺陷与关键决策仍需要人工参与</a:t>
-            </a:r>
-          </a:p>
-        </p:txBody>
-      </p:sp>
-      <p:sp>
-        <p:nvSpPr>
-          <p:cNvPr id="5" name="Rectangle 4"/>
+              <a:t>人只在两头定目标与判交付；中间四个阶段无人值守，每个阶段都有明确产出</a:t>
+            </a:r>
+          </a:p>
+        </p:txBody>
+      </p:sp>
+      <p:sp>
+        <p:nvSpPr>
+          <p:cNvPr id="5" name="TextBox 4"/>
+          <p:cNvSpPr txBox="1"/>
+          <p:nvPr/>
+        </p:nvSpPr>
+        <p:spPr>
+          <a:xfrm>
+            <a:off x="548640" y="1664208"/>
+            <a:ext cx="11094415" cy="274320"/>
+          </a:xfrm>
+          <a:prstGeom prst="rect">
+            <a:avLst/>
+          </a:prstGeom>
+          <a:noFill/>
+        </p:spPr>
+        <p:txBody>
+          <a:bodyPr wrap="square" anchor="ctr" lIns="0" tIns="0" rIns="0" bIns="0">
+            <a:noAutofit/>
+          </a:bodyPr>
+          <a:lstStyle/>
+          <a:p>
+            <a:pPr algn="l" latinLnBrk="0">
+              <a:lnSpc>
+                <a:spcPct val="100000"/>
+              </a:lnSpc>
+              <a:spcBef>
+                <a:spcPts val="0"/>
+              </a:spcBef>
+              <a:spcAft>
+                <a:spcPts val="0"/>
+              </a:spcAft>
+            </a:pPr>
+            <a:r>
+              <a:rPr sz="1000" b="0">
+                <a:solidFill>
+                  <a:srgbClr val="66727F"/>
+                </a:solidFill>
+                <a:latin typeface="Microsoft YaHei"/>
+                <a:ea typeface="Microsoft YaHei"/>
+                <a:cs typeface="Microsoft YaHei"/>
+              </a:rPr>
+              <a:t>三条命令线共用同一套契约　</a:t>
+            </a:r>
+            <a:r>
+              <a:rPr sz="1050" b="1">
+                <a:solidFill>
+                  <a:srgbClr val="16202A"/>
+                </a:solidFill>
+                <a:latin typeface="Microsoft YaHei"/>
+                <a:ea typeface="Microsoft YaHei"/>
+                <a:cs typeface="Microsoft YaHei"/>
+              </a:rPr>
+              <a:t>架构接入</a:t>
+            </a:r>
+            <a:r>
+              <a:rPr sz="950" b="0">
+                <a:solidFill>
+                  <a:srgbClr val="66727F"/>
+                </a:solidFill>
+                <a:latin typeface="Consolas"/>
+                <a:ea typeface="Microsoft YaHei"/>
+                <a:cs typeface="Microsoft YaHei"/>
+              </a:rPr>
+              <a:t> onboard-*</a:t>
+            </a:r>
+            <a:r>
+              <a:rPr sz="1000" b="0">
+                <a:solidFill>
+                  <a:srgbClr val="8C96A1"/>
+                </a:solidFill>
+                <a:latin typeface="Microsoft YaHei"/>
+                <a:ea typeface="Microsoft YaHei"/>
+                <a:cs typeface="Microsoft YaHei"/>
+              </a:rPr>
+              <a:t>　→　</a:t>
+            </a:r>
+            <a:r>
+              <a:rPr sz="1050" b="1">
+                <a:solidFill>
+                  <a:srgbClr val="C0612C"/>
+                </a:solidFill>
+                <a:latin typeface="Microsoft YaHei"/>
+                <a:ea typeface="Microsoft YaHei"/>
+                <a:cs typeface="Microsoft YaHei"/>
+              </a:rPr>
+              <a:t>性能调优</a:t>
+            </a:r>
+            <a:r>
+              <a:rPr sz="950" b="0">
+                <a:solidFill>
+                  <a:srgbClr val="C0612C"/>
+                </a:solidFill>
+                <a:latin typeface="Consolas"/>
+                <a:ea typeface="Microsoft YaHei"/>
+                <a:cs typeface="Microsoft YaHei"/>
+              </a:rPr>
+              <a:t> run / resume</a:t>
+            </a:r>
+            <a:r>
+              <a:rPr sz="1000" b="0">
+                <a:solidFill>
+                  <a:srgbClr val="8C96A1"/>
+                </a:solidFill>
+                <a:latin typeface="Microsoft YaHei"/>
+                <a:ea typeface="Microsoft YaHei"/>
+                <a:cs typeface="Microsoft YaHei"/>
+              </a:rPr>
+              <a:t>　→　</a:t>
+            </a:r>
+            <a:r>
+              <a:rPr sz="1050" b="1">
+                <a:solidFill>
+                  <a:srgbClr val="16202A"/>
+                </a:solidFill>
+                <a:latin typeface="Microsoft YaHei"/>
+                <a:ea typeface="Microsoft YaHei"/>
+                <a:cs typeface="Microsoft YaHei"/>
+              </a:rPr>
+              <a:t>持续优化</a:t>
+            </a:r>
+            <a:r>
+              <a:rPr sz="950" b="0">
+                <a:solidFill>
+                  <a:srgbClr val="66727F"/>
+                </a:solidFill>
+                <a:latin typeface="Consolas"/>
+                <a:ea typeface="Microsoft YaHei"/>
+                <a:cs typeface="Microsoft YaHei"/>
+              </a:rPr>
+              <a:t> optimize-*</a:t>
+            </a:r>
+            <a:r>
+              <a:rPr sz="1000" b="0">
+                <a:solidFill>
+                  <a:srgbClr val="66727F"/>
+                </a:solidFill>
+                <a:latin typeface="Microsoft YaHei"/>
+                <a:ea typeface="Microsoft YaHei"/>
+                <a:cs typeface="Microsoft YaHei"/>
+              </a:rPr>
+              <a:t>　　本页讲中间这条</a:t>
+            </a:r>
+          </a:p>
+        </p:txBody>
+      </p:sp>
+      <p:sp>
+        <p:nvSpPr>
+          <p:cNvPr id="6" name="Rectangle 5"/>
           <p:cNvSpPr/>
           <p:nvPr/>
         </p:nvSpPr>
         <p:spPr>
           <a:xfrm>
-            <a:off x="548640" y="1682496"/>
-            <a:ext cx="3515258" cy="457200"/>
+            <a:off x="548640" y="2011680"/>
+            <a:ext cx="2286000" cy="3255264"/>
           </a:xfrm>
           <a:prstGeom prst="rect">
             <a:avLst/>
@@ -10818,318 +11228,13 @@
       </p:sp>
       <p:sp>
         <p:nvSpPr>
-          <p:cNvPr id="6" name="TextBox 5"/>
-          <p:cNvSpPr txBox="1"/>
-          <p:nvPr/>
-        </p:nvSpPr>
-        <p:spPr>
-          <a:xfrm>
-            <a:off x="749808" y="1682496"/>
-            <a:ext cx="3112922" cy="457200"/>
-          </a:xfrm>
-          <a:prstGeom prst="rect">
-            <a:avLst/>
-          </a:prstGeom>
-          <a:noFill/>
-        </p:spPr>
-        <p:txBody>
-          <a:bodyPr wrap="square" anchor="ctr" lIns="0" tIns="0" rIns="0" bIns="0">
-            <a:noAutofit/>
-          </a:bodyPr>
-          <a:lstStyle/>
-          <a:p>
-            <a:pPr algn="l" latinLnBrk="0">
-              <a:lnSpc>
-                <a:spcPct val="100000"/>
-              </a:lnSpc>
-              <a:spcBef>
-                <a:spcPts val="0"/>
-              </a:spcBef>
-              <a:spcAft>
-                <a:spcPts val="0"/>
-              </a:spcAft>
-            </a:pPr>
-            <a:r>
-              <a:rPr sz="1150" b="1">
-                <a:solidFill>
-                  <a:srgbClr val="16202A"/>
-                </a:solidFill>
-                <a:latin typeface="Microsoft YaHei"/>
-                <a:ea typeface="Microsoft YaHei"/>
-                <a:cs typeface="Microsoft YaHei"/>
-              </a:rPr>
-              <a:t>架构接入</a:t>
-            </a:r>
-            <a:r>
-              <a:rPr sz="1000" b="0">
-                <a:solidFill>
-                  <a:srgbClr val="35424F"/>
-                </a:solidFill>
-                <a:latin typeface="Microsoft YaHei"/>
-                <a:ea typeface="Microsoft YaHei"/>
-                <a:cs typeface="Microsoft YaHei"/>
-              </a:rPr>
-              <a:t>　新架构逐层验收</a:t>
-            </a:r>
-          </a:p>
-        </p:txBody>
-      </p:sp>
-      <p:sp>
-        <p:nvSpPr>
           <p:cNvPr id="7" name="Rectangle 6"/>
           <p:cNvSpPr/>
           <p:nvPr/>
         </p:nvSpPr>
         <p:spPr>
           <a:xfrm>
-            <a:off x="4338218" y="1682496"/>
-            <a:ext cx="3515258" cy="457200"/>
-          </a:xfrm>
-          <a:prstGeom prst="rect">
-            <a:avLst/>
-          </a:prstGeom>
-          <a:solidFill>
-            <a:srgbClr val="F8EADF"/>
-          </a:solidFill>
-          <a:ln>
-            <a:noFill/>
-          </a:ln>
-        </p:spPr>
-        <p:txBody>
-          <a:bodyPr rtlCol="0" anchor="ctr"/>
-          <a:lstStyle/>
-          <a:p>
-            <a:pPr algn="ctr"/>
-          </a:p>
-        </p:txBody>
-      </p:sp>
-      <p:sp>
-        <p:nvSpPr>
-          <p:cNvPr id="8" name="TextBox 7"/>
-          <p:cNvSpPr txBox="1"/>
-          <p:nvPr/>
-        </p:nvSpPr>
-        <p:spPr>
-          <a:xfrm>
-            <a:off x="4539386" y="1682496"/>
-            <a:ext cx="3112922" cy="457200"/>
-          </a:xfrm>
-          <a:prstGeom prst="rect">
-            <a:avLst/>
-          </a:prstGeom>
-          <a:noFill/>
-        </p:spPr>
-        <p:txBody>
-          <a:bodyPr wrap="square" anchor="ctr" lIns="0" tIns="0" rIns="0" bIns="0">
-            <a:noAutofit/>
-          </a:bodyPr>
-          <a:lstStyle/>
-          <a:p>
-            <a:pPr algn="l" latinLnBrk="0">
-              <a:lnSpc>
-                <a:spcPct val="100000"/>
-              </a:lnSpc>
-              <a:spcBef>
-                <a:spcPts val="0"/>
-              </a:spcBef>
-              <a:spcAft>
-                <a:spcPts val="0"/>
-              </a:spcAft>
-            </a:pPr>
-            <a:r>
-              <a:rPr sz="1150" b="1">
-                <a:solidFill>
-                  <a:srgbClr val="16202A"/>
-                </a:solidFill>
-                <a:latin typeface="Microsoft YaHei"/>
-                <a:ea typeface="Microsoft YaHei"/>
-                <a:cs typeface="Microsoft YaHei"/>
-              </a:rPr>
-              <a:t>性能调优</a:t>
-            </a:r>
-            <a:r>
-              <a:rPr sz="1000" b="0">
-                <a:solidFill>
-                  <a:srgbClr val="35424F"/>
-                </a:solidFill>
-                <a:latin typeface="Microsoft YaHei"/>
-                <a:ea typeface="Microsoft YaHei"/>
-                <a:cs typeface="Microsoft YaHei"/>
-              </a:rPr>
-              <a:t>　实测环境下迭代优化</a:t>
-            </a:r>
-          </a:p>
-        </p:txBody>
-      </p:sp>
-      <p:cxnSp>
-        <p:nvCxnSpPr>
-          <p:cNvPr id="9" name="Connector 8"/>
-          <p:cNvCxnSpPr/>
-          <p:nvPr/>
-        </p:nvCxnSpPr>
-        <p:spPr>
-          <a:xfrm>
-            <a:off x="4100474" y="1911095"/>
-            <a:ext cx="192024" cy="0"/>
-          </a:xfrm>
-          <a:prstGeom prst="line">
-            <a:avLst/>
-          </a:prstGeom>
-          <a:ln w="15875">
-            <a:solidFill>
-              <a:srgbClr val="C0612C"/>
-            </a:solidFill>
-            <a:tailEnd type="triangle" w="med" len="med"/>
-          </a:ln>
-        </p:spPr>
-      </p:cxnSp>
-      <p:sp>
-        <p:nvSpPr>
-          <p:cNvPr id="10" name="Rectangle 9"/>
-          <p:cNvSpPr/>
-          <p:nvPr/>
-        </p:nvSpPr>
-        <p:spPr>
-          <a:xfrm>
-            <a:off x="8127796" y="1682496"/>
-            <a:ext cx="3515258" cy="457200"/>
-          </a:xfrm>
-          <a:prstGeom prst="rect">
-            <a:avLst/>
-          </a:prstGeom>
-          <a:solidFill>
-            <a:srgbClr val="F6F7F9"/>
-          </a:solidFill>
-          <a:ln>
-            <a:noFill/>
-          </a:ln>
-        </p:spPr>
-        <p:txBody>
-          <a:bodyPr rtlCol="0" anchor="ctr"/>
-          <a:lstStyle/>
-          <a:p>
-            <a:pPr algn="ctr"/>
-          </a:p>
-        </p:txBody>
-      </p:sp>
-      <p:sp>
-        <p:nvSpPr>
-          <p:cNvPr id="11" name="TextBox 10"/>
-          <p:cNvSpPr txBox="1"/>
-          <p:nvPr/>
-        </p:nvSpPr>
-        <p:spPr>
-          <a:xfrm>
-            <a:off x="8328964" y="1682496"/>
-            <a:ext cx="3112922" cy="457200"/>
-          </a:xfrm>
-          <a:prstGeom prst="rect">
-            <a:avLst/>
-          </a:prstGeom>
-          <a:noFill/>
-        </p:spPr>
-        <p:txBody>
-          <a:bodyPr wrap="square" anchor="ctr" lIns="0" tIns="0" rIns="0" bIns="0">
-            <a:noAutofit/>
-          </a:bodyPr>
-          <a:lstStyle/>
-          <a:p>
-            <a:pPr algn="l" latinLnBrk="0">
-              <a:lnSpc>
-                <a:spcPct val="100000"/>
-              </a:lnSpc>
-              <a:spcBef>
-                <a:spcPts val="0"/>
-              </a:spcBef>
-              <a:spcAft>
-                <a:spcPts val="0"/>
-              </a:spcAft>
-            </a:pPr>
-            <a:r>
-              <a:rPr sz="1150" b="1">
-                <a:solidFill>
-                  <a:srgbClr val="16202A"/>
-                </a:solidFill>
-                <a:latin typeface="Microsoft YaHei"/>
-                <a:ea typeface="Microsoft YaHei"/>
-                <a:cs typeface="Microsoft YaHei"/>
-              </a:rPr>
-              <a:t>持续优化</a:t>
-            </a:r>
-            <a:r>
-              <a:rPr sz="1000" b="0">
-                <a:solidFill>
-                  <a:srgbClr val="35424F"/>
-                </a:solidFill>
-                <a:latin typeface="Microsoft YaHei"/>
-                <a:ea typeface="Microsoft YaHei"/>
-                <a:cs typeface="Microsoft YaHei"/>
-              </a:rPr>
-              <a:t>　按 Trace 持续迭代</a:t>
-            </a:r>
-          </a:p>
-        </p:txBody>
-      </p:sp>
-      <p:cxnSp>
-        <p:nvCxnSpPr>
-          <p:cNvPr id="12" name="Connector 11"/>
-          <p:cNvCxnSpPr/>
-          <p:nvPr/>
-        </p:nvCxnSpPr>
-        <p:spPr>
-          <a:xfrm>
-            <a:off x="7890052" y="1911095"/>
-            <a:ext cx="192024" cy="0"/>
-          </a:xfrm>
-          <a:prstGeom prst="line">
-            <a:avLst/>
-          </a:prstGeom>
-          <a:ln w="15875">
-            <a:solidFill>
-              <a:srgbClr val="C0612C"/>
-            </a:solidFill>
-            <a:tailEnd type="triangle" w="med" len="med"/>
-          </a:ln>
-        </p:spPr>
-      </p:cxnSp>
-      <p:sp>
-        <p:nvSpPr>
-          <p:cNvPr id="13" name="Rectangle 12"/>
-          <p:cNvSpPr/>
-          <p:nvPr/>
-        </p:nvSpPr>
-        <p:spPr>
-          <a:xfrm>
-            <a:off x="548640" y="2304288"/>
-            <a:ext cx="2286000" cy="2926080"/>
-          </a:xfrm>
-          <a:prstGeom prst="rect">
-            <a:avLst/>
-          </a:prstGeom>
-          <a:solidFill>
-            <a:srgbClr val="F6F7F9"/>
-          </a:solidFill>
-          <a:ln>
-            <a:noFill/>
-          </a:ln>
-        </p:spPr>
-        <p:txBody>
-          <a:bodyPr rtlCol="0" anchor="ctr"/>
-          <a:lstStyle/>
-          <a:p>
-            <a:pPr algn="ctr"/>
-          </a:p>
-        </p:txBody>
-      </p:sp>
-      <p:sp>
-        <p:nvSpPr>
-          <p:cNvPr id="14" name="Rectangle 13"/>
-          <p:cNvSpPr/>
-          <p:nvPr/>
-        </p:nvSpPr>
-        <p:spPr>
-          <a:xfrm>
-            <a:off x="548640" y="2304288"/>
+            <a:off x="548640" y="2011680"/>
             <a:ext cx="2286000" cy="45720"/>
           </a:xfrm>
           <a:prstGeom prst="rect">
@@ -11152,13 +11257,13 @@
       </p:sp>
       <p:sp>
         <p:nvSpPr>
-          <p:cNvPr id="15" name="TextBox 14"/>
+          <p:cNvPr id="8" name="TextBox 7"/>
           <p:cNvSpPr txBox="1"/>
           <p:nvPr/>
         </p:nvSpPr>
         <p:spPr>
           <a:xfrm>
-            <a:off x="749808" y="2432304"/>
+            <a:off x="749808" y="2139696"/>
             <a:ext cx="1883664" cy="310896"/>
           </a:xfrm>
           <a:prstGeom prst="rect">
@@ -11210,13 +11315,13 @@
       </p:sp>
       <p:sp>
         <p:nvSpPr>
-          <p:cNvPr id="16" name="Oval 15"/>
+          <p:cNvPr id="9" name="Oval 8"/>
           <p:cNvSpPr/>
           <p:nvPr/>
         </p:nvSpPr>
         <p:spPr>
           <a:xfrm>
-            <a:off x="749808" y="2999232"/>
+            <a:off x="749808" y="2706624"/>
             <a:ext cx="91440" cy="91440"/>
           </a:xfrm>
           <a:prstGeom prst="ellipse">
@@ -11239,13 +11344,13 @@
       </p:sp>
       <p:sp>
         <p:nvSpPr>
-          <p:cNvPr id="17" name="TextBox 16"/>
+          <p:cNvPr id="10" name="TextBox 9"/>
           <p:cNvSpPr txBox="1"/>
           <p:nvPr/>
         </p:nvSpPr>
         <p:spPr>
           <a:xfrm>
-            <a:off x="950976" y="2852928"/>
+            <a:off x="950976" y="2560320"/>
             <a:ext cx="1682496" cy="420624"/>
           </a:xfrm>
           <a:prstGeom prst="rect">
@@ -11286,13 +11391,13 @@
       </p:sp>
       <p:sp>
         <p:nvSpPr>
-          <p:cNvPr id="18" name="Oval 17"/>
+          <p:cNvPr id="11" name="Oval 10"/>
           <p:cNvSpPr/>
           <p:nvPr/>
         </p:nvSpPr>
         <p:spPr>
           <a:xfrm>
-            <a:off x="749808" y="3419856"/>
+            <a:off x="749808" y="3127248"/>
             <a:ext cx="91440" cy="91440"/>
           </a:xfrm>
           <a:prstGeom prst="ellipse">
@@ -11315,13 +11420,13 @@
       </p:sp>
       <p:sp>
         <p:nvSpPr>
-          <p:cNvPr id="19" name="TextBox 18"/>
+          <p:cNvPr id="12" name="TextBox 11"/>
           <p:cNvSpPr txBox="1"/>
           <p:nvPr/>
         </p:nvSpPr>
         <p:spPr>
           <a:xfrm>
-            <a:off x="950976" y="3273552"/>
+            <a:off x="950976" y="2980944"/>
             <a:ext cx="1682496" cy="420624"/>
           </a:xfrm>
           <a:prstGeom prst="rect">
@@ -11362,13 +11467,13 @@
       </p:sp>
       <p:sp>
         <p:nvSpPr>
-          <p:cNvPr id="20" name="Oval 19"/>
+          <p:cNvPr id="13" name="Oval 12"/>
           <p:cNvSpPr/>
           <p:nvPr/>
         </p:nvSpPr>
         <p:spPr>
           <a:xfrm>
-            <a:off x="749808" y="3840480"/>
+            <a:off x="749808" y="3547872"/>
             <a:ext cx="91440" cy="91440"/>
           </a:xfrm>
           <a:prstGeom prst="ellipse">
@@ -11391,13 +11496,13 @@
       </p:sp>
       <p:sp>
         <p:nvSpPr>
-          <p:cNvPr id="21" name="TextBox 20"/>
+          <p:cNvPr id="14" name="TextBox 13"/>
           <p:cNvSpPr txBox="1"/>
           <p:nvPr/>
         </p:nvSpPr>
         <p:spPr>
           <a:xfrm>
-            <a:off x="950976" y="3694176"/>
+            <a:off x="950976" y="3401568"/>
             <a:ext cx="1682496" cy="420624"/>
           </a:xfrm>
           <a:prstGeom prst="rect">
@@ -11438,13 +11543,13 @@
       </p:sp>
       <p:sp>
         <p:nvSpPr>
-          <p:cNvPr id="22" name="Oval 21"/>
+          <p:cNvPr id="15" name="Oval 14"/>
           <p:cNvSpPr/>
           <p:nvPr/>
         </p:nvSpPr>
         <p:spPr>
           <a:xfrm>
-            <a:off x="749808" y="4261104"/>
+            <a:off x="749808" y="3968496"/>
             <a:ext cx="91440" cy="91440"/>
           </a:xfrm>
           <a:prstGeom prst="ellipse">
@@ -11467,13 +11572,13 @@
       </p:sp>
       <p:sp>
         <p:nvSpPr>
-          <p:cNvPr id="23" name="TextBox 22"/>
+          <p:cNvPr id="16" name="TextBox 15"/>
           <p:cNvSpPr txBox="1"/>
           <p:nvPr/>
         </p:nvSpPr>
         <p:spPr>
           <a:xfrm>
-            <a:off x="950976" y="4114800"/>
+            <a:off x="950976" y="3822192"/>
             <a:ext cx="1682496" cy="420624"/>
           </a:xfrm>
           <a:prstGeom prst="rect">
@@ -11514,13 +11619,13 @@
       </p:sp>
       <p:sp>
         <p:nvSpPr>
-          <p:cNvPr id="24" name="TextBox 23"/>
+          <p:cNvPr id="17" name="TextBox 16"/>
           <p:cNvSpPr txBox="1"/>
           <p:nvPr/>
         </p:nvSpPr>
         <p:spPr>
           <a:xfrm>
-            <a:off x="749808" y="4754880"/>
+            <a:off x="749808" y="4791456"/>
             <a:ext cx="1883664" cy="274320"/>
           </a:xfrm>
           <a:prstGeom prst="rect">
@@ -11561,13 +11666,13 @@
       </p:sp>
       <p:sp>
         <p:nvSpPr>
-          <p:cNvPr id="25" name="TextBox 24"/>
+          <p:cNvPr id="18" name="TextBox 17"/>
           <p:cNvSpPr txBox="1"/>
           <p:nvPr/>
         </p:nvSpPr>
         <p:spPr>
           <a:xfrm>
-            <a:off x="548640" y="5010912"/>
+            <a:off x="548640" y="5047488"/>
             <a:ext cx="2286000" cy="201168"/>
           </a:xfrm>
           <a:prstGeom prst="rect">
@@ -11608,14 +11713,14 @@
       </p:sp>
       <p:sp>
         <p:nvSpPr>
-          <p:cNvPr id="26" name="Rectangle 25"/>
+          <p:cNvPr id="19" name="Rectangle 18"/>
           <p:cNvSpPr/>
           <p:nvPr/>
         </p:nvSpPr>
         <p:spPr>
           <a:xfrm>
-            <a:off x="3017520" y="2304288"/>
-            <a:ext cx="5760720" cy="2926080"/>
+            <a:off x="3017520" y="2011680"/>
+            <a:ext cx="5760720" cy="3255264"/>
           </a:xfrm>
           <a:prstGeom prst="rect">
             <a:avLst/>
@@ -11639,13 +11744,13 @@
       </p:sp>
       <p:sp>
         <p:nvSpPr>
-          <p:cNvPr id="27" name="TextBox 26"/>
+          <p:cNvPr id="20" name="TextBox 19"/>
           <p:cNvSpPr txBox="1"/>
           <p:nvPr/>
         </p:nvSpPr>
         <p:spPr>
           <a:xfrm>
-            <a:off x="3218688" y="2432304"/>
+            <a:off x="3218688" y="2139696"/>
             <a:ext cx="5358383" cy="310896"/>
           </a:xfrm>
           <a:prstGeom prst="rect">
@@ -11708,14 +11813,14 @@
       </p:sp>
       <p:sp>
         <p:nvSpPr>
-          <p:cNvPr id="28" name="Rectangle 27"/>
+          <p:cNvPr id="21" name="Rectangle 20"/>
           <p:cNvSpPr/>
           <p:nvPr/>
         </p:nvSpPr>
         <p:spPr>
           <a:xfrm>
-            <a:off x="3218688" y="2816352"/>
-            <a:ext cx="5358383" cy="493776"/>
+            <a:off x="3218688" y="2523744"/>
+            <a:ext cx="5358383" cy="621792"/>
           </a:xfrm>
           <a:prstGeom prst="rect">
             <a:avLst/>
@@ -11737,13 +11842,13 @@
       </p:sp>
       <p:sp>
         <p:nvSpPr>
-          <p:cNvPr id="29" name="Oval 28"/>
+          <p:cNvPr id="22" name="Oval 21"/>
           <p:cNvSpPr/>
           <p:nvPr/>
         </p:nvSpPr>
         <p:spPr>
           <a:xfrm>
-            <a:off x="3328416" y="2926080"/>
+            <a:off x="3328416" y="2697480"/>
             <a:ext cx="274320" cy="274320"/>
           </a:xfrm>
           <a:prstGeom prst="ellipse">
@@ -11789,14 +11894,14 @@
       </p:sp>
       <p:sp>
         <p:nvSpPr>
-          <p:cNvPr id="30" name="TextBox 29"/>
+          <p:cNvPr id="23" name="TextBox 22"/>
           <p:cNvSpPr txBox="1"/>
           <p:nvPr/>
         </p:nvSpPr>
         <p:spPr>
           <a:xfrm>
-            <a:off x="3694176" y="2816352"/>
-            <a:ext cx="1371600" cy="493776"/>
+            <a:off x="3694176" y="2523744"/>
+            <a:ext cx="1371600" cy="621792"/>
           </a:xfrm>
           <a:prstGeom prst="rect">
             <a:avLst/>
@@ -11836,14 +11941,14 @@
       </p:sp>
       <p:sp>
         <p:nvSpPr>
-          <p:cNvPr id="31" name="TextBox 30"/>
+          <p:cNvPr id="24" name="TextBox 23"/>
           <p:cNvSpPr txBox="1"/>
           <p:nvPr/>
         </p:nvSpPr>
         <p:spPr>
           <a:xfrm>
-            <a:off x="4892040" y="2816352"/>
-            <a:ext cx="3154680" cy="493776"/>
+            <a:off x="4892040" y="2578608"/>
+            <a:ext cx="3154680" cy="274320"/>
           </a:xfrm>
           <a:prstGeom prst="rect">
             <a:avLst/>
@@ -11876,21 +11981,68 @@
                 <a:ea typeface="Microsoft YaHei"/>
                 <a:cs typeface="Microsoft YaHei"/>
               </a:rPr>
-              <a:t>先完成预检，再验收基线</a:t>
-            </a:r>
-          </a:p>
-        </p:txBody>
-      </p:sp>
-      <p:sp>
-        <p:nvSpPr>
-          <p:cNvPr id="32" name="Rectangle 31"/>
+              <a:t>先完成预检，再跑全量评测</a:t>
+            </a:r>
+          </a:p>
+        </p:txBody>
+      </p:sp>
+      <p:sp>
+        <p:nvSpPr>
+          <p:cNvPr id="25" name="TextBox 24"/>
+          <p:cNvSpPr txBox="1"/>
+          <p:nvPr/>
+        </p:nvSpPr>
+        <p:spPr>
+          <a:xfrm>
+            <a:off x="4892040" y="2852928"/>
+            <a:ext cx="3154680" cy="256032"/>
+          </a:xfrm>
+          <a:prstGeom prst="rect">
+            <a:avLst/>
+          </a:prstGeom>
+          <a:noFill/>
+        </p:spPr>
+        <p:txBody>
+          <a:bodyPr wrap="square" anchor="ctr" lIns="0" tIns="0" rIns="0" bIns="0">
+            <a:noAutofit/>
+          </a:bodyPr>
+          <a:lstStyle/>
+          <a:p>
+            <a:pPr algn="l" latinLnBrk="0">
+              <a:lnSpc>
+                <a:spcPct val="100000"/>
+              </a:lnSpc>
+              <a:spcBef>
+                <a:spcPts val="0"/>
+              </a:spcBef>
+              <a:spcAft>
+                <a:spcPts val="0"/>
+              </a:spcAft>
+            </a:pPr>
+            <a:r>
+              <a:rPr sz="950" b="0">
+                <a:solidFill>
+                  <a:srgbClr val="66727F"/>
+                </a:solidFill>
+                <a:latin typeface="Microsoft YaHei"/>
+                <a:ea typeface="Microsoft YaHei"/>
+                <a:cs typeface="Microsoft YaHei"/>
+              </a:rPr>
+              <a:t>产出：基线指标与可复现的启动方式</a:t>
+            </a:r>
+          </a:p>
+        </p:txBody>
+      </p:sp>
+      <p:sp>
+        <p:nvSpPr>
+          <p:cNvPr id="26" name="Rectangle 25"/>
           <p:cNvSpPr/>
           <p:nvPr/>
         </p:nvSpPr>
         <p:spPr>
           <a:xfrm>
-            <a:off x="3218688" y="3346704"/>
-            <a:ext cx="5358383" cy="493776"/>
+            <a:off x="3218688" y="3182112"/>
+            <a:ext cx="5358383" cy="621792"/>
           </a:xfrm>
           <a:prstGeom prst="rect">
             <a:avLst/>
@@ -11912,13 +12064,13 @@
       </p:sp>
       <p:sp>
         <p:nvSpPr>
-          <p:cNvPr id="33" name="Oval 32"/>
+          <p:cNvPr id="27" name="Oval 26"/>
           <p:cNvSpPr/>
           <p:nvPr/>
         </p:nvSpPr>
         <p:spPr>
           <a:xfrm>
-            <a:off x="3328416" y="3456432"/>
+            <a:off x="3328416" y="3355848"/>
             <a:ext cx="274320" cy="274320"/>
           </a:xfrm>
           <a:prstGeom prst="ellipse">
@@ -11964,14 +12116,14 @@
       </p:sp>
       <p:sp>
         <p:nvSpPr>
-          <p:cNvPr id="34" name="TextBox 33"/>
+          <p:cNvPr id="28" name="TextBox 27"/>
           <p:cNvSpPr txBox="1"/>
           <p:nvPr/>
         </p:nvSpPr>
         <p:spPr>
           <a:xfrm>
-            <a:off x="3694176" y="3346704"/>
-            <a:ext cx="1371600" cy="493776"/>
+            <a:off x="3694176" y="3182112"/>
+            <a:ext cx="1371600" cy="621792"/>
           </a:xfrm>
           <a:prstGeom prst="rect">
             <a:avLst/>
@@ -12011,14 +12163,14 @@
       </p:sp>
       <p:sp>
         <p:nvSpPr>
-          <p:cNvPr id="35" name="TextBox 34"/>
+          <p:cNvPr id="29" name="TextBox 28"/>
           <p:cNvSpPr txBox="1"/>
           <p:nvPr/>
         </p:nvSpPr>
         <p:spPr>
           <a:xfrm>
-            <a:off x="4892040" y="3346704"/>
-            <a:ext cx="3154680" cy="493776"/>
+            <a:off x="4892040" y="3236976"/>
+            <a:ext cx="3154680" cy="274320"/>
           </a:xfrm>
           <a:prstGeom prst="rect">
             <a:avLst/>
@@ -12051,21 +12203,68 @@
                 <a:ea typeface="Microsoft YaHei"/>
                 <a:cs typeface="Microsoft YaHei"/>
               </a:rPr>
-              <a:t>独立采样，只用于诊断</a:t>
-            </a:r>
-          </a:p>
-        </p:txBody>
-      </p:sp>
-      <p:sp>
-        <p:nvSpPr>
-          <p:cNvPr id="36" name="Rectangle 35"/>
+              <a:t>独立进程采样，不参与计时</a:t>
+            </a:r>
+          </a:p>
+        </p:txBody>
+      </p:sp>
+      <p:sp>
+        <p:nvSpPr>
+          <p:cNvPr id="30" name="TextBox 29"/>
+          <p:cNvSpPr txBox="1"/>
+          <p:nvPr/>
+        </p:nvSpPr>
+        <p:spPr>
+          <a:xfrm>
+            <a:off x="4892040" y="3511296"/>
+            <a:ext cx="3154680" cy="256032"/>
+          </a:xfrm>
+          <a:prstGeom prst="rect">
+            <a:avLst/>
+          </a:prstGeom>
+          <a:noFill/>
+        </p:spPr>
+        <p:txBody>
+          <a:bodyPr wrap="square" anchor="ctr" lIns="0" tIns="0" rIns="0" bIns="0">
+            <a:noAutofit/>
+          </a:bodyPr>
+          <a:lstStyle/>
+          <a:p>
+            <a:pPr algn="l" latinLnBrk="0">
+              <a:lnSpc>
+                <a:spcPct val="100000"/>
+              </a:lnSpc>
+              <a:spcBef>
+                <a:spcPts val="0"/>
+              </a:spcBef>
+              <a:spcAft>
+                <a:spcPts val="0"/>
+              </a:spcAft>
+            </a:pPr>
+            <a:r>
+              <a:rPr sz="950" b="0">
+                <a:solidFill>
+                  <a:srgbClr val="66727F"/>
+                </a:solidFill>
+                <a:latin typeface="Microsoft YaHei"/>
+                <a:ea typeface="Microsoft YaHei"/>
+                <a:cs typeface="Microsoft YaHei"/>
+              </a:rPr>
+              <a:t>产出：热点清单，只用于选方向</a:t>
+            </a:r>
+          </a:p>
+        </p:txBody>
+      </p:sp>
+      <p:sp>
+        <p:nvSpPr>
+          <p:cNvPr id="31" name="Rectangle 30"/>
           <p:cNvSpPr/>
           <p:nvPr/>
         </p:nvSpPr>
         <p:spPr>
           <a:xfrm>
-            <a:off x="3218688" y="3877056"/>
-            <a:ext cx="5358383" cy="493776"/>
+            <a:off x="3218688" y="3840480"/>
+            <a:ext cx="5358383" cy="621792"/>
           </a:xfrm>
           <a:prstGeom prst="rect">
             <a:avLst/>
@@ -12087,13 +12286,13 @@
       </p:sp>
       <p:sp>
         <p:nvSpPr>
-          <p:cNvPr id="37" name="Oval 36"/>
+          <p:cNvPr id="32" name="Oval 31"/>
           <p:cNvSpPr/>
           <p:nvPr/>
         </p:nvSpPr>
         <p:spPr>
           <a:xfrm>
-            <a:off x="3328416" y="3986784"/>
+            <a:off x="3328416" y="4014216"/>
             <a:ext cx="274320" cy="274320"/>
           </a:xfrm>
           <a:prstGeom prst="ellipse">
@@ -12139,14 +12338,14 @@
       </p:sp>
       <p:sp>
         <p:nvSpPr>
-          <p:cNvPr id="38" name="TextBox 37"/>
+          <p:cNvPr id="33" name="TextBox 32"/>
           <p:cNvSpPr txBox="1"/>
           <p:nvPr/>
         </p:nvSpPr>
         <p:spPr>
           <a:xfrm>
-            <a:off x="3694176" y="3877056"/>
-            <a:ext cx="1371600" cy="493776"/>
+            <a:off x="3694176" y="3840480"/>
+            <a:ext cx="1371600" cy="621792"/>
           </a:xfrm>
           <a:prstGeom prst="rect">
             <a:avLst/>
@@ -12186,14 +12385,14 @@
       </p:sp>
       <p:sp>
         <p:nvSpPr>
-          <p:cNvPr id="39" name="TextBox 38"/>
+          <p:cNvPr id="34" name="TextBox 33"/>
           <p:cNvSpPr txBox="1"/>
           <p:nvPr/>
         </p:nvSpPr>
         <p:spPr>
           <a:xfrm>
-            <a:off x="4892040" y="3877056"/>
-            <a:ext cx="3154680" cy="493776"/>
+            <a:off x="4892040" y="3895344"/>
+            <a:ext cx="3154680" cy="274320"/>
           </a:xfrm>
           <a:prstGeom prst="rect">
             <a:avLst/>
@@ -12226,21 +12425,68 @@
                 <a:ea typeface="Microsoft YaHei"/>
                 <a:cs typeface="Microsoft YaHei"/>
               </a:rPr>
-              <a:t>小步改动，逐轮验证收益</a:t>
-            </a:r>
-          </a:p>
-        </p:txBody>
-      </p:sp>
-      <p:sp>
-        <p:nvSpPr>
-          <p:cNvPr id="40" name="Freeform 39"/>
+              <a:t>小步改动，逐个按三道条件验收</a:t>
+            </a:r>
+          </a:p>
+        </p:txBody>
+      </p:sp>
+      <p:sp>
+        <p:nvSpPr>
+          <p:cNvPr id="35" name="TextBox 34"/>
+          <p:cNvSpPr txBox="1"/>
+          <p:nvPr/>
+        </p:nvSpPr>
+        <p:spPr>
+          <a:xfrm>
+            <a:off x="4892040" y="4169664"/>
+            <a:ext cx="3154680" cy="256032"/>
+          </a:xfrm>
+          <a:prstGeom prst="rect">
+            <a:avLst/>
+          </a:prstGeom>
+          <a:noFill/>
+        </p:spPr>
+        <p:txBody>
+          <a:bodyPr wrap="square" anchor="ctr" lIns="0" tIns="0" rIns="0" bIns="0">
+            <a:noAutofit/>
+          </a:bodyPr>
+          <a:lstStyle/>
+          <a:p>
+            <a:pPr algn="l" latinLnBrk="0">
+              <a:lnSpc>
+                <a:spcPct val="100000"/>
+              </a:lnSpc>
+              <a:spcBef>
+                <a:spcPts val="0"/>
+              </a:spcBef>
+              <a:spcAft>
+                <a:spcPts val="0"/>
+              </a:spcAft>
+            </a:pPr>
+            <a:r>
+              <a:rPr sz="950" b="0">
+                <a:solidFill>
+                  <a:srgbClr val="C0612C"/>
+                </a:solidFill>
+                <a:latin typeface="Microsoft YaHei"/>
+                <a:ea typeface="Microsoft YaHei"/>
+                <a:cs typeface="Microsoft YaHei"/>
+              </a:rPr>
+              <a:t>产出：通过筛选的候选与各自收益　→ 下一页</a:t>
+            </a:r>
+          </a:p>
+        </p:txBody>
+      </p:sp>
+      <p:sp>
+        <p:nvSpPr>
+          <p:cNvPr id="36" name="Freeform 35"/>
           <p:cNvSpPr/>
           <p:nvPr/>
         </p:nvSpPr>
         <p:spPr>
           <a:xfrm>
             <a:off x="8138160" y="3968496"/>
-            <a:ext cx="237744" cy="310896"/>
+            <a:ext cx="237744" cy="365760"/>
           </a:xfrm>
           <a:custGeom>
             <a:avLst/>
@@ -12249,12 +12495,12 @@
             <a:cxnLst/>
             <a:rect l="l" t="t" r="r" b="b"/>
             <a:pathLst>
-              <a:path w="237744" h="310896">
+              <a:path w="237744" h="365760">
                 <a:moveTo>
-                  <a:pt x="0" y="310896"/>
+                  <a:pt x="0" y="365760"/>
                 </a:moveTo>
                 <a:lnTo>
-                  <a:pt x="237744" y="310896"/>
+                  <a:pt x="237744" y="365760"/>
                 </a:lnTo>
                 <a:lnTo>
                   <a:pt x="237744" y="0"/>
@@ -12283,14 +12529,14 @@
       </p:sp>
       <p:sp>
         <p:nvSpPr>
-          <p:cNvPr id="41" name="Rectangle 40"/>
+          <p:cNvPr id="37" name="Rectangle 36"/>
           <p:cNvSpPr/>
           <p:nvPr/>
         </p:nvSpPr>
         <p:spPr>
           <a:xfrm>
-            <a:off x="3218688" y="4407408"/>
-            <a:ext cx="5358383" cy="493776"/>
+            <a:off x="3218688" y="4498848"/>
+            <a:ext cx="5358383" cy="621792"/>
           </a:xfrm>
           <a:prstGeom prst="rect">
             <a:avLst/>
@@ -12312,13 +12558,13 @@
       </p:sp>
       <p:sp>
         <p:nvSpPr>
-          <p:cNvPr id="42" name="Oval 41"/>
+          <p:cNvPr id="38" name="Oval 37"/>
           <p:cNvSpPr/>
           <p:nvPr/>
         </p:nvSpPr>
         <p:spPr>
           <a:xfrm>
-            <a:off x="3328416" y="4517136"/>
+            <a:off x="3328416" y="4672584"/>
             <a:ext cx="274320" cy="274320"/>
           </a:xfrm>
           <a:prstGeom prst="ellipse">
@@ -12364,14 +12610,14 @@
       </p:sp>
       <p:sp>
         <p:nvSpPr>
-          <p:cNvPr id="43" name="TextBox 42"/>
+          <p:cNvPr id="39" name="TextBox 38"/>
           <p:cNvSpPr txBox="1"/>
           <p:nvPr/>
         </p:nvSpPr>
         <p:spPr>
           <a:xfrm>
-            <a:off x="3694176" y="4407408"/>
-            <a:ext cx="1371600" cy="493776"/>
+            <a:off x="3694176" y="4498848"/>
+            <a:ext cx="1371600" cy="621792"/>
           </a:xfrm>
           <a:prstGeom prst="rect">
             <a:avLst/>
@@ -12411,14 +12657,14 @@
       </p:sp>
       <p:sp>
         <p:nvSpPr>
-          <p:cNvPr id="44" name="TextBox 43"/>
+          <p:cNvPr id="40" name="TextBox 39"/>
           <p:cNvSpPr txBox="1"/>
           <p:nvPr/>
         </p:nvSpPr>
         <p:spPr>
           <a:xfrm>
-            <a:off x="4892040" y="4407408"/>
-            <a:ext cx="3154680" cy="493776"/>
+            <a:off x="4892040" y="4553712"/>
+            <a:ext cx="3154680" cy="274320"/>
           </a:xfrm>
           <a:prstGeom prst="rect">
             <a:avLst/>
@@ -12451,21 +12697,21 @@
                 <a:ea typeface="Microsoft YaHei"/>
                 <a:cs typeface="Microsoft YaHei"/>
               </a:rPr>
-              <a:t>重测基线与候选，独立复验</a:t>
-            </a:r>
-          </a:p>
-        </p:txBody>
-      </p:sp>
-      <p:sp>
-        <p:nvSpPr>
-          <p:cNvPr id="45" name="TextBox 44"/>
+              <a:t>重测基线，独立复验每个候选</a:t>
+            </a:r>
+          </a:p>
+        </p:txBody>
+      </p:sp>
+      <p:sp>
+        <p:nvSpPr>
+          <p:cNvPr id="41" name="TextBox 40"/>
           <p:cNvSpPr txBox="1"/>
           <p:nvPr/>
         </p:nvSpPr>
         <p:spPr>
           <a:xfrm>
-            <a:off x="4892040" y="4956048"/>
-            <a:ext cx="3611880" cy="237744"/>
+            <a:off x="4892040" y="4828032"/>
+            <a:ext cx="3154680" cy="256032"/>
           </a:xfrm>
           <a:prstGeom prst="rect">
             <a:avLst/>
@@ -12490,29 +12736,29 @@
               </a:spcAft>
             </a:pPr>
             <a:r>
-              <a:rPr sz="1000" b="0">
-                <a:solidFill>
-                  <a:srgbClr val="C0612C"/>
-                </a:solidFill>
-                <a:latin typeface="Microsoft YaHei"/>
-                <a:ea typeface="Microsoft YaHei"/>
-                <a:cs typeface="Microsoft YaHei"/>
-              </a:rPr>
-              <a:t>每个候选如何验收 → 下一页</a:t>
-            </a:r>
-          </a:p>
-        </p:txBody>
-      </p:sp>
-      <p:sp>
-        <p:nvSpPr>
-          <p:cNvPr id="46" name="Rectangle 45"/>
+              <a:rPr sz="950" b="0">
+                <a:solidFill>
+                  <a:srgbClr val="66727F"/>
+                </a:solidFill>
+                <a:latin typeface="Microsoft YaHei"/>
+                <a:ea typeface="Microsoft YaHei"/>
+                <a:cs typeface="Microsoft YaHei"/>
+              </a:rPr>
+              <a:t>产出：可交付的最优候选</a:t>
+            </a:r>
+          </a:p>
+        </p:txBody>
+      </p:sp>
+      <p:sp>
+        <p:nvSpPr>
+          <p:cNvPr id="42" name="Rectangle 41"/>
           <p:cNvSpPr/>
           <p:nvPr/>
         </p:nvSpPr>
         <p:spPr>
           <a:xfrm>
-            <a:off x="8961119" y="2304288"/>
-            <a:ext cx="2681935" cy="2926080"/>
+            <a:off x="8961119" y="2011680"/>
+            <a:ext cx="2681935" cy="3255264"/>
           </a:xfrm>
           <a:prstGeom prst="rect">
             <a:avLst/>
@@ -12534,13 +12780,13 @@
       </p:sp>
       <p:sp>
         <p:nvSpPr>
-          <p:cNvPr id="47" name="Rectangle 46"/>
+          <p:cNvPr id="43" name="Rectangle 42"/>
           <p:cNvSpPr/>
           <p:nvPr/>
         </p:nvSpPr>
         <p:spPr>
           <a:xfrm>
-            <a:off x="8961119" y="2304288"/>
+            <a:off x="8961119" y="2011680"/>
             <a:ext cx="2681935" cy="45720"/>
           </a:xfrm>
           <a:prstGeom prst="rect">
@@ -12563,13 +12809,13 @@
       </p:sp>
       <p:sp>
         <p:nvSpPr>
-          <p:cNvPr id="48" name="TextBox 47"/>
+          <p:cNvPr id="44" name="TextBox 43"/>
           <p:cNvSpPr txBox="1"/>
           <p:nvPr/>
         </p:nvSpPr>
         <p:spPr>
           <a:xfrm>
-            <a:off x="9162288" y="2432304"/>
+            <a:off x="9162288" y="2139696"/>
             <a:ext cx="2279599" cy="310896"/>
           </a:xfrm>
           <a:prstGeom prst="rect">
@@ -12621,13 +12867,13 @@
       </p:sp>
       <p:sp>
         <p:nvSpPr>
-          <p:cNvPr id="49" name="Oval 48"/>
+          <p:cNvPr id="45" name="Oval 44"/>
           <p:cNvSpPr/>
           <p:nvPr/>
         </p:nvSpPr>
         <p:spPr>
           <a:xfrm>
-            <a:off x="9162288" y="2999232"/>
+            <a:off x="9162288" y="2706624"/>
             <a:ext cx="91440" cy="91440"/>
           </a:xfrm>
           <a:prstGeom prst="ellipse">
@@ -12650,13 +12896,13 @@
       </p:sp>
       <p:sp>
         <p:nvSpPr>
-          <p:cNvPr id="50" name="TextBox 49"/>
+          <p:cNvPr id="46" name="TextBox 45"/>
           <p:cNvSpPr txBox="1"/>
           <p:nvPr/>
         </p:nvSpPr>
         <p:spPr>
           <a:xfrm>
-            <a:off x="9363456" y="2852928"/>
+            <a:off x="9363456" y="2560320"/>
             <a:ext cx="2078431" cy="420624"/>
           </a:xfrm>
           <a:prstGeom prst="rect">
@@ -12697,13 +12943,13 @@
       </p:sp>
       <p:sp>
         <p:nvSpPr>
-          <p:cNvPr id="51" name="Oval 50"/>
+          <p:cNvPr id="47" name="Oval 46"/>
           <p:cNvSpPr/>
           <p:nvPr/>
         </p:nvSpPr>
         <p:spPr>
           <a:xfrm>
-            <a:off x="9162288" y="3419856"/>
+            <a:off x="9162288" y="3127248"/>
             <a:ext cx="91440" cy="91440"/>
           </a:xfrm>
           <a:prstGeom prst="ellipse">
@@ -12726,13 +12972,13 @@
       </p:sp>
       <p:sp>
         <p:nvSpPr>
-          <p:cNvPr id="52" name="TextBox 51"/>
+          <p:cNvPr id="48" name="TextBox 47"/>
           <p:cNvSpPr txBox="1"/>
           <p:nvPr/>
         </p:nvSpPr>
         <p:spPr>
           <a:xfrm>
-            <a:off x="9363456" y="3273552"/>
+            <a:off x="9363456" y="2980944"/>
             <a:ext cx="2078431" cy="420624"/>
           </a:xfrm>
           <a:prstGeom prst="rect">
@@ -12773,13 +13019,13 @@
       </p:sp>
       <p:sp>
         <p:nvSpPr>
-          <p:cNvPr id="53" name="Oval 52"/>
+          <p:cNvPr id="49" name="Oval 48"/>
           <p:cNvSpPr/>
           <p:nvPr/>
         </p:nvSpPr>
         <p:spPr>
           <a:xfrm>
-            <a:off x="9162288" y="3840480"/>
+            <a:off x="9162288" y="3547872"/>
             <a:ext cx="91440" cy="91440"/>
           </a:xfrm>
           <a:prstGeom prst="ellipse">
@@ -12802,13 +13048,13 @@
       </p:sp>
       <p:sp>
         <p:nvSpPr>
-          <p:cNvPr id="54" name="TextBox 53"/>
+          <p:cNvPr id="50" name="TextBox 49"/>
           <p:cNvSpPr txBox="1"/>
           <p:nvPr/>
         </p:nvSpPr>
         <p:spPr>
           <a:xfrm>
-            <a:off x="9363456" y="3694176"/>
+            <a:off x="9363456" y="3401568"/>
             <a:ext cx="2078431" cy="420624"/>
           </a:xfrm>
           <a:prstGeom prst="rect">
@@ -12849,13 +13095,13 @@
       </p:sp>
       <p:sp>
         <p:nvSpPr>
-          <p:cNvPr id="55" name="Oval 54"/>
+          <p:cNvPr id="51" name="Oval 50"/>
           <p:cNvSpPr/>
           <p:nvPr/>
         </p:nvSpPr>
         <p:spPr>
           <a:xfrm>
-            <a:off x="9162288" y="4261104"/>
+            <a:off x="9162288" y="3968496"/>
             <a:ext cx="91440" cy="91440"/>
           </a:xfrm>
           <a:prstGeom prst="ellipse">
@@ -12878,13 +13124,13 @@
       </p:sp>
       <p:sp>
         <p:nvSpPr>
-          <p:cNvPr id="56" name="TextBox 55"/>
+          <p:cNvPr id="52" name="TextBox 51"/>
           <p:cNvSpPr txBox="1"/>
           <p:nvPr/>
         </p:nvSpPr>
         <p:spPr>
           <a:xfrm>
-            <a:off x="9363456" y="4114800"/>
+            <a:off x="9363456" y="3822192"/>
             <a:ext cx="2078431" cy="420624"/>
           </a:xfrm>
           <a:prstGeom prst="rect">
@@ -12925,13 +13171,13 @@
       </p:sp>
       <p:sp>
         <p:nvSpPr>
-          <p:cNvPr id="57" name="TextBox 56"/>
+          <p:cNvPr id="53" name="TextBox 52"/>
           <p:cNvSpPr txBox="1"/>
           <p:nvPr/>
         </p:nvSpPr>
         <p:spPr>
           <a:xfrm>
-            <a:off x="9162288" y="4754880"/>
+            <a:off x="9162288" y="4791456"/>
             <a:ext cx="2279599" cy="274320"/>
           </a:xfrm>
           <a:prstGeom prst="rect">
@@ -12972,13 +13218,13 @@
       </p:sp>
       <p:sp>
         <p:nvSpPr>
-          <p:cNvPr id="58" name="TextBox 57"/>
+          <p:cNvPr id="54" name="TextBox 53"/>
           <p:cNvSpPr txBox="1"/>
           <p:nvPr/>
         </p:nvSpPr>
         <p:spPr>
           <a:xfrm>
-            <a:off x="8961119" y="5010912"/>
+            <a:off x="8961119" y="5047488"/>
             <a:ext cx="2681935" cy="201168"/>
           </a:xfrm>
           <a:prstGeom prst="rect">
@@ -13019,13 +13265,13 @@
       </p:sp>
       <p:sp>
         <p:nvSpPr>
-          <p:cNvPr id="59" name="Freeform 58"/>
+          <p:cNvPr id="55" name="Freeform 54"/>
           <p:cNvSpPr/>
           <p:nvPr/>
         </p:nvSpPr>
         <p:spPr>
           <a:xfrm>
-            <a:off x="1691640" y="5230368"/>
+            <a:off x="1691640" y="5266944"/>
             <a:ext cx="8610447" cy="237744"/>
           </a:xfrm>
           <a:custGeom>
@@ -13069,13 +13315,13 @@
       </p:sp>
       <p:sp>
         <p:nvSpPr>
-          <p:cNvPr id="60" name="TextBox 59"/>
+          <p:cNvPr id="56" name="TextBox 55"/>
           <p:cNvSpPr txBox="1"/>
           <p:nvPr/>
         </p:nvSpPr>
         <p:spPr>
           <a:xfrm>
-            <a:off x="548640" y="5541264"/>
+            <a:off x="548640" y="5577840"/>
             <a:ext cx="11094415" cy="274320"/>
           </a:xfrm>
           <a:prstGeom prst="rect">
@@ -13116,7 +13362,7 @@
       </p:sp>
       <p:sp>
         <p:nvSpPr>
-          <p:cNvPr id="61" name="TextBox 60"/>
+          <p:cNvPr id="57" name="TextBox 56"/>
           <p:cNvSpPr txBox="1"/>
           <p:nvPr/>
         </p:nvSpPr>
@@ -13156,14 +13402,14 @@
                 <a:ea typeface="Microsoft YaHei"/>
                 <a:cs typeface="Microsoft YaHei"/>
               </a:rPr>
-              <a:t>三个阶段共用同一套契约与验收口径；架构接入验收通过后自动交接到优化</a:t>
-            </a:r>
-          </a:p>
-        </p:txBody>
-      </p:sp>
-      <p:sp>
-        <p:nvSpPr>
-          <p:cNvPr id="62" name="TextBox 61"/>
+              <a:t>已有流程可自动执行；新架构、未知缺陷与关键决策仍需要人工参与</a:t>
+            </a:r>
+          </a:p>
+        </p:txBody>
+      </p:sp>
+      <p:sp>
+        <p:nvSpPr>
+          <p:cNvPr id="58" name="TextBox 57"/>
           <p:cNvSpPr txBox="1"/>
           <p:nvPr/>
         </p:nvSpPr>
@@ -13203,7 +13449,7 @@
                 <a:ea typeface="Microsoft YaHei"/>
                 <a:cs typeface="Microsoft YaHei"/>
               </a:rPr>
-              <a:t>4 / 8</a:t>
+              <a:t>4 / 9</a:t>
             </a:r>
           </a:p>
         </p:txBody>
@@ -13268,7 +13514,7 @@
                 <a:ea typeface="Microsoft YaHei"/>
                 <a:cs typeface="Microsoft YaHei"/>
               </a:rPr>
-              <a:t>模型层 · 单个候选的验收</a:t>
+              <a:t>模型层 · 凭什么相信这些数字</a:t>
             </a:r>
           </a:p>
         </p:txBody>
@@ -13362,7 +13608,7 @@
                 <a:ea typeface="Microsoft YaHei"/>
                 <a:cs typeface="Microsoft YaHei"/>
               </a:rPr>
-              <a:t>三道条件由便宜到贵排列；判据为任务冻结时写定的阈值，不由模型解释</a:t>
+              <a:t>这一页回答一个问题：Agent 报出来的收益，凭什么可信</a:t>
             </a:r>
           </a:p>
         </p:txBody>
@@ -13375,8 +13621,8 @@
         </p:nvSpPr>
         <p:spPr>
           <a:xfrm>
-            <a:off x="548640" y="1737360"/>
-            <a:ext cx="6156655" cy="274320"/>
+            <a:off x="548640" y="1719072"/>
+            <a:ext cx="6156655" cy="256032"/>
           </a:xfrm>
           <a:prstGeom prst="rect">
             <a:avLst/>
@@ -13433,8 +13679,8 @@
         </p:nvSpPr>
         <p:spPr>
           <a:xfrm>
-            <a:off x="548640" y="2084831"/>
-            <a:ext cx="6156655" cy="402336"/>
+            <a:off x="548640" y="2029968"/>
+            <a:ext cx="6156655" cy="384048"/>
           </a:xfrm>
           <a:prstGeom prst="rect">
             <a:avLst/>
@@ -13462,8 +13708,8 @@
         </p:nvSpPr>
         <p:spPr>
           <a:xfrm>
-            <a:off x="768096" y="2084831"/>
-            <a:ext cx="5717743" cy="402336"/>
+            <a:off x="768096" y="2029968"/>
+            <a:ext cx="5717743" cy="384048"/>
           </a:xfrm>
           <a:prstGeom prst="rect">
             <a:avLst/>
@@ -13520,8 +13766,8 @@
         </p:nvSpPr>
         <p:spPr>
           <a:xfrm>
-            <a:off x="548640" y="2633472"/>
-            <a:ext cx="6156655" cy="493776"/>
+            <a:off x="548640" y="2523744"/>
+            <a:ext cx="6156655" cy="457200"/>
           </a:xfrm>
           <a:prstGeom prst="rect">
             <a:avLst/>
@@ -13551,8 +13797,8 @@
         </p:nvSpPr>
         <p:spPr>
           <a:xfrm>
-            <a:off x="713232" y="2633472"/>
-            <a:ext cx="329184" cy="493776"/>
+            <a:off x="713232" y="2523744"/>
+            <a:ext cx="329184" cy="457200"/>
           </a:xfrm>
           <a:prstGeom prst="rect">
             <a:avLst/>
@@ -13598,8 +13844,8 @@
         </p:nvSpPr>
         <p:spPr>
           <a:xfrm>
-            <a:off x="1078992" y="2633472"/>
-            <a:ext cx="914400" cy="493776"/>
+            <a:off x="1078992" y="2523744"/>
+            <a:ext cx="914400" cy="457200"/>
           </a:xfrm>
           <a:prstGeom prst="rect">
             <a:avLst/>
@@ -13645,8 +13891,8 @@
         </p:nvSpPr>
         <p:spPr>
           <a:xfrm>
-            <a:off x="2066543" y="2633472"/>
-            <a:ext cx="2011680" cy="493776"/>
+            <a:off x="2066543" y="2523744"/>
+            <a:ext cx="2011680" cy="457200"/>
           </a:xfrm>
           <a:prstGeom prst="rect">
             <a:avLst/>
@@ -13692,8 +13938,8 @@
         </p:nvSpPr>
         <p:spPr>
           <a:xfrm>
-            <a:off x="4151376" y="2633472"/>
-            <a:ext cx="2389327" cy="493776"/>
+            <a:off x="4151376" y="2523744"/>
+            <a:ext cx="2389327" cy="457200"/>
           </a:xfrm>
           <a:prstGeom prst="rect">
             <a:avLst/>
@@ -13739,8 +13985,8 @@
         </p:nvSpPr>
         <p:spPr>
           <a:xfrm>
-            <a:off x="548640" y="3200400"/>
-            <a:ext cx="6156655" cy="493776"/>
+            <a:off x="548640" y="3035808"/>
+            <a:ext cx="6156655" cy="457200"/>
           </a:xfrm>
           <a:prstGeom prst="rect">
             <a:avLst/>
@@ -13770,8 +14016,8 @@
         </p:nvSpPr>
         <p:spPr>
           <a:xfrm>
-            <a:off x="713232" y="3200400"/>
-            <a:ext cx="329184" cy="493776"/>
+            <a:off x="713232" y="3035808"/>
+            <a:ext cx="329184" cy="457200"/>
           </a:xfrm>
           <a:prstGeom prst="rect">
             <a:avLst/>
@@ -13817,8 +14063,8 @@
         </p:nvSpPr>
         <p:spPr>
           <a:xfrm>
-            <a:off x="1078992" y="3200400"/>
-            <a:ext cx="914400" cy="493776"/>
+            <a:off x="1078992" y="3035808"/>
+            <a:ext cx="914400" cy="457200"/>
           </a:xfrm>
           <a:prstGeom prst="rect">
             <a:avLst/>
@@ -13864,8 +14110,8 @@
         </p:nvSpPr>
         <p:spPr>
           <a:xfrm>
-            <a:off x="2066543" y="3200400"/>
-            <a:ext cx="2011680" cy="493776"/>
+            <a:off x="2066543" y="3035808"/>
+            <a:ext cx="2011680" cy="457200"/>
           </a:xfrm>
           <a:prstGeom prst="rect">
             <a:avLst/>
@@ -13911,8 +14157,8 @@
         </p:nvSpPr>
         <p:spPr>
           <a:xfrm>
-            <a:off x="4151376" y="3200400"/>
-            <a:ext cx="2389327" cy="493776"/>
+            <a:off x="4151376" y="3035808"/>
+            <a:ext cx="2389327" cy="457200"/>
           </a:xfrm>
           <a:prstGeom prst="rect">
             <a:avLst/>
@@ -13958,8 +14204,8 @@
         </p:nvSpPr>
         <p:spPr>
           <a:xfrm>
-            <a:off x="548640" y="3767328"/>
-            <a:ext cx="6156655" cy="493776"/>
+            <a:off x="548640" y="3547872"/>
+            <a:ext cx="6156655" cy="457200"/>
           </a:xfrm>
           <a:prstGeom prst="rect">
             <a:avLst/>
@@ -13989,8 +14235,8 @@
         </p:nvSpPr>
         <p:spPr>
           <a:xfrm>
-            <a:off x="713232" y="3767328"/>
-            <a:ext cx="329184" cy="493776"/>
+            <a:off x="713232" y="3547872"/>
+            <a:ext cx="329184" cy="457200"/>
           </a:xfrm>
           <a:prstGeom prst="rect">
             <a:avLst/>
@@ -14036,8 +14282,8 @@
         </p:nvSpPr>
         <p:spPr>
           <a:xfrm>
-            <a:off x="1078992" y="3767328"/>
-            <a:ext cx="914400" cy="493776"/>
+            <a:off x="1078992" y="3547872"/>
+            <a:ext cx="914400" cy="457200"/>
           </a:xfrm>
           <a:prstGeom prst="rect">
             <a:avLst/>
@@ -14083,8 +14329,8 @@
         </p:nvSpPr>
         <p:spPr>
           <a:xfrm>
-            <a:off x="2066543" y="3767328"/>
-            <a:ext cx="2011680" cy="493776"/>
+            <a:off x="2066543" y="3547872"/>
+            <a:ext cx="2011680" cy="457200"/>
           </a:xfrm>
           <a:prstGeom prst="rect">
             <a:avLst/>
@@ -14130,8 +14376,8 @@
         </p:nvSpPr>
         <p:spPr>
           <a:xfrm>
-            <a:off x="4151376" y="3767328"/>
-            <a:ext cx="2389327" cy="493776"/>
+            <a:off x="4151376" y="3547872"/>
+            <a:ext cx="2389327" cy="457200"/>
           </a:xfrm>
           <a:prstGeom prst="rect">
             <a:avLst/>
@@ -14177,8 +14423,8 @@
         </p:nvSpPr>
         <p:spPr>
           <a:xfrm>
-            <a:off x="548640" y="4425696"/>
-            <a:ext cx="6156655" cy="274320"/>
+            <a:off x="548640" y="4023360"/>
+            <a:ext cx="6156655" cy="201168"/>
           </a:xfrm>
           <a:prstGeom prst="rect">
             <a:avLst/>
@@ -14203,6 +14449,53 @@
               </a:spcAft>
             </a:pPr>
             <a:r>
+              <a:rPr sz="950" b="0">
+                <a:solidFill>
+                  <a:srgbClr val="66727F"/>
+                </a:solidFill>
+                <a:latin typeface="Microsoft YaHei"/>
+                <a:ea typeface="Microsoft YaHei"/>
+                <a:cs typeface="Microsoft YaHei"/>
+              </a:rPr>
+              <a:t>由便宜到贵排列，任一道不通过即停止后续测试</a:t>
+            </a:r>
+          </a:p>
+        </p:txBody>
+      </p:sp>
+      <p:sp>
+        <p:nvSpPr>
+          <p:cNvPr id="24" name="TextBox 23"/>
+          <p:cNvSpPr txBox="1"/>
+          <p:nvPr/>
+        </p:nvSpPr>
+        <p:spPr>
+          <a:xfrm>
+            <a:off x="548640" y="4389120"/>
+            <a:ext cx="6156655" cy="256032"/>
+          </a:xfrm>
+          <a:prstGeom prst="rect">
+            <a:avLst/>
+          </a:prstGeom>
+          <a:noFill/>
+        </p:spPr>
+        <p:txBody>
+          <a:bodyPr wrap="square" anchor="ctr" lIns="0" tIns="0" rIns="0" bIns="0">
+            <a:noAutofit/>
+          </a:bodyPr>
+          <a:lstStyle/>
+          <a:p>
+            <a:pPr algn="l" latinLnBrk="0">
+              <a:lnSpc>
+                <a:spcPct val="100000"/>
+              </a:lnSpc>
+              <a:spcBef>
+                <a:spcPts val="0"/>
+              </a:spcBef>
+              <a:spcAft>
+                <a:spcPts val="0"/>
+              </a:spcAft>
+            </a:pPr>
+            <a:r>
               <a:rPr sz="1200" b="1">
                 <a:solidFill>
                   <a:srgbClr val="16202A"/>
@@ -14211,7 +14504,7 @@
                 <a:ea typeface="Microsoft YaHei"/>
                 <a:cs typeface="Microsoft YaHei"/>
               </a:rPr>
-              <a:t>固定外部环境与输入</a:t>
+              <a:t>凭什么可信</a:t>
             </a:r>
             <a:r>
               <a:rPr sz="1050" b="0">
@@ -14222,20 +14515,20 @@
                 <a:ea typeface="Microsoft YaHei"/>
                 <a:cs typeface="Microsoft YaHei"/>
               </a:rPr>
-              <a:t>　保证候选之间可比</a:t>
-            </a:r>
-          </a:p>
-        </p:txBody>
-      </p:sp>
-      <p:sp>
-        <p:nvSpPr>
-          <p:cNvPr id="24" name="Oval 23"/>
+              <a:t>　三条防止自欺的约束</a:t>
+            </a:r>
+          </a:p>
+        </p:txBody>
+      </p:sp>
+      <p:sp>
+        <p:nvSpPr>
+          <p:cNvPr id="25" name="Oval 24"/>
           <p:cNvSpPr/>
           <p:nvPr/>
         </p:nvSpPr>
         <p:spPr>
           <a:xfrm>
-            <a:off x="548640" y="4837176"/>
+            <a:off x="548640" y="4745736"/>
             <a:ext cx="91440" cy="91440"/>
           </a:xfrm>
           <a:prstGeom prst="ellipse">
@@ -14258,14 +14551,14 @@
       </p:sp>
       <p:sp>
         <p:nvSpPr>
-          <p:cNvPr id="25" name="TextBox 24"/>
+          <p:cNvPr id="26" name="TextBox 25"/>
           <p:cNvSpPr txBox="1"/>
           <p:nvPr/>
         </p:nvSpPr>
         <p:spPr>
           <a:xfrm>
-            <a:off x="749808" y="4736592"/>
-            <a:ext cx="5955487" cy="329184"/>
+            <a:off x="749808" y="4663440"/>
+            <a:ext cx="5955487" cy="292608"/>
           </a:xfrm>
           <a:prstGeom prst="rect">
             <a:avLst/>
@@ -14298,20 +14591,20 @@
                 <a:ea typeface="Microsoft YaHei"/>
                 <a:cs typeface="Microsoft YaHei"/>
               </a:rPr>
-              <a:t>固定输入、精度、上下文与缓存条件；prompt token 数必须等于冻结值</a:t>
-            </a:r>
-          </a:p>
-        </p:txBody>
-      </p:sp>
-      <p:sp>
-        <p:nvSpPr>
-          <p:cNvPr id="26" name="Oval 25"/>
+              <a:t>口径先冻结：模型、负载、阈值与预算随任务写定，改了之后已有结果不再沿用</a:t>
+            </a:r>
+          </a:p>
+        </p:txBody>
+      </p:sp>
+      <p:sp>
+        <p:nvSpPr>
+          <p:cNvPr id="27" name="Oval 26"/>
           <p:cNvSpPr/>
           <p:nvPr/>
         </p:nvSpPr>
         <p:spPr>
           <a:xfrm>
-            <a:off x="548640" y="5166360"/>
+            <a:off x="548640" y="5038344"/>
             <a:ext cx="91440" cy="91440"/>
           </a:xfrm>
           <a:prstGeom prst="ellipse">
@@ -14334,14 +14627,14 @@
       </p:sp>
       <p:sp>
         <p:nvSpPr>
-          <p:cNvPr id="27" name="TextBox 26"/>
+          <p:cNvPr id="28" name="TextBox 27"/>
           <p:cNvSpPr txBox="1"/>
           <p:nvPr/>
         </p:nvSpPr>
         <p:spPr>
           <a:xfrm>
-            <a:off x="749808" y="5065776"/>
-            <a:ext cx="5955487" cy="329184"/>
+            <a:off x="749808" y="4956048"/>
+            <a:ext cx="5955487" cy="292608"/>
           </a:xfrm>
           <a:prstGeom prst="rect">
             <a:avLst/>
@@ -14374,21 +14667,97 @@
                 <a:ea typeface="Microsoft YaHei"/>
                 <a:cs typeface="Microsoft YaHei"/>
               </a:rPr>
-              <a:t>诊断与正式压测分开；收益由关闭 profiler 的独立复测确认</a:t>
-            </a:r>
-          </a:p>
-        </p:txBody>
-      </p:sp>
-      <p:sp>
-        <p:nvSpPr>
-          <p:cNvPr id="28" name="Rectangle 27"/>
+              <a:t>测的是同一个候选：隔离副本、记录产物身份，启动时核对端口与模型路径</a:t>
+            </a:r>
+          </a:p>
+        </p:txBody>
+      </p:sp>
+      <p:sp>
+        <p:nvSpPr>
+          <p:cNvPr id="29" name="Oval 28"/>
           <p:cNvSpPr/>
           <p:nvPr/>
         </p:nvSpPr>
         <p:spPr>
           <a:xfrm>
-            <a:off x="7071055" y="1737360"/>
-            <a:ext cx="4572000" cy="3602736"/>
+            <a:off x="548640" y="5330952"/>
+            <a:ext cx="91440" cy="91440"/>
+          </a:xfrm>
+          <a:prstGeom prst="ellipse">
+            <a:avLst/>
+          </a:prstGeom>
+          <a:solidFill>
+            <a:srgbClr val="C0612C"/>
+          </a:solidFill>
+          <a:ln>
+            <a:noFill/>
+          </a:ln>
+        </p:spPr>
+        <p:txBody>
+          <a:bodyPr rtlCol="0" anchor="ctr"/>
+          <a:lstStyle/>
+          <a:p>
+            <a:pPr algn="ctr"/>
+          </a:p>
+        </p:txBody>
+      </p:sp>
+      <p:sp>
+        <p:nvSpPr>
+          <p:cNvPr id="30" name="TextBox 29"/>
+          <p:cNvSpPr txBox="1"/>
+          <p:nvPr/>
+        </p:nvSpPr>
+        <p:spPr>
+          <a:xfrm>
+            <a:off x="749808" y="5248655"/>
+            <a:ext cx="5955487" cy="292608"/>
+          </a:xfrm>
+          <a:prstGeom prst="rect">
+            <a:avLst/>
+          </a:prstGeom>
+          <a:noFill/>
+        </p:spPr>
+        <p:txBody>
+          <a:bodyPr wrap="square" anchor="ctr" lIns="0" tIns="0" rIns="0" bIns="0">
+            <a:noAutofit/>
+          </a:bodyPr>
+          <a:lstStyle/>
+          <a:p>
+            <a:pPr algn="l" latinLnBrk="0">
+              <a:lnSpc>
+                <a:spcPct val="100000"/>
+              </a:lnSpc>
+              <a:spcBef>
+                <a:spcPts val="0"/>
+              </a:spcBef>
+              <a:spcAft>
+                <a:spcPts val="0"/>
+              </a:spcAft>
+            </a:pPr>
+            <a:r>
+              <a:rPr sz="1050" b="0">
+                <a:solidFill>
+                  <a:srgbClr val="35424F"/>
+                </a:solidFill>
+                <a:latin typeface="Microsoft YaHei"/>
+                <a:ea typeface="Microsoft YaHei"/>
+                <a:cs typeface="Microsoft YaHei"/>
+              </a:rPr>
+              <a:t>不能靠少干活变快：输入、精度、上下文与缓存全部冻结，诊断与正式压测分开</a:t>
+            </a:r>
+          </a:p>
+        </p:txBody>
+      </p:sp>
+      <p:sp>
+        <p:nvSpPr>
+          <p:cNvPr id="31" name="Rectangle 30"/>
+          <p:cNvSpPr/>
+          <p:nvPr/>
+        </p:nvSpPr>
+        <p:spPr>
+          <a:xfrm>
+            <a:off x="7071055" y="1719072"/>
+            <a:ext cx="4572000" cy="3822191"/>
           </a:xfrm>
           <a:prstGeom prst="rect">
             <a:avLst/>
@@ -14501,20 +14870,20 @@
                 <a:ea typeface="Microsoft YaHei"/>
                 <a:cs typeface="Microsoft YaHei"/>
               </a:rPr>
-              <a:t>5.0 × 3.94 in（约 4:3）</a:t>
-            </a:r>
-          </a:p>
-        </p:txBody>
-      </p:sp>
-      <p:sp>
-        <p:nvSpPr>
-          <p:cNvPr id="29" name="Rectangle 28"/>
+              <a:t>5.0 × 4.18 in</a:t>
+            </a:r>
+          </a:p>
+        </p:txBody>
+      </p:sp>
+      <p:sp>
+        <p:nvSpPr>
+          <p:cNvPr id="32" name="Rectangle 31"/>
           <p:cNvSpPr/>
           <p:nvPr/>
         </p:nvSpPr>
         <p:spPr>
           <a:xfrm>
-            <a:off x="548640" y="5486400"/>
+            <a:off x="548640" y="5632704"/>
             <a:ext cx="11094415" cy="475488"/>
           </a:xfrm>
           <a:prstGeom prst="rect">
@@ -14537,13 +14906,13 @@
       </p:sp>
       <p:sp>
         <p:nvSpPr>
-          <p:cNvPr id="30" name="Rectangle 29"/>
+          <p:cNvPr id="33" name="Rectangle 32"/>
           <p:cNvSpPr/>
           <p:nvPr/>
         </p:nvSpPr>
         <p:spPr>
           <a:xfrm>
-            <a:off x="548640" y="5486400"/>
+            <a:off x="548640" y="5632704"/>
             <a:ext cx="64008" cy="475488"/>
           </a:xfrm>
           <a:prstGeom prst="rect">
@@ -14566,13 +14935,13 @@
       </p:sp>
       <p:sp>
         <p:nvSpPr>
-          <p:cNvPr id="31" name="TextBox 30"/>
+          <p:cNvPr id="34" name="TextBox 33"/>
           <p:cNvSpPr txBox="1"/>
           <p:nvPr/>
         </p:nvSpPr>
         <p:spPr>
           <a:xfrm>
-            <a:off x="859536" y="5486400"/>
+            <a:off x="859536" y="5632704"/>
             <a:ext cx="10454335" cy="475488"/>
           </a:xfrm>
           <a:prstGeom prst="rect">
@@ -14624,7 +14993,7 @@
       </p:sp>
       <p:sp>
         <p:nvSpPr>
-          <p:cNvPr id="32" name="TextBox 31"/>
+          <p:cNvPr id="35" name="TextBox 34"/>
           <p:cNvSpPr txBox="1"/>
           <p:nvPr/>
         </p:nvSpPr>
@@ -14671,7 +15040,7 @@
       </p:sp>
       <p:sp>
         <p:nvSpPr>
-          <p:cNvPr id="33" name="TextBox 32"/>
+          <p:cNvPr id="36" name="TextBox 35"/>
           <p:cNvSpPr txBox="1"/>
           <p:nvPr/>
         </p:nvSpPr>
@@ -14711,7 +15080,7 @@
                 <a:ea typeface="Microsoft YaHei"/>
                 <a:cs typeface="Microsoft YaHei"/>
               </a:rPr>
-              <a:t>5 / 8</a:t>
+              <a:t>5 / 9</a:t>
             </a:r>
           </a:p>
         </p:txBody>
@@ -16467,7 +16836,7 @@
                 <a:ea typeface="Microsoft YaHei"/>
                 <a:cs typeface="Microsoft YaHei"/>
               </a:rPr>
-              <a:t>6 / 8</a:t>
+              <a:t>6 / 9</a:t>
             </a:r>
           </a:p>
         </p:txBody>
@@ -16532,7 +16901,7 @@
                 <a:ea typeface="Microsoft YaHei"/>
                 <a:cs typeface="Microsoft YaHei"/>
               </a:rPr>
-              <a:t>难点 · 局部加速与整体收益</a:t>
+              <a:t>难点 · 回到模型层看收益</a:t>
             </a:r>
           </a:p>
         </p:txBody>
@@ -16954,7 +17323,7 @@
               </a:spcAft>
             </a:pPr>
             <a:r>
-              <a:rPr sz="1000" b="0">
+              <a:rPr sz="950" b="0">
                 <a:solidFill>
                   <a:srgbClr val="66727F"/>
                 </a:solidFill>
@@ -16962,7 +17331,7 @@
                 <a:ea typeface="Microsoft YaHei"/>
                 <a:cs typeface="Microsoft YaHei"/>
               </a:rPr>
-              <a:t>偏 GEMM 的负载</a:t>
+              <a:t>短输入，GEMM 为主</a:t>
             </a:r>
           </a:p>
           <a:p>
@@ -17521,7 +17890,7 @@
               </a:spcAft>
             </a:pPr>
             <a:r>
-              <a:rPr sz="1000" b="0">
+              <a:rPr sz="950" b="0">
                 <a:solidFill>
                   <a:srgbClr val="66727F"/>
                 </a:solidFill>
@@ -17529,7 +17898,7 @@
                 <a:ea typeface="Microsoft YaHei"/>
                 <a:cs typeface="Microsoft YaHei"/>
               </a:rPr>
-              <a:t>Attention 占比增加</a:t>
+              <a:t>长上下文，Attention 变重</a:t>
             </a:r>
           </a:p>
           <a:p>
@@ -18383,7 +18752,7 @@
                 <a:ea typeface="Microsoft YaHei"/>
                 <a:cs typeface="Microsoft YaHei"/>
               </a:rPr>
-              <a:t>需要调度仿真与压测验证</a:t>
+              <a:t>下一页给出完整的换算办法</a:t>
             </a:r>
           </a:p>
         </p:txBody>
@@ -19375,7 +19744,7 @@
                 <a:ea typeface="Microsoft YaHei"/>
                 <a:cs typeface="Microsoft YaHei"/>
               </a:rPr>
-              <a:t>7 / 8</a:t>
+              <a:t>7 / 9</a:t>
             </a:r>
           </a:p>
         </p:txBody>
@@ -19440,7 +19809,7 @@
                 <a:ea typeface="Microsoft YaHei"/>
                 <a:cs typeface="Microsoft YaHei"/>
               </a:rPr>
-              <a:t>方法 · 从算子耗时到服务容量</a:t>
+              <a:t>方法 · 模型层如何给算子排优先级</a:t>
             </a:r>
           </a:p>
         </p:txBody>
@@ -21637,7 +22006,1859 @@
                 <a:ea typeface="Microsoft YaHei"/>
                 <a:cs typeface="Microsoft YaHei"/>
               </a:rPr>
-              <a:t>8 / 8</a:t>
+              <a:t>8 / 9</a:t>
+            </a:r>
+          </a:p>
+        </p:txBody>
+      </p:sp>
+    </p:spTree>
+  </p:cSld>
+  <p:clrMapOvr>
+    <a:masterClrMapping/>
+  </p:clrMapOvr>
+</p:sld>
+</file>
+
+<file path=ppt/slides/slide9.xml><?xml version="1.0" encoding="utf-8"?>
+<p:sld xmlns:a="http://schemas.openxmlformats.org/drawingml/2006/main" xmlns:p="http://schemas.openxmlformats.org/presentationml/2006/main" xmlns:r="http://schemas.openxmlformats.org/officeDocument/2006/relationships">
+  <p:cSld>
+    <p:spTree>
+      <p:nvGrpSpPr>
+        <p:cNvPr id="1" name=""/>
+        <p:cNvGrpSpPr/>
+        <p:nvPr/>
+      </p:nvGrpSpPr>
+      <p:grpSpPr/>
+      <p:sp>
+        <p:nvSpPr>
+          <p:cNvPr id="2" name="TextBox 1"/>
+          <p:cNvSpPr txBox="1"/>
+          <p:nvPr/>
+        </p:nvSpPr>
+        <p:spPr>
+          <a:xfrm>
+            <a:off x="548640" y="384048"/>
+            <a:ext cx="8229600" cy="292608"/>
+          </a:xfrm>
+          <a:prstGeom prst="rect">
+            <a:avLst/>
+          </a:prstGeom>
+          <a:noFill/>
+        </p:spPr>
+        <p:txBody>
+          <a:bodyPr wrap="square" anchor="ctr" lIns="0" tIns="0" rIns="0" bIns="0">
+            <a:noAutofit/>
+          </a:bodyPr>
+          <a:lstStyle/>
+          <a:p>
+            <a:pPr algn="l" latinLnBrk="0">
+              <a:lnSpc>
+                <a:spcPct val="100000"/>
+              </a:lnSpc>
+              <a:spcBef>
+                <a:spcPts val="0"/>
+              </a:spcBef>
+              <a:spcAft>
+                <a:spcPts val="0"/>
+              </a:spcAft>
+            </a:pPr>
+            <a:r>
+              <a:rPr sz="1100" b="1">
+                <a:solidFill>
+                  <a:srgbClr val="C0612C"/>
+                </a:solidFill>
+                <a:latin typeface="Consolas"/>
+                <a:ea typeface="Microsoft YaHei"/>
+                <a:cs typeface="Microsoft YaHei"/>
+              </a:rPr>
+              <a:t>收尾 · 现状与下一步</a:t>
+            </a:r>
+          </a:p>
+        </p:txBody>
+      </p:sp>
+      <p:sp>
+        <p:nvSpPr>
+          <p:cNvPr id="3" name="TextBox 2"/>
+          <p:cNvSpPr txBox="1"/>
+          <p:nvPr/>
+        </p:nvSpPr>
+        <p:spPr>
+          <a:xfrm>
+            <a:off x="548640" y="731520"/>
+            <a:ext cx="11094415" cy="530352"/>
+          </a:xfrm>
+          <a:prstGeom prst="rect">
+            <a:avLst/>
+          </a:prstGeom>
+          <a:noFill/>
+        </p:spPr>
+        <p:txBody>
+          <a:bodyPr wrap="square" anchor="ctr" lIns="0" tIns="0" rIns="0" bIns="0">
+            <a:noAutofit/>
+          </a:bodyPr>
+          <a:lstStyle/>
+          <a:p>
+            <a:pPr algn="l" latinLnBrk="0">
+              <a:lnSpc>
+                <a:spcPct val="100000"/>
+              </a:lnSpc>
+              <a:spcBef>
+                <a:spcPts val="0"/>
+              </a:spcBef>
+              <a:spcAft>
+                <a:spcPts val="0"/>
+              </a:spcAft>
+            </a:pPr>
+            <a:r>
+              <a:rPr sz="2500" b="1">
+                <a:solidFill>
+                  <a:srgbClr val="16202A"/>
+                </a:solidFill>
+                <a:latin typeface="Microsoft YaHei"/>
+                <a:ea typeface="Microsoft YaHei"/>
+                <a:cs typeface="Microsoft YaHei"/>
+              </a:rPr>
+              <a:t>回到第 1 页的命题：适配成本降下来了多少</a:t>
+            </a:r>
+          </a:p>
+        </p:txBody>
+      </p:sp>
+      <p:sp>
+        <p:nvSpPr>
+          <p:cNvPr id="4" name="TextBox 3"/>
+          <p:cNvSpPr txBox="1"/>
+          <p:nvPr/>
+        </p:nvSpPr>
+        <p:spPr>
+          <a:xfrm>
+            <a:off x="548640" y="1261872"/>
+            <a:ext cx="11094415" cy="329184"/>
+          </a:xfrm>
+          <a:prstGeom prst="rect">
+            <a:avLst/>
+          </a:prstGeom>
+          <a:noFill/>
+        </p:spPr>
+        <p:txBody>
+          <a:bodyPr wrap="square" anchor="ctr" lIns="0" tIns="0" rIns="0" bIns="0">
+            <a:noAutofit/>
+          </a:bodyPr>
+          <a:lstStyle/>
+          <a:p>
+            <a:pPr algn="l" latinLnBrk="0">
+              <a:lnSpc>
+                <a:spcPct val="100000"/>
+              </a:lnSpc>
+              <a:spcBef>
+                <a:spcPts val="0"/>
+              </a:spcBef>
+              <a:spcAft>
+                <a:spcPts val="0"/>
+              </a:spcAft>
+            </a:pPr>
+            <a:r>
+              <a:rPr sz="1300" b="0">
+                <a:solidFill>
+                  <a:srgbClr val="66727F"/>
+                </a:solidFill>
+                <a:latin typeface="Microsoft YaHei"/>
+                <a:ea typeface="Microsoft YaHei"/>
+                <a:cs typeface="Microsoft YaHei"/>
+              </a:rPr>
+              <a:t>如实对账——哪些已经自动跑，哪些仍然靠人，哪些还没做</a:t>
+            </a:r>
+          </a:p>
+        </p:txBody>
+      </p:sp>
+      <p:sp>
+        <p:nvSpPr>
+          <p:cNvPr id="5" name="Rectangle 4"/>
+          <p:cNvSpPr/>
+          <p:nvPr/>
+        </p:nvSpPr>
+        <p:spPr>
+          <a:xfrm>
+            <a:off x="548640" y="1828800"/>
+            <a:ext cx="3515258" cy="3200400"/>
+          </a:xfrm>
+          <a:prstGeom prst="rect">
+            <a:avLst/>
+          </a:prstGeom>
+          <a:solidFill>
+            <a:srgbClr val="F8EADF"/>
+          </a:solidFill>
+          <a:ln>
+            <a:noFill/>
+          </a:ln>
+        </p:spPr>
+        <p:txBody>
+          <a:bodyPr rtlCol="0" anchor="ctr"/>
+          <a:lstStyle/>
+          <a:p>
+            <a:pPr algn="ctr"/>
+          </a:p>
+        </p:txBody>
+      </p:sp>
+      <p:sp>
+        <p:nvSpPr>
+          <p:cNvPr id="6" name="Rectangle 5"/>
+          <p:cNvSpPr/>
+          <p:nvPr/>
+        </p:nvSpPr>
+        <p:spPr>
+          <a:xfrm>
+            <a:off x="548640" y="1828800"/>
+            <a:ext cx="3515258" cy="45720"/>
+          </a:xfrm>
+          <a:prstGeom prst="rect">
+            <a:avLst/>
+          </a:prstGeom>
+          <a:solidFill>
+            <a:srgbClr val="C0612C"/>
+          </a:solidFill>
+          <a:ln>
+            <a:noFill/>
+          </a:ln>
+        </p:spPr>
+        <p:txBody>
+          <a:bodyPr rtlCol="0" anchor="ctr"/>
+          <a:lstStyle/>
+          <a:p>
+            <a:pPr algn="ctr"/>
+          </a:p>
+        </p:txBody>
+      </p:sp>
+      <p:sp>
+        <p:nvSpPr>
+          <p:cNvPr id="7" name="TextBox 6"/>
+          <p:cNvSpPr txBox="1"/>
+          <p:nvPr/>
+        </p:nvSpPr>
+        <p:spPr>
+          <a:xfrm>
+            <a:off x="768096" y="2011680"/>
+            <a:ext cx="3076346" cy="329184"/>
+          </a:xfrm>
+          <a:prstGeom prst="rect">
+            <a:avLst/>
+          </a:prstGeom>
+          <a:noFill/>
+        </p:spPr>
+        <p:txBody>
+          <a:bodyPr wrap="square" anchor="ctr" lIns="0" tIns="0" rIns="0" bIns="0">
+            <a:noAutofit/>
+          </a:bodyPr>
+          <a:lstStyle/>
+          <a:p>
+            <a:pPr algn="l" latinLnBrk="0">
+              <a:lnSpc>
+                <a:spcPct val="100000"/>
+              </a:lnSpc>
+              <a:spcBef>
+                <a:spcPts val="0"/>
+              </a:spcBef>
+              <a:spcAft>
+                <a:spcPts val="0"/>
+              </a:spcAft>
+            </a:pPr>
+            <a:r>
+              <a:rPr sz="1500" b="1">
+                <a:solidFill>
+                  <a:srgbClr val="16202A"/>
+                </a:solidFill>
+                <a:latin typeface="Microsoft YaHei"/>
+                <a:ea typeface="Microsoft YaHei"/>
+                <a:cs typeface="Microsoft YaHei"/>
+              </a:rPr>
+              <a:t>已经自动跑</a:t>
+            </a:r>
+          </a:p>
+        </p:txBody>
+      </p:sp>
+      <p:sp>
+        <p:nvSpPr>
+          <p:cNvPr id="8" name="TextBox 7"/>
+          <p:cNvSpPr txBox="1"/>
+          <p:nvPr/>
+        </p:nvSpPr>
+        <p:spPr>
+          <a:xfrm>
+            <a:off x="768096" y="2359152"/>
+            <a:ext cx="3076346" cy="237744"/>
+          </a:xfrm>
+          <a:prstGeom prst="rect">
+            <a:avLst/>
+          </a:prstGeom>
+          <a:noFill/>
+        </p:spPr>
+        <p:txBody>
+          <a:bodyPr wrap="square" anchor="ctr" lIns="0" tIns="0" rIns="0" bIns="0">
+            <a:noAutofit/>
+          </a:bodyPr>
+          <a:lstStyle/>
+          <a:p>
+            <a:pPr algn="l" latinLnBrk="0">
+              <a:lnSpc>
+                <a:spcPct val="100000"/>
+              </a:lnSpc>
+              <a:spcBef>
+                <a:spcPts val="0"/>
+              </a:spcBef>
+              <a:spcAft>
+                <a:spcPts val="0"/>
+              </a:spcAft>
+            </a:pPr>
+            <a:r>
+              <a:rPr sz="950" b="0">
+                <a:solidFill>
+                  <a:srgbClr val="C0612C"/>
+                </a:solidFill>
+                <a:latin typeface="Consolas"/>
+                <a:ea typeface="Microsoft YaHei"/>
+                <a:cs typeface="Microsoft YaHei"/>
+              </a:rPr>
+              <a:t>第 4 - 6 页</a:t>
+            </a:r>
+          </a:p>
+        </p:txBody>
+      </p:sp>
+      <p:sp>
+        <p:nvSpPr>
+          <p:cNvPr id="9" name="Oval 8"/>
+          <p:cNvSpPr/>
+          <p:nvPr/>
+        </p:nvSpPr>
+        <p:spPr>
+          <a:xfrm>
+            <a:off x="768096" y="2889504"/>
+            <a:ext cx="91440" cy="91440"/>
+          </a:xfrm>
+          <a:prstGeom prst="ellipse">
+            <a:avLst/>
+          </a:prstGeom>
+          <a:solidFill>
+            <a:srgbClr val="C0612C"/>
+          </a:solidFill>
+          <a:ln>
+            <a:noFill/>
+          </a:ln>
+        </p:spPr>
+        <p:txBody>
+          <a:bodyPr rtlCol="0" anchor="ctr"/>
+          <a:lstStyle/>
+          <a:p>
+            <a:pPr algn="ctr"/>
+          </a:p>
+        </p:txBody>
+      </p:sp>
+      <p:sp>
+        <p:nvSpPr>
+          <p:cNvPr id="10" name="TextBox 9"/>
+          <p:cNvSpPr txBox="1"/>
+          <p:nvPr/>
+        </p:nvSpPr>
+        <p:spPr>
+          <a:xfrm>
+            <a:off x="969264" y="2724912"/>
+            <a:ext cx="2875178" cy="457200"/>
+          </a:xfrm>
+          <a:prstGeom prst="rect">
+            <a:avLst/>
+          </a:prstGeom>
+          <a:noFill/>
+        </p:spPr>
+        <p:txBody>
+          <a:bodyPr wrap="square" anchor="ctr" lIns="0" tIns="0" rIns="0" bIns="0">
+            <a:noAutofit/>
+          </a:bodyPr>
+          <a:lstStyle/>
+          <a:p>
+            <a:pPr algn="l" latinLnBrk="0">
+              <a:lnSpc>
+                <a:spcPct val="100000"/>
+              </a:lnSpc>
+              <a:spcBef>
+                <a:spcPts val="0"/>
+              </a:spcBef>
+              <a:spcAft>
+                <a:spcPts val="0"/>
+              </a:spcAft>
+            </a:pPr>
+            <a:r>
+              <a:rPr sz="1100" b="0">
+                <a:solidFill>
+                  <a:srgbClr val="16202A"/>
+                </a:solidFill>
+                <a:latin typeface="Microsoft YaHei"/>
+                <a:ea typeface="Microsoft YaHei"/>
+                <a:cs typeface="Microsoft YaHei"/>
+              </a:rPr>
+              <a:t>基线建立与全量评测</a:t>
+            </a:r>
+          </a:p>
+        </p:txBody>
+      </p:sp>
+      <p:sp>
+        <p:nvSpPr>
+          <p:cNvPr id="11" name="Oval 10"/>
+          <p:cNvSpPr/>
+          <p:nvPr/>
+        </p:nvSpPr>
+        <p:spPr>
+          <a:xfrm>
+            <a:off x="768096" y="3346704"/>
+            <a:ext cx="91440" cy="91440"/>
+          </a:xfrm>
+          <a:prstGeom prst="ellipse">
+            <a:avLst/>
+          </a:prstGeom>
+          <a:solidFill>
+            <a:srgbClr val="C0612C"/>
+          </a:solidFill>
+          <a:ln>
+            <a:noFill/>
+          </a:ln>
+        </p:spPr>
+        <p:txBody>
+          <a:bodyPr rtlCol="0" anchor="ctr"/>
+          <a:lstStyle/>
+          <a:p>
+            <a:pPr algn="ctr"/>
+          </a:p>
+        </p:txBody>
+      </p:sp>
+      <p:sp>
+        <p:nvSpPr>
+          <p:cNvPr id="12" name="TextBox 11"/>
+          <p:cNvSpPr txBox="1"/>
+          <p:nvPr/>
+        </p:nvSpPr>
+        <p:spPr>
+          <a:xfrm>
+            <a:off x="969264" y="3182112"/>
+            <a:ext cx="2875178" cy="457200"/>
+          </a:xfrm>
+          <a:prstGeom prst="rect">
+            <a:avLst/>
+          </a:prstGeom>
+          <a:noFill/>
+        </p:spPr>
+        <p:txBody>
+          <a:bodyPr wrap="square" anchor="ctr" lIns="0" tIns="0" rIns="0" bIns="0">
+            <a:noAutofit/>
+          </a:bodyPr>
+          <a:lstStyle/>
+          <a:p>
+            <a:pPr algn="l" latinLnBrk="0">
+              <a:lnSpc>
+                <a:spcPct val="100000"/>
+              </a:lnSpc>
+              <a:spcBef>
+                <a:spcPts val="0"/>
+              </a:spcBef>
+              <a:spcAft>
+                <a:spcPts val="0"/>
+              </a:spcAft>
+            </a:pPr>
+            <a:r>
+              <a:rPr sz="1100" b="0">
+                <a:solidFill>
+                  <a:srgbClr val="16202A"/>
+                </a:solidFill>
+                <a:latin typeface="Microsoft YaHei"/>
+                <a:ea typeface="Microsoft YaHei"/>
+                <a:cs typeface="Microsoft YaHei"/>
+              </a:rPr>
+              <a:t>候选迭代与三道条件验收</a:t>
+            </a:r>
+          </a:p>
+        </p:txBody>
+      </p:sp>
+      <p:sp>
+        <p:nvSpPr>
+          <p:cNvPr id="13" name="Oval 12"/>
+          <p:cNvSpPr/>
+          <p:nvPr/>
+        </p:nvSpPr>
+        <p:spPr>
+          <a:xfrm>
+            <a:off x="768096" y="3803904"/>
+            <a:ext cx="91440" cy="91440"/>
+          </a:xfrm>
+          <a:prstGeom prst="ellipse">
+            <a:avLst/>
+          </a:prstGeom>
+          <a:solidFill>
+            <a:srgbClr val="C0612C"/>
+          </a:solidFill>
+          <a:ln>
+            <a:noFill/>
+          </a:ln>
+        </p:spPr>
+        <p:txBody>
+          <a:bodyPr rtlCol="0" anchor="ctr"/>
+          <a:lstStyle/>
+          <a:p>
+            <a:pPr algn="ctr"/>
+          </a:p>
+        </p:txBody>
+      </p:sp>
+      <p:sp>
+        <p:nvSpPr>
+          <p:cNvPr id="14" name="TextBox 13"/>
+          <p:cNvSpPr txBox="1"/>
+          <p:nvPr/>
+        </p:nvSpPr>
+        <p:spPr>
+          <a:xfrm>
+            <a:off x="969264" y="3639312"/>
+            <a:ext cx="2875178" cy="457200"/>
+          </a:xfrm>
+          <a:prstGeom prst="rect">
+            <a:avLst/>
+          </a:prstGeom>
+          <a:noFill/>
+        </p:spPr>
+        <p:txBody>
+          <a:bodyPr wrap="square" anchor="ctr" lIns="0" tIns="0" rIns="0" bIns="0">
+            <a:noAutofit/>
+          </a:bodyPr>
+          <a:lstStyle/>
+          <a:p>
+            <a:pPr algn="l" latinLnBrk="0">
+              <a:lnSpc>
+                <a:spcPct val="100000"/>
+              </a:lnSpc>
+              <a:spcBef>
+                <a:spcPts val="0"/>
+              </a:spcBef>
+              <a:spcAft>
+                <a:spcPts val="0"/>
+              </a:spcAft>
+            </a:pPr>
+            <a:r>
+              <a:rPr sz="1100" b="0">
+                <a:solidFill>
+                  <a:srgbClr val="16202A"/>
+                </a:solidFill>
+                <a:latin typeface="Microsoft YaHei"/>
+                <a:ea typeface="Microsoft YaHei"/>
+                <a:cs typeface="Microsoft YaHei"/>
+              </a:rPr>
+              <a:t>Trace 采集与热点定位</a:t>
+            </a:r>
+          </a:p>
+        </p:txBody>
+      </p:sp>
+      <p:sp>
+        <p:nvSpPr>
+          <p:cNvPr id="15" name="Oval 14"/>
+          <p:cNvSpPr/>
+          <p:nvPr/>
+        </p:nvSpPr>
+        <p:spPr>
+          <a:xfrm>
+            <a:off x="768096" y="4261104"/>
+            <a:ext cx="91440" cy="91440"/>
+          </a:xfrm>
+          <a:prstGeom prst="ellipse">
+            <a:avLst/>
+          </a:prstGeom>
+          <a:solidFill>
+            <a:srgbClr val="C0612C"/>
+          </a:solidFill>
+          <a:ln>
+            <a:noFill/>
+          </a:ln>
+        </p:spPr>
+        <p:txBody>
+          <a:bodyPr rtlCol="0" anchor="ctr"/>
+          <a:lstStyle/>
+          <a:p>
+            <a:pPr algn="ctr"/>
+          </a:p>
+        </p:txBody>
+      </p:sp>
+      <p:sp>
+        <p:nvSpPr>
+          <p:cNvPr id="16" name="TextBox 15"/>
+          <p:cNvSpPr txBox="1"/>
+          <p:nvPr/>
+        </p:nvSpPr>
+        <p:spPr>
+          <a:xfrm>
+            <a:off x="969264" y="4096512"/>
+            <a:ext cx="2875178" cy="457200"/>
+          </a:xfrm>
+          <a:prstGeom prst="rect">
+            <a:avLst/>
+          </a:prstGeom>
+          <a:noFill/>
+        </p:spPr>
+        <p:txBody>
+          <a:bodyPr wrap="square" anchor="ctr" lIns="0" tIns="0" rIns="0" bIns="0">
+            <a:noAutofit/>
+          </a:bodyPr>
+          <a:lstStyle/>
+          <a:p>
+            <a:pPr algn="l" latinLnBrk="0">
+              <a:lnSpc>
+                <a:spcPct val="100000"/>
+              </a:lnSpc>
+              <a:spcBef>
+                <a:spcPts val="0"/>
+              </a:spcBef>
+              <a:spcAft>
+                <a:spcPts val="0"/>
+              </a:spcAft>
+            </a:pPr>
+            <a:r>
+              <a:rPr sz="1100" b="0">
+                <a:solidFill>
+                  <a:srgbClr val="16202A"/>
+                </a:solidFill>
+                <a:latin typeface="Microsoft YaHei"/>
+                <a:ea typeface="Microsoft YaHei"/>
+                <a:cs typeface="Microsoft YaHei"/>
+              </a:rPr>
+              <a:t>失败证据与逐轮回放</a:t>
+            </a:r>
+          </a:p>
+        </p:txBody>
+      </p:sp>
+      <p:sp>
+        <p:nvSpPr>
+          <p:cNvPr id="17" name="TextBox 16"/>
+          <p:cNvSpPr txBox="1"/>
+          <p:nvPr/>
+        </p:nvSpPr>
+        <p:spPr>
+          <a:xfrm>
+            <a:off x="768096" y="4572000"/>
+            <a:ext cx="3076346" cy="310896"/>
+          </a:xfrm>
+          <a:prstGeom prst="rect">
+            <a:avLst/>
+          </a:prstGeom>
+          <a:noFill/>
+        </p:spPr>
+        <p:txBody>
+          <a:bodyPr wrap="square" anchor="ctr" lIns="0" tIns="0" rIns="0" bIns="0">
+            <a:noAutofit/>
+          </a:bodyPr>
+          <a:lstStyle/>
+          <a:p>
+            <a:pPr algn="l" latinLnBrk="0">
+              <a:lnSpc>
+                <a:spcPct val="100000"/>
+              </a:lnSpc>
+              <a:spcBef>
+                <a:spcPts val="0"/>
+              </a:spcBef>
+              <a:spcAft>
+                <a:spcPts val="0"/>
+              </a:spcAft>
+            </a:pPr>
+            <a:r>
+              <a:rPr sz="1000" b="0">
+                <a:solidFill>
+                  <a:srgbClr val="66727F"/>
+                </a:solidFill>
+                <a:latin typeface="Microsoft YaHei"/>
+                <a:ea typeface="Microsoft YaHei"/>
+                <a:cs typeface="Microsoft YaHei"/>
+              </a:rPr>
+              <a:t>人不在回路里，跑完才看结果</a:t>
+            </a:r>
+          </a:p>
+        </p:txBody>
+      </p:sp>
+      <p:sp>
+        <p:nvSpPr>
+          <p:cNvPr id="18" name="Rectangle 17"/>
+          <p:cNvSpPr/>
+          <p:nvPr/>
+        </p:nvSpPr>
+        <p:spPr>
+          <a:xfrm>
+            <a:off x="4338218" y="1828800"/>
+            <a:ext cx="3515258" cy="3200400"/>
+          </a:xfrm>
+          <a:prstGeom prst="rect">
+            <a:avLst/>
+          </a:prstGeom>
+          <a:solidFill>
+            <a:srgbClr val="F6F7F9"/>
+          </a:solidFill>
+          <a:ln>
+            <a:noFill/>
+          </a:ln>
+        </p:spPr>
+        <p:txBody>
+          <a:bodyPr rtlCol="0" anchor="ctr"/>
+          <a:lstStyle/>
+          <a:p>
+            <a:pPr algn="ctr"/>
+          </a:p>
+        </p:txBody>
+      </p:sp>
+      <p:sp>
+        <p:nvSpPr>
+          <p:cNvPr id="19" name="Rectangle 18"/>
+          <p:cNvSpPr/>
+          <p:nvPr/>
+        </p:nvSpPr>
+        <p:spPr>
+          <a:xfrm>
+            <a:off x="4338218" y="1828800"/>
+            <a:ext cx="3515258" cy="45720"/>
+          </a:xfrm>
+          <a:prstGeom prst="rect">
+            <a:avLst/>
+          </a:prstGeom>
+          <a:solidFill>
+            <a:srgbClr val="8C96A1"/>
+          </a:solidFill>
+          <a:ln>
+            <a:noFill/>
+          </a:ln>
+        </p:spPr>
+        <p:txBody>
+          <a:bodyPr rtlCol="0" anchor="ctr"/>
+          <a:lstStyle/>
+          <a:p>
+            <a:pPr algn="ctr"/>
+          </a:p>
+        </p:txBody>
+      </p:sp>
+      <p:sp>
+        <p:nvSpPr>
+          <p:cNvPr id="20" name="TextBox 19"/>
+          <p:cNvSpPr txBox="1"/>
+          <p:nvPr/>
+        </p:nvSpPr>
+        <p:spPr>
+          <a:xfrm>
+            <a:off x="4557674" y="2011680"/>
+            <a:ext cx="3076346" cy="329184"/>
+          </a:xfrm>
+          <a:prstGeom prst="rect">
+            <a:avLst/>
+          </a:prstGeom>
+          <a:noFill/>
+        </p:spPr>
+        <p:txBody>
+          <a:bodyPr wrap="square" anchor="ctr" lIns="0" tIns="0" rIns="0" bIns="0">
+            <a:noAutofit/>
+          </a:bodyPr>
+          <a:lstStyle/>
+          <a:p>
+            <a:pPr algn="l" latinLnBrk="0">
+              <a:lnSpc>
+                <a:spcPct val="100000"/>
+              </a:lnSpc>
+              <a:spcBef>
+                <a:spcPts val="0"/>
+              </a:spcBef>
+              <a:spcAft>
+                <a:spcPts val="0"/>
+              </a:spcAft>
+            </a:pPr>
+            <a:r>
+              <a:rPr sz="1500" b="1">
+                <a:solidFill>
+                  <a:srgbClr val="16202A"/>
+                </a:solidFill>
+                <a:latin typeface="Microsoft YaHei"/>
+                <a:ea typeface="Microsoft YaHei"/>
+                <a:cs typeface="Microsoft YaHei"/>
+              </a:rPr>
+              <a:t>仍然靠人</a:t>
+            </a:r>
+          </a:p>
+        </p:txBody>
+      </p:sp>
+      <p:sp>
+        <p:nvSpPr>
+          <p:cNvPr id="21" name="TextBox 20"/>
+          <p:cNvSpPr txBox="1"/>
+          <p:nvPr/>
+        </p:nvSpPr>
+        <p:spPr>
+          <a:xfrm>
+            <a:off x="4557674" y="2359152"/>
+            <a:ext cx="3076346" cy="237744"/>
+          </a:xfrm>
+          <a:prstGeom prst="rect">
+            <a:avLst/>
+          </a:prstGeom>
+          <a:noFill/>
+        </p:spPr>
+        <p:txBody>
+          <a:bodyPr wrap="square" anchor="ctr" lIns="0" tIns="0" rIns="0" bIns="0">
+            <a:noAutofit/>
+          </a:bodyPr>
+          <a:lstStyle/>
+          <a:p>
+            <a:pPr algn="l" latinLnBrk="0">
+              <a:lnSpc>
+                <a:spcPct val="100000"/>
+              </a:lnSpc>
+              <a:spcBef>
+                <a:spcPts val="0"/>
+              </a:spcBef>
+              <a:spcAft>
+                <a:spcPts val="0"/>
+              </a:spcAft>
+            </a:pPr>
+            <a:r>
+              <a:rPr sz="950" b="0">
+                <a:solidFill>
+                  <a:srgbClr val="66727F"/>
+                </a:solidFill>
+                <a:latin typeface="Consolas"/>
+                <a:ea typeface="Microsoft YaHei"/>
+                <a:cs typeface="Microsoft YaHei"/>
+              </a:rPr>
+              <a:t>第 4 页两端</a:t>
+            </a:r>
+          </a:p>
+        </p:txBody>
+      </p:sp>
+      <p:sp>
+        <p:nvSpPr>
+          <p:cNvPr id="22" name="Oval 21"/>
+          <p:cNvSpPr/>
+          <p:nvPr/>
+        </p:nvSpPr>
+        <p:spPr>
+          <a:xfrm>
+            <a:off x="4557674" y="2889504"/>
+            <a:ext cx="91440" cy="91440"/>
+          </a:xfrm>
+          <a:prstGeom prst="ellipse">
+            <a:avLst/>
+          </a:prstGeom>
+          <a:solidFill>
+            <a:srgbClr val="C0612C"/>
+          </a:solidFill>
+          <a:ln>
+            <a:noFill/>
+          </a:ln>
+        </p:spPr>
+        <p:txBody>
+          <a:bodyPr rtlCol="0" anchor="ctr"/>
+          <a:lstStyle/>
+          <a:p>
+            <a:pPr algn="ctr"/>
+          </a:p>
+        </p:txBody>
+      </p:sp>
+      <p:sp>
+        <p:nvSpPr>
+          <p:cNvPr id="23" name="TextBox 22"/>
+          <p:cNvSpPr txBox="1"/>
+          <p:nvPr/>
+        </p:nvSpPr>
+        <p:spPr>
+          <a:xfrm>
+            <a:off x="4758842" y="2724912"/>
+            <a:ext cx="2875178" cy="457200"/>
+          </a:xfrm>
+          <a:prstGeom prst="rect">
+            <a:avLst/>
+          </a:prstGeom>
+          <a:noFill/>
+        </p:spPr>
+        <p:txBody>
+          <a:bodyPr wrap="square" anchor="ctr" lIns="0" tIns="0" rIns="0" bIns="0">
+            <a:noAutofit/>
+          </a:bodyPr>
+          <a:lstStyle/>
+          <a:p>
+            <a:pPr algn="l" latinLnBrk="0">
+              <a:lnSpc>
+                <a:spcPct val="100000"/>
+              </a:lnSpc>
+              <a:spcBef>
+                <a:spcPts val="0"/>
+              </a:spcBef>
+              <a:spcAft>
+                <a:spcPts val="0"/>
+              </a:spcAft>
+            </a:pPr>
+            <a:r>
+              <a:rPr sz="1100" b="0">
+                <a:solidFill>
+                  <a:srgbClr val="35424F"/>
+                </a:solidFill>
+                <a:latin typeface="Microsoft YaHei"/>
+                <a:ea typeface="Microsoft YaHei"/>
+                <a:cs typeface="Microsoft YaHei"/>
+              </a:rPr>
+              <a:t>定目标、冻结验收口径</a:t>
+            </a:r>
+          </a:p>
+        </p:txBody>
+      </p:sp>
+      <p:sp>
+        <p:nvSpPr>
+          <p:cNvPr id="24" name="Oval 23"/>
+          <p:cNvSpPr/>
+          <p:nvPr/>
+        </p:nvSpPr>
+        <p:spPr>
+          <a:xfrm>
+            <a:off x="4557674" y="3346704"/>
+            <a:ext cx="91440" cy="91440"/>
+          </a:xfrm>
+          <a:prstGeom prst="ellipse">
+            <a:avLst/>
+          </a:prstGeom>
+          <a:solidFill>
+            <a:srgbClr val="C0612C"/>
+          </a:solidFill>
+          <a:ln>
+            <a:noFill/>
+          </a:ln>
+        </p:spPr>
+        <p:txBody>
+          <a:bodyPr rtlCol="0" anchor="ctr"/>
+          <a:lstStyle/>
+          <a:p>
+            <a:pPr algn="ctr"/>
+          </a:p>
+        </p:txBody>
+      </p:sp>
+      <p:sp>
+        <p:nvSpPr>
+          <p:cNvPr id="25" name="TextBox 24"/>
+          <p:cNvSpPr txBox="1"/>
+          <p:nvPr/>
+        </p:nvSpPr>
+        <p:spPr>
+          <a:xfrm>
+            <a:off x="4758842" y="3182112"/>
+            <a:ext cx="2875178" cy="457200"/>
+          </a:xfrm>
+          <a:prstGeom prst="rect">
+            <a:avLst/>
+          </a:prstGeom>
+          <a:noFill/>
+        </p:spPr>
+        <p:txBody>
+          <a:bodyPr wrap="square" anchor="ctr" lIns="0" tIns="0" rIns="0" bIns="0">
+            <a:noAutofit/>
+          </a:bodyPr>
+          <a:lstStyle/>
+          <a:p>
+            <a:pPr algn="l" latinLnBrk="0">
+              <a:lnSpc>
+                <a:spcPct val="100000"/>
+              </a:lnSpc>
+              <a:spcBef>
+                <a:spcPts val="0"/>
+              </a:spcBef>
+              <a:spcAft>
+                <a:spcPts val="0"/>
+              </a:spcAft>
+            </a:pPr>
+            <a:r>
+              <a:rPr sz="1100" b="0">
+                <a:solidFill>
+                  <a:srgbClr val="35424F"/>
+                </a:solidFill>
+                <a:latin typeface="Microsoft YaHei"/>
+                <a:ea typeface="Microsoft YaHei"/>
+                <a:cs typeface="Microsoft YaHei"/>
+              </a:rPr>
+              <a:t>新架构的接入判断</a:t>
+            </a:r>
+          </a:p>
+        </p:txBody>
+      </p:sp>
+      <p:sp>
+        <p:nvSpPr>
+          <p:cNvPr id="26" name="Oval 25"/>
+          <p:cNvSpPr/>
+          <p:nvPr/>
+        </p:nvSpPr>
+        <p:spPr>
+          <a:xfrm>
+            <a:off x="4557674" y="3803904"/>
+            <a:ext cx="91440" cy="91440"/>
+          </a:xfrm>
+          <a:prstGeom prst="ellipse">
+            <a:avLst/>
+          </a:prstGeom>
+          <a:solidFill>
+            <a:srgbClr val="C0612C"/>
+          </a:solidFill>
+          <a:ln>
+            <a:noFill/>
+          </a:ln>
+        </p:spPr>
+        <p:txBody>
+          <a:bodyPr rtlCol="0" anchor="ctr"/>
+          <a:lstStyle/>
+          <a:p>
+            <a:pPr algn="ctr"/>
+          </a:p>
+        </p:txBody>
+      </p:sp>
+      <p:sp>
+        <p:nvSpPr>
+          <p:cNvPr id="27" name="TextBox 26"/>
+          <p:cNvSpPr txBox="1"/>
+          <p:nvPr/>
+        </p:nvSpPr>
+        <p:spPr>
+          <a:xfrm>
+            <a:off x="4758842" y="3639312"/>
+            <a:ext cx="2875178" cy="457200"/>
+          </a:xfrm>
+          <a:prstGeom prst="rect">
+            <a:avLst/>
+          </a:prstGeom>
+          <a:noFill/>
+        </p:spPr>
+        <p:txBody>
+          <a:bodyPr wrap="square" anchor="ctr" lIns="0" tIns="0" rIns="0" bIns="0">
+            <a:noAutofit/>
+          </a:bodyPr>
+          <a:lstStyle/>
+          <a:p>
+            <a:pPr algn="l" latinLnBrk="0">
+              <a:lnSpc>
+                <a:spcPct val="100000"/>
+              </a:lnSpc>
+              <a:spcBef>
+                <a:spcPts val="0"/>
+              </a:spcBef>
+              <a:spcAft>
+                <a:spcPts val="0"/>
+              </a:spcAft>
+            </a:pPr>
+            <a:r>
+              <a:rPr sz="1100" b="0">
+                <a:solidFill>
+                  <a:srgbClr val="35424F"/>
+                </a:solidFill>
+                <a:latin typeface="Microsoft YaHei"/>
+                <a:ea typeface="Microsoft YaHei"/>
+                <a:cs typeface="Microsoft YaHei"/>
+              </a:rPr>
+              <a:t>未知缺陷的根因定位</a:t>
+            </a:r>
+          </a:p>
+        </p:txBody>
+      </p:sp>
+      <p:sp>
+        <p:nvSpPr>
+          <p:cNvPr id="28" name="Oval 27"/>
+          <p:cNvSpPr/>
+          <p:nvPr/>
+        </p:nvSpPr>
+        <p:spPr>
+          <a:xfrm>
+            <a:off x="4557674" y="4261104"/>
+            <a:ext cx="91440" cy="91440"/>
+          </a:xfrm>
+          <a:prstGeom prst="ellipse">
+            <a:avLst/>
+          </a:prstGeom>
+          <a:solidFill>
+            <a:srgbClr val="C0612C"/>
+          </a:solidFill>
+          <a:ln>
+            <a:noFill/>
+          </a:ln>
+        </p:spPr>
+        <p:txBody>
+          <a:bodyPr rtlCol="0" anchor="ctr"/>
+          <a:lstStyle/>
+          <a:p>
+            <a:pPr algn="ctr"/>
+          </a:p>
+        </p:txBody>
+      </p:sp>
+      <p:sp>
+        <p:nvSpPr>
+          <p:cNvPr id="29" name="TextBox 28"/>
+          <p:cNvSpPr txBox="1"/>
+          <p:nvPr/>
+        </p:nvSpPr>
+        <p:spPr>
+          <a:xfrm>
+            <a:off x="4758842" y="4096512"/>
+            <a:ext cx="2875178" cy="457200"/>
+          </a:xfrm>
+          <a:prstGeom prst="rect">
+            <a:avLst/>
+          </a:prstGeom>
+          <a:noFill/>
+        </p:spPr>
+        <p:txBody>
+          <a:bodyPr wrap="square" anchor="ctr" lIns="0" tIns="0" rIns="0" bIns="0">
+            <a:noAutofit/>
+          </a:bodyPr>
+          <a:lstStyle/>
+          <a:p>
+            <a:pPr algn="l" latinLnBrk="0">
+              <a:lnSpc>
+                <a:spcPct val="100000"/>
+              </a:lnSpc>
+              <a:spcBef>
+                <a:spcPts val="0"/>
+              </a:spcBef>
+              <a:spcAft>
+                <a:spcPts val="0"/>
+              </a:spcAft>
+            </a:pPr>
+            <a:r>
+              <a:rPr sz="1100" b="0">
+                <a:solidFill>
+                  <a:srgbClr val="35424F"/>
+                </a:solidFill>
+                <a:latin typeface="Microsoft YaHei"/>
+                <a:ea typeface="Microsoft YaHei"/>
+                <a:cs typeface="Microsoft YaHei"/>
+              </a:rPr>
+              <a:t>交付与否的最终决定</a:t>
+            </a:r>
+          </a:p>
+        </p:txBody>
+      </p:sp>
+      <p:sp>
+        <p:nvSpPr>
+          <p:cNvPr id="30" name="TextBox 29"/>
+          <p:cNvSpPr txBox="1"/>
+          <p:nvPr/>
+        </p:nvSpPr>
+        <p:spPr>
+          <a:xfrm>
+            <a:off x="4557674" y="4572000"/>
+            <a:ext cx="3076346" cy="310896"/>
+          </a:xfrm>
+          <a:prstGeom prst="rect">
+            <a:avLst/>
+          </a:prstGeom>
+          <a:noFill/>
+        </p:spPr>
+        <p:txBody>
+          <a:bodyPr wrap="square" anchor="ctr" lIns="0" tIns="0" rIns="0" bIns="0">
+            <a:noAutofit/>
+          </a:bodyPr>
+          <a:lstStyle/>
+          <a:p>
+            <a:pPr algn="l" latinLnBrk="0">
+              <a:lnSpc>
+                <a:spcPct val="100000"/>
+              </a:lnSpc>
+              <a:spcBef>
+                <a:spcPts val="0"/>
+              </a:spcBef>
+              <a:spcAft>
+                <a:spcPts val="0"/>
+              </a:spcAft>
+            </a:pPr>
+            <a:r>
+              <a:rPr sz="1000" b="0">
+                <a:solidFill>
+                  <a:srgbClr val="66727F"/>
+                </a:solidFill>
+                <a:latin typeface="Microsoft YaHei"/>
+                <a:ea typeface="Microsoft YaHei"/>
+                <a:cs typeface="Microsoft YaHei"/>
+              </a:rPr>
+              <a:t>这几项短期内不打算交出去</a:t>
+            </a:r>
+          </a:p>
+        </p:txBody>
+      </p:sp>
+      <p:sp>
+        <p:nvSpPr>
+          <p:cNvPr id="31" name="Rectangle 30"/>
+          <p:cNvSpPr/>
+          <p:nvPr/>
+        </p:nvSpPr>
+        <p:spPr>
+          <a:xfrm>
+            <a:off x="8127796" y="1828800"/>
+            <a:ext cx="3515258" cy="3200400"/>
+          </a:xfrm>
+          <a:prstGeom prst="rect">
+            <a:avLst/>
+          </a:prstGeom>
+          <a:solidFill>
+            <a:srgbClr val="FFFFFF"/>
+          </a:solidFill>
+          <a:ln w="9525">
+            <a:solidFill>
+              <a:srgbClr val="C5CCD4"/>
+            </a:solidFill>
+            <a:prstDash val="dash"/>
+          </a:ln>
+        </p:spPr>
+        <p:txBody>
+          <a:bodyPr rtlCol="0" anchor="ctr"/>
+          <a:lstStyle/>
+          <a:p>
+            <a:pPr algn="ctr"/>
+          </a:p>
+        </p:txBody>
+      </p:sp>
+      <p:sp>
+        <p:nvSpPr>
+          <p:cNvPr id="32" name="TextBox 31"/>
+          <p:cNvSpPr txBox="1"/>
+          <p:nvPr/>
+        </p:nvSpPr>
+        <p:spPr>
+          <a:xfrm>
+            <a:off x="8347252" y="2011680"/>
+            <a:ext cx="3076346" cy="329184"/>
+          </a:xfrm>
+          <a:prstGeom prst="rect">
+            <a:avLst/>
+          </a:prstGeom>
+          <a:noFill/>
+        </p:spPr>
+        <p:txBody>
+          <a:bodyPr wrap="square" anchor="ctr" lIns="0" tIns="0" rIns="0" bIns="0">
+            <a:noAutofit/>
+          </a:bodyPr>
+          <a:lstStyle/>
+          <a:p>
+            <a:pPr algn="l" latinLnBrk="0">
+              <a:lnSpc>
+                <a:spcPct val="100000"/>
+              </a:lnSpc>
+              <a:spcBef>
+                <a:spcPts val="0"/>
+              </a:spcBef>
+              <a:spcAft>
+                <a:spcPts val="0"/>
+              </a:spcAft>
+            </a:pPr>
+            <a:r>
+              <a:rPr sz="1500" b="1">
+                <a:solidFill>
+                  <a:srgbClr val="16202A"/>
+                </a:solidFill>
+                <a:latin typeface="Microsoft YaHei"/>
+                <a:ea typeface="Microsoft YaHei"/>
+                <a:cs typeface="Microsoft YaHei"/>
+              </a:rPr>
+              <a:t>下一步补齐</a:t>
+            </a:r>
+          </a:p>
+        </p:txBody>
+      </p:sp>
+      <p:sp>
+        <p:nvSpPr>
+          <p:cNvPr id="33" name="TextBox 32"/>
+          <p:cNvSpPr txBox="1"/>
+          <p:nvPr/>
+        </p:nvSpPr>
+        <p:spPr>
+          <a:xfrm>
+            <a:off x="8347252" y="2359152"/>
+            <a:ext cx="3076346" cy="237744"/>
+          </a:xfrm>
+          <a:prstGeom prst="rect">
+            <a:avLst/>
+          </a:prstGeom>
+          <a:noFill/>
+        </p:spPr>
+        <p:txBody>
+          <a:bodyPr wrap="square" anchor="ctr" lIns="0" tIns="0" rIns="0" bIns="0">
+            <a:noAutofit/>
+          </a:bodyPr>
+          <a:lstStyle/>
+          <a:p>
+            <a:pPr algn="l" latinLnBrk="0">
+              <a:lnSpc>
+                <a:spcPct val="100000"/>
+              </a:lnSpc>
+              <a:spcBef>
+                <a:spcPts val="0"/>
+              </a:spcBef>
+              <a:spcAft>
+                <a:spcPts val="0"/>
+              </a:spcAft>
+            </a:pPr>
+            <a:r>
+              <a:rPr sz="950" b="0">
+                <a:solidFill>
+                  <a:srgbClr val="66727F"/>
+                </a:solidFill>
+                <a:latin typeface="Consolas"/>
+                <a:ea typeface="Microsoft YaHei"/>
+                <a:cs typeface="Microsoft YaHei"/>
+              </a:rPr>
+              <a:t>第 7 - 8 页</a:t>
+            </a:r>
+          </a:p>
+        </p:txBody>
+      </p:sp>
+      <p:sp>
+        <p:nvSpPr>
+          <p:cNvPr id="34" name="Oval 33"/>
+          <p:cNvSpPr/>
+          <p:nvPr/>
+        </p:nvSpPr>
+        <p:spPr>
+          <a:xfrm>
+            <a:off x="8347252" y="2889504"/>
+            <a:ext cx="91440" cy="91440"/>
+          </a:xfrm>
+          <a:prstGeom prst="ellipse">
+            <a:avLst/>
+          </a:prstGeom>
+          <a:solidFill>
+            <a:srgbClr val="C0612C"/>
+          </a:solidFill>
+          <a:ln>
+            <a:noFill/>
+          </a:ln>
+        </p:spPr>
+        <p:txBody>
+          <a:bodyPr rtlCol="0" anchor="ctr"/>
+          <a:lstStyle/>
+          <a:p>
+            <a:pPr algn="ctr"/>
+          </a:p>
+        </p:txBody>
+      </p:sp>
+      <p:sp>
+        <p:nvSpPr>
+          <p:cNvPr id="35" name="TextBox 34"/>
+          <p:cNvSpPr txBox="1"/>
+          <p:nvPr/>
+        </p:nvSpPr>
+        <p:spPr>
+          <a:xfrm>
+            <a:off x="8548420" y="2724912"/>
+            <a:ext cx="2875178" cy="457200"/>
+          </a:xfrm>
+          <a:prstGeom prst="rect">
+            <a:avLst/>
+          </a:prstGeom>
+          <a:noFill/>
+        </p:spPr>
+        <p:txBody>
+          <a:bodyPr wrap="square" anchor="ctr" lIns="0" tIns="0" rIns="0" bIns="0">
+            <a:noAutofit/>
+          </a:bodyPr>
+          <a:lstStyle/>
+          <a:p>
+            <a:pPr algn="l" latinLnBrk="0">
+              <a:lnSpc>
+                <a:spcPct val="100000"/>
+              </a:lnSpc>
+              <a:spcBef>
+                <a:spcPts val="0"/>
+              </a:spcBef>
+              <a:spcAft>
+                <a:spcPts val="0"/>
+              </a:spcAft>
+            </a:pPr>
+            <a:r>
+              <a:rPr sz="1100" b="0">
+                <a:solidFill>
+                  <a:srgbClr val="35424F"/>
+                </a:solidFill>
+                <a:latin typeface="Microsoft YaHei"/>
+                <a:ea typeface="Microsoft YaHei"/>
+                <a:cs typeface="Microsoft YaHei"/>
+              </a:rPr>
+              <a:t>换算链在 M100 上校准</a:t>
+            </a:r>
+          </a:p>
+        </p:txBody>
+      </p:sp>
+      <p:sp>
+        <p:nvSpPr>
+          <p:cNvPr id="36" name="Oval 35"/>
+          <p:cNvSpPr/>
+          <p:nvPr/>
+        </p:nvSpPr>
+        <p:spPr>
+          <a:xfrm>
+            <a:off x="8347252" y="3346704"/>
+            <a:ext cx="91440" cy="91440"/>
+          </a:xfrm>
+          <a:prstGeom prst="ellipse">
+            <a:avLst/>
+          </a:prstGeom>
+          <a:solidFill>
+            <a:srgbClr val="C0612C"/>
+          </a:solidFill>
+          <a:ln>
+            <a:noFill/>
+          </a:ln>
+        </p:spPr>
+        <p:txBody>
+          <a:bodyPr rtlCol="0" anchor="ctr"/>
+          <a:lstStyle/>
+          <a:p>
+            <a:pPr algn="ctr"/>
+          </a:p>
+        </p:txBody>
+      </p:sp>
+      <p:sp>
+        <p:nvSpPr>
+          <p:cNvPr id="37" name="TextBox 36"/>
+          <p:cNvSpPr txBox="1"/>
+          <p:nvPr/>
+        </p:nvSpPr>
+        <p:spPr>
+          <a:xfrm>
+            <a:off x="8548420" y="3182112"/>
+            <a:ext cx="2875178" cy="457200"/>
+          </a:xfrm>
+          <a:prstGeom prst="rect">
+            <a:avLst/>
+          </a:prstGeom>
+          <a:noFill/>
+        </p:spPr>
+        <p:txBody>
+          <a:bodyPr wrap="square" anchor="ctr" lIns="0" tIns="0" rIns="0" bIns="0">
+            <a:noAutofit/>
+          </a:bodyPr>
+          <a:lstStyle/>
+          <a:p>
+            <a:pPr algn="l" latinLnBrk="0">
+              <a:lnSpc>
+                <a:spcPct val="100000"/>
+              </a:lnSpc>
+              <a:spcBef>
+                <a:spcPts val="0"/>
+              </a:spcBef>
+              <a:spcAft>
+                <a:spcPts val="0"/>
+              </a:spcAft>
+            </a:pPr>
+            <a:r>
+              <a:rPr sz="1100" b="0">
+                <a:solidFill>
+                  <a:srgbClr val="35424F"/>
+                </a:solidFill>
+                <a:latin typeface="Microsoft YaHei"/>
+                <a:ea typeface="Microsoft YaHei"/>
+                <a:cs typeface="Microsoft YaHei"/>
+              </a:rPr>
+              <a:t>模型层与算子层自动交接</a:t>
+            </a:r>
+          </a:p>
+        </p:txBody>
+      </p:sp>
+      <p:sp>
+        <p:nvSpPr>
+          <p:cNvPr id="38" name="Oval 37"/>
+          <p:cNvSpPr/>
+          <p:nvPr/>
+        </p:nvSpPr>
+        <p:spPr>
+          <a:xfrm>
+            <a:off x="8347252" y="3803904"/>
+            <a:ext cx="91440" cy="91440"/>
+          </a:xfrm>
+          <a:prstGeom prst="ellipse">
+            <a:avLst/>
+          </a:prstGeom>
+          <a:solidFill>
+            <a:srgbClr val="C0612C"/>
+          </a:solidFill>
+          <a:ln>
+            <a:noFill/>
+          </a:ln>
+        </p:spPr>
+        <p:txBody>
+          <a:bodyPr rtlCol="0" anchor="ctr"/>
+          <a:lstStyle/>
+          <a:p>
+            <a:pPr algn="ctr"/>
+          </a:p>
+        </p:txBody>
+      </p:sp>
+      <p:sp>
+        <p:nvSpPr>
+          <p:cNvPr id="39" name="TextBox 38"/>
+          <p:cNvSpPr txBox="1"/>
+          <p:nvPr/>
+        </p:nvSpPr>
+        <p:spPr>
+          <a:xfrm>
+            <a:off x="8548420" y="3639312"/>
+            <a:ext cx="2875178" cy="457200"/>
+          </a:xfrm>
+          <a:prstGeom prst="rect">
+            <a:avLst/>
+          </a:prstGeom>
+          <a:noFill/>
+        </p:spPr>
+        <p:txBody>
+          <a:bodyPr wrap="square" anchor="ctr" lIns="0" tIns="0" rIns="0" bIns="0">
+            <a:noAutofit/>
+          </a:bodyPr>
+          <a:lstStyle/>
+          <a:p>
+            <a:pPr algn="l" latinLnBrk="0">
+              <a:lnSpc>
+                <a:spcPct val="100000"/>
+              </a:lnSpc>
+              <a:spcBef>
+                <a:spcPts val="0"/>
+              </a:spcBef>
+              <a:spcAft>
+                <a:spcPts val="0"/>
+              </a:spcAft>
+            </a:pPr>
+            <a:r>
+              <a:rPr sz="1100" b="0">
+                <a:solidFill>
+                  <a:srgbClr val="35424F"/>
+                </a:solidFill>
+                <a:latin typeface="Microsoft YaHei"/>
+                <a:ea typeface="Microsoft YaHei"/>
+                <a:cs typeface="Microsoft YaHei"/>
+              </a:rPr>
+              <a:t>规则与补丁沉淀为可复用知识</a:t>
+            </a:r>
+          </a:p>
+        </p:txBody>
+      </p:sp>
+      <p:sp>
+        <p:nvSpPr>
+          <p:cNvPr id="40" name="Oval 39"/>
+          <p:cNvSpPr/>
+          <p:nvPr/>
+        </p:nvSpPr>
+        <p:spPr>
+          <a:xfrm>
+            <a:off x="8347252" y="4261104"/>
+            <a:ext cx="91440" cy="91440"/>
+          </a:xfrm>
+          <a:prstGeom prst="ellipse">
+            <a:avLst/>
+          </a:prstGeom>
+          <a:solidFill>
+            <a:srgbClr val="C0612C"/>
+          </a:solidFill>
+          <a:ln>
+            <a:noFill/>
+          </a:ln>
+        </p:spPr>
+        <p:txBody>
+          <a:bodyPr rtlCol="0" anchor="ctr"/>
+          <a:lstStyle/>
+          <a:p>
+            <a:pPr algn="ctr"/>
+          </a:p>
+        </p:txBody>
+      </p:sp>
+      <p:sp>
+        <p:nvSpPr>
+          <p:cNvPr id="41" name="TextBox 40"/>
+          <p:cNvSpPr txBox="1"/>
+          <p:nvPr/>
+        </p:nvSpPr>
+        <p:spPr>
+          <a:xfrm>
+            <a:off x="8548420" y="4096512"/>
+            <a:ext cx="2875178" cy="457200"/>
+          </a:xfrm>
+          <a:prstGeom prst="rect">
+            <a:avLst/>
+          </a:prstGeom>
+          <a:noFill/>
+        </p:spPr>
+        <p:txBody>
+          <a:bodyPr wrap="square" anchor="ctr" lIns="0" tIns="0" rIns="0" bIns="0">
+            <a:noAutofit/>
+          </a:bodyPr>
+          <a:lstStyle/>
+          <a:p>
+            <a:pPr algn="l" latinLnBrk="0">
+              <a:lnSpc>
+                <a:spcPct val="100000"/>
+              </a:lnSpc>
+              <a:spcBef>
+                <a:spcPts val="0"/>
+              </a:spcBef>
+              <a:spcAft>
+                <a:spcPts val="0"/>
+              </a:spcAft>
+            </a:pPr>
+            <a:r>
+              <a:rPr sz="1100" b="0">
+                <a:solidFill>
+                  <a:srgbClr val="35424F"/>
+                </a:solidFill>
+                <a:latin typeface="Microsoft YaHei"/>
+                <a:ea typeface="Microsoft YaHei"/>
+                <a:cs typeface="Microsoft YaHei"/>
+              </a:rPr>
+              <a:t>适配成本的量化对账</a:t>
+            </a:r>
+          </a:p>
+        </p:txBody>
+      </p:sp>
+      <p:sp>
+        <p:nvSpPr>
+          <p:cNvPr id="42" name="TextBox 41"/>
+          <p:cNvSpPr txBox="1"/>
+          <p:nvPr/>
+        </p:nvSpPr>
+        <p:spPr>
+          <a:xfrm>
+            <a:off x="8347252" y="4572000"/>
+            <a:ext cx="3076346" cy="310896"/>
+          </a:xfrm>
+          <a:prstGeom prst="rect">
+            <a:avLst/>
+          </a:prstGeom>
+          <a:noFill/>
+        </p:spPr>
+        <p:txBody>
+          <a:bodyPr wrap="square" anchor="ctr" lIns="0" tIns="0" rIns="0" bIns="0">
+            <a:noAutofit/>
+          </a:bodyPr>
+          <a:lstStyle/>
+          <a:p>
+            <a:pPr algn="l" latinLnBrk="0">
+              <a:lnSpc>
+                <a:spcPct val="100000"/>
+              </a:lnSpc>
+              <a:spcBef>
+                <a:spcPts val="0"/>
+              </a:spcBef>
+              <a:spcAft>
+                <a:spcPts val="0"/>
+              </a:spcAft>
+            </a:pPr>
+            <a:r>
+              <a:rPr sz="1000" b="0">
+                <a:solidFill>
+                  <a:srgbClr val="66727F"/>
+                </a:solidFill>
+                <a:latin typeface="Microsoft YaHei"/>
+                <a:ea typeface="Microsoft YaHei"/>
+                <a:cs typeface="Microsoft YaHei"/>
+              </a:rPr>
+              <a:t>按这个顺序做，先校准再谈预测</a:t>
+            </a:r>
+          </a:p>
+        </p:txBody>
+      </p:sp>
+      <p:sp>
+        <p:nvSpPr>
+          <p:cNvPr id="43" name="Rectangle 42"/>
+          <p:cNvSpPr/>
+          <p:nvPr/>
+        </p:nvSpPr>
+        <p:spPr>
+          <a:xfrm>
+            <a:off x="548640" y="5230368"/>
+            <a:ext cx="11094415" cy="566928"/>
+          </a:xfrm>
+          <a:prstGeom prst="rect">
+            <a:avLst/>
+          </a:prstGeom>
+          <a:solidFill>
+            <a:srgbClr val="F8EADF"/>
+          </a:solidFill>
+          <a:ln>
+            <a:noFill/>
+          </a:ln>
+        </p:spPr>
+        <p:txBody>
+          <a:bodyPr rtlCol="0" anchor="ctr"/>
+          <a:lstStyle/>
+          <a:p>
+            <a:pPr algn="ctr"/>
+          </a:p>
+        </p:txBody>
+      </p:sp>
+      <p:sp>
+        <p:nvSpPr>
+          <p:cNvPr id="44" name="Rectangle 43"/>
+          <p:cNvSpPr/>
+          <p:nvPr/>
+        </p:nvSpPr>
+        <p:spPr>
+          <a:xfrm>
+            <a:off x="548640" y="5230368"/>
+            <a:ext cx="64008" cy="566928"/>
+          </a:xfrm>
+          <a:prstGeom prst="rect">
+            <a:avLst/>
+          </a:prstGeom>
+          <a:solidFill>
+            <a:srgbClr val="C0612C"/>
+          </a:solidFill>
+          <a:ln>
+            <a:noFill/>
+          </a:ln>
+        </p:spPr>
+        <p:txBody>
+          <a:bodyPr rtlCol="0" anchor="ctr"/>
+          <a:lstStyle/>
+          <a:p>
+            <a:pPr algn="ctr"/>
+          </a:p>
+        </p:txBody>
+      </p:sp>
+      <p:sp>
+        <p:nvSpPr>
+          <p:cNvPr id="45" name="TextBox 44"/>
+          <p:cNvSpPr txBox="1"/>
+          <p:nvPr/>
+        </p:nvSpPr>
+        <p:spPr>
+          <a:xfrm>
+            <a:off x="859536" y="5230368"/>
+            <a:ext cx="10454335" cy="566928"/>
+          </a:xfrm>
+          <a:prstGeom prst="rect">
+            <a:avLst/>
+          </a:prstGeom>
+          <a:noFill/>
+        </p:spPr>
+        <p:txBody>
+          <a:bodyPr wrap="square" anchor="ctr" lIns="0" tIns="0" rIns="0" bIns="0">
+            <a:noAutofit/>
+          </a:bodyPr>
+          <a:lstStyle/>
+          <a:p>
+            <a:pPr algn="l" latinLnBrk="0">
+              <a:lnSpc>
+                <a:spcPct val="100000"/>
+              </a:lnSpc>
+              <a:spcBef>
+                <a:spcPts val="0"/>
+              </a:spcBef>
+              <a:spcAft>
+                <a:spcPts val="0"/>
+              </a:spcAft>
+            </a:pPr>
+            <a:r>
+              <a:rPr sz="1200" b="1">
+                <a:solidFill>
+                  <a:srgbClr val="C0612C"/>
+                </a:solidFill>
+                <a:latin typeface="Consolas"/>
+                <a:ea typeface="Microsoft YaHei"/>
+                <a:cs typeface="Microsoft YaHei"/>
+              </a:rPr>
+              <a:t>命题　</a:t>
+            </a:r>
+            <a:r>
+              <a:rPr sz="1600" b="1">
+                <a:solidFill>
+                  <a:srgbClr val="16202A"/>
+                </a:solidFill>
+                <a:latin typeface="Microsoft YaHei"/>
+                <a:ea typeface="Microsoft YaHei"/>
+                <a:cs typeface="Microsoft YaHei"/>
+              </a:rPr>
+              <a:t>把重复判断交给 Agent，一个模型一个模型往下压</a:t>
+            </a:r>
+          </a:p>
+        </p:txBody>
+      </p:sp>
+      <p:sp>
+        <p:nvSpPr>
+          <p:cNvPr id="46" name="TextBox 45"/>
+          <p:cNvSpPr txBox="1"/>
+          <p:nvPr/>
+        </p:nvSpPr>
+        <p:spPr>
+          <a:xfrm>
+            <a:off x="548640" y="6382512"/>
+            <a:ext cx="9722815" cy="256032"/>
+          </a:xfrm>
+          <a:prstGeom prst="rect">
+            <a:avLst/>
+          </a:prstGeom>
+          <a:noFill/>
+        </p:spPr>
+        <p:txBody>
+          <a:bodyPr wrap="square" anchor="ctr" lIns="0" tIns="0" rIns="0" bIns="0">
+            <a:noAutofit/>
+          </a:bodyPr>
+          <a:lstStyle/>
+          <a:p>
+            <a:pPr algn="l" latinLnBrk="0">
+              <a:lnSpc>
+                <a:spcPct val="100000"/>
+              </a:lnSpc>
+              <a:spcBef>
+                <a:spcPts val="0"/>
+              </a:spcBef>
+              <a:spcAft>
+                <a:spcPts val="0"/>
+              </a:spcAft>
+            </a:pPr>
+            <a:r>
+              <a:rPr sz="1000" b="0">
+                <a:solidFill>
+                  <a:srgbClr val="66727F"/>
+                </a:solidFill>
+                <a:latin typeface="Microsoft YaHei"/>
+                <a:ea typeface="Microsoft YaHei"/>
+                <a:cs typeface="Microsoft YaHei"/>
+              </a:rPr>
+              <a:t>三列按当前进度如实分栏；左列已在 M100 上跑通，右列尚未开始</a:t>
+            </a:r>
+          </a:p>
+        </p:txBody>
+      </p:sp>
+      <p:sp>
+        <p:nvSpPr>
+          <p:cNvPr id="47" name="TextBox 46"/>
+          <p:cNvSpPr txBox="1"/>
+          <p:nvPr/>
+        </p:nvSpPr>
+        <p:spPr>
+          <a:xfrm>
+            <a:off x="10362895" y="6382512"/>
+            <a:ext cx="1280160" cy="256032"/>
+          </a:xfrm>
+          <a:prstGeom prst="rect">
+            <a:avLst/>
+          </a:prstGeom>
+          <a:noFill/>
+        </p:spPr>
+        <p:txBody>
+          <a:bodyPr wrap="square" anchor="ctr" lIns="0" tIns="0" rIns="0" bIns="0">
+            <a:noAutofit/>
+          </a:bodyPr>
+          <a:lstStyle/>
+          <a:p>
+            <a:pPr algn="r" latinLnBrk="0">
+              <a:lnSpc>
+                <a:spcPct val="100000"/>
+              </a:lnSpc>
+              <a:spcBef>
+                <a:spcPts val="0"/>
+              </a:spcBef>
+              <a:spcAft>
+                <a:spcPts val="0"/>
+              </a:spcAft>
+            </a:pPr>
+            <a:r>
+              <a:rPr sz="1000" b="0">
+                <a:solidFill>
+                  <a:srgbClr val="66727F"/>
+                </a:solidFill>
+                <a:latin typeface="Consolas"/>
+                <a:ea typeface="Microsoft YaHei"/>
+                <a:cs typeface="Microsoft YaHei"/>
+              </a:rPr>
+              <a:t>9 / 9</a:t>
             </a:r>
           </a:p>
         </p:txBody>

</xml_diff>

<commit_message>
slides: keep the two decks reading from the same page-7 script
The themed deck tightened that page after the block was first written -- the five
change rounds are pointed at rather than read out, which brings the page back to
3:15. The white deck was still carrying the longer first draft. Both now hold the
same paragraphs, so the only remaining difference between the two copies of this
page is the three lines that bind its colours.
</commit_message>
<xml_diff>
--- a/slides/m100_agent_deck.pptx
+++ b/slides/m100_agent_deck.pptx
@@ -2239,7 +2239,7 @@
                 <a:ea typeface="Microsoft YaHei"/>
                 <a:cs typeface="Microsoft YaHei"/>
               </a:rPr>
-              <a:t>【7 / 10 · 算子层 · batch_norm 迭代记录 · 约 200 秒（3:20）】</a:t>
+              <a:t>【7 / 10 · 算子层 · batch_norm 迭代记录 · 约 195 秒（3:15）】</a:t>
             </a:r>
           </a:p>
           <a:p>
@@ -2311,7 +2311,7 @@
                 <a:ea typeface="Microsoft YaHei"/>
                 <a:cs typeface="Microsoft YaHei"/>
               </a:rPr>
-              <a:t>然后是五轮改动。第 2 轮换成原生 rsqrt 指令，13.24 降到 11.72，0.532 升到 0.601，保留。第 3 轮想用 shared 广播系数，加了同步，结果更慢，15.06 微秒，当场丢弃。第 4 轮想把系数挪到 host 侧折好，但每次要 H2D 上传 2KB，光传输就 17.6 微秒，比 kernel 还贵，也丢弃。第 5 轮修了 copy 路径上的寄存器 spill，9.81 微秒，achieved 0.719——已经贴到地板上了。第 6 轮把折叠做成 scale 乘 x 加 shift，9.82，持平，作为交付默认。</a:t>
+              <a:t>右边是五轮改动，表上都有，我只点两处。第 3 轮想用 shared 广播系数，加了同步之后反而更慢，15.06 微秒，当场丢弃；第 4 轮想把系数挪到 host 侧折好，但每次要 H2D 上传 2KB，光传输就 17.6 微秒，比 kernel 本身还贵，也丢弃——注意这一轮丢的理由是整体变慢，不是 kernel 变慢。</a:t>
             </a:r>
           </a:p>
           <a:p>
@@ -2329,7 +2329,7 @@
                 <a:ea typeface="Microsoft YaHei"/>
                 <a:cs typeface="Microsoft YaHei"/>
               </a:rPr>
-              <a:t>第 7、8 轮没有性能变化，是补模拟器消融脚手架和修 ABI，属于基础设施。交付前在空闲卡上复测两百次，9.66 微秒，achieved 0.730。</a:t>
+              <a:t>真正有效的是第 2、5、6 轮：换原生 rsqrt 指令到 0.601，修 copy 路径的寄存器 spill 到 0.719，再把折叠做成 scale 乘 x 加 shift 持平交付。第 7、8 轮是补脚手架和修 ABI，没有性能变化。交付前在空闲卡上复测两百次，9.66 微秒，achieved 0.730。</a:t>
             </a:r>
           </a:p>
           <a:p>
@@ -2347,7 +2347,7 @@
                 <a:ea typeface="Microsoft YaHei"/>
                 <a:cs typeface="Microsoft YaHei"/>
               </a:rPr>
-              <a:t>两件事值得强调。第一，八轮里只有三轮带来收益，两轮被真机测量当场否掉——这和第 5 页模型层的做法是同一套：判定不听模型解释，只看测量。第二，现在已经打在拷贝地板上，再怎么优化计算都不会有收益，要再快只能换访存方式。</a:t>
+              <a:t>两件事值得强调。第一，八轮里只有三轮带来收益，两轮被真机测量当场否掉——这和第 5 页模型层是同一套做法：判定不听模型解释，只看测量。第二，现在已经打在拷贝地板上，再怎么优化计算都不会有收益，要再快只能换访存方式。</a:t>
             </a:r>
           </a:p>
           <a:p>

</xml_diff>

<commit_message>
slides: point the stack page at both operator pages
The software-stack page sends the reader to "第 6 页" for the operator-layer work.
That was right when the operator section was one page; it now runs 6 to 7, with
the batch_norm record on the second. The arrow on the page and the matching
sentence in the script both say 第 6、7 页.
</commit_message>
<xml_diff>
--- a/slides/m100_agent_deck.pptx
+++ b/slides/m100_agent_deck.pptx
@@ -1050,7 +1050,7 @@
                 <a:ea typeface="Microsoft YaHei"/>
                 <a:cs typeface="Microsoft YaHei"/>
               </a:rPr>
-              <a:t>下面一框是算子层：XCN_ATEN_OPS。这一层补齐算子缺口、生成与调优实现、再用真机验证收益，第 6 页展开。</a:t>
+              <a:t>下面一框是算子层：XCN_ATEN_OPS。这一层补齐算子缺口、生成与调优实现、再用真机验证收益，第 6、7 页展开。</a:t>
             </a:r>
           </a:p>
           <a:p>
@@ -10373,7 +10373,7 @@
                 <a:ea typeface="Microsoft YaHei"/>
                 <a:cs typeface="Microsoft YaHei"/>
               </a:rPr>
-              <a:t>　→　第 6 页展开</a:t>
+              <a:t>　→　第 6、7 页展开</a:t>
             </a:r>
           </a:p>
         </p:txBody>

</xml_diff>

<commit_message>
slides: fill the gate page's reserved figure with the real verdicts
The left half of page 5 says how a candidate is judged; the right half
was a placeholder. Put the 30B-A3B run's actual verdicts there: five
groups in, what each gate stopped and on what evidence, the two that
passed all three, and the resulting peak throughput.

The numerical gate stopped one mode inside a candidate rather than a
whole candidate, so its tally is counted in modes and the group
arithmetic still reads five in, three stopped, two delivered. The
quality gate stopped nothing this round, which the panel states rather
than hides: everything that cleared the numerical gate was bit-identical.

Rules this makes concrete and the model-layer page should follow: the
routing fusion is recorded here as failing the performance gate, since
its ceiling of 0.9% cannot reach the 3% threshold.

Page 5's speaker note now walks the panel instead of the empty slot.
</commit_message>
<xml_diff>
--- a/slides/m100_agent_deck.pptx
+++ b/slides/m100_agent_deck.pptx
@@ -1731,7 +1731,7 @@
                 <a:ea typeface="Microsoft YaHei"/>
                 <a:cs typeface="Microsoft YaHei"/>
               </a:rPr>
-              <a:t>【5 / 10 · 模型层 · 候选验收与可信度 · 约 135 秒（2:15）】</a:t>
+              <a:t>【5 / 10 · 模型层 · 候选验收与可信度 · 约 185 秒（3:05）】</a:t>
             </a:r>
           </a:p>
           <a:p>
@@ -1821,7 +1821,7 @@
                 <a:ea typeface="Microsoft YaHei"/>
                 <a:cs typeface="Microsoft YaHei"/>
               </a:rPr>
-              <a:t>右边放这条流水线判出来的实际结果。最后一条口径：只有独立复验通过的收益才进入最终交付，筛选阶段看起来有收益、复验没过的，一个都不算。</a:t>
+              <a:t>右边是这条流水线在 30B-A3B 上判出来的实际结果。五组候选送进去：第一道挡掉一个模式——分组关掉之后 cos 直接是 0，算出来就是错的；第二道这一轮没拦下任何一个，因为过了第一道的候选输出逐位一致，不必再看质量；第三道挡掉三组——强制不分组慢 20%，换现成核只有 0.61 倍更慢，路由融合算到头也只值 0.9%，够不着 3% 的门槛。三道全过的两组交付，峰值吞吐从 1370 涨到 1883。最后一条口径：只有独立复验通过的收益才进入最终交付，筛选阶段看起来有收益、复验没过的，一个都不算。</a:t>
             </a:r>
           </a:p>
           <a:p>
@@ -16935,15 +16935,188 @@
           <a:solidFill>
             <a:srgbClr val="F6F7F9"/>
           </a:solidFill>
+          <a:ln>
+            <a:noFill/>
+          </a:ln>
+        </p:spPr>
+        <p:txBody>
+          <a:bodyPr rtlCol="0" anchor="ctr"/>
+          <a:lstStyle/>
+          <a:p>
+            <a:pPr algn="ctr"/>
+          </a:p>
+        </p:txBody>
+      </p:sp>
+      <p:sp>
+        <p:nvSpPr>
+          <p:cNvPr id="32" name="TextBox 31"/>
+          <p:cNvSpPr txBox="1"/>
+          <p:nvPr/>
+        </p:nvSpPr>
+        <p:spPr>
+          <a:xfrm>
+            <a:off x="7272223" y="1773936"/>
+            <a:ext cx="4169663" cy="256032"/>
+          </a:xfrm>
+          <a:prstGeom prst="rect">
+            <a:avLst/>
+          </a:prstGeom>
+          <a:noFill/>
+        </p:spPr>
+        <p:txBody>
+          <a:bodyPr wrap="square" anchor="ctr" lIns="0" tIns="0" rIns="0" bIns="0">
+            <a:noAutofit/>
+          </a:bodyPr>
+          <a:lstStyle/>
+          <a:p>
+            <a:pPr algn="l" latinLnBrk="0">
+              <a:lnSpc>
+                <a:spcPct val="100000"/>
+              </a:lnSpc>
+              <a:spcBef>
+                <a:spcPts val="0"/>
+              </a:spcBef>
+              <a:spcAft>
+                <a:spcPts val="0"/>
+              </a:spcAft>
+            </a:pPr>
+            <a:r>
+              <a:rPr sz="1250" b="1">
+                <a:solidFill>
+                  <a:srgbClr val="16202A"/>
+                </a:solidFill>
+                <a:latin typeface="Microsoft YaHei"/>
+                <a:ea typeface="Microsoft YaHei"/>
+                <a:cs typeface="Microsoft YaHei"/>
+              </a:rPr>
+              <a:t>本轮实际判定</a:t>
+            </a:r>
+            <a:r>
+              <a:rPr sz="1000" b="0">
+                <a:solidFill>
+                  <a:srgbClr val="66727F"/>
+                </a:solidFill>
+                <a:latin typeface="Microsoft YaHei"/>
+                <a:ea typeface="Microsoft YaHei"/>
+                <a:cs typeface="Microsoft YaHei"/>
+              </a:rPr>
+              <a:t>　30B-A3B 单卡</a:t>
+            </a:r>
+          </a:p>
+        </p:txBody>
+      </p:sp>
+      <p:sp>
+        <p:nvSpPr>
+          <p:cNvPr id="33" name="Rectangle 32"/>
+          <p:cNvSpPr/>
+          <p:nvPr/>
+        </p:nvSpPr>
+        <p:spPr>
+          <a:xfrm>
+            <a:off x="7272223" y="2066543"/>
+            <a:ext cx="4169663" cy="292608"/>
+          </a:xfrm>
+          <a:prstGeom prst="rect">
+            <a:avLst/>
+          </a:prstGeom>
+          <a:solidFill>
+            <a:srgbClr val="FFFFFF"/>
+          </a:solidFill>
           <a:ln w="9525">
             <a:solidFill>
-              <a:srgbClr val="C5CCD4"/>
+              <a:srgbClr val="DDE2E7"/>
             </a:solidFill>
-            <a:prstDash val="dash"/>
           </a:ln>
         </p:spPr>
         <p:txBody>
-          <a:bodyPr rtlCol="0" anchor="ctr" wrap="square" tIns="36576" bIns="36576">
+          <a:bodyPr rtlCol="0" anchor="ctr"/>
+          <a:lstStyle/>
+          <a:p>
+            <a:pPr algn="ctr"/>
+          </a:p>
+        </p:txBody>
+      </p:sp>
+      <p:sp>
+        <p:nvSpPr>
+          <p:cNvPr id="34" name="TextBox 33"/>
+          <p:cNvSpPr txBox="1"/>
+          <p:nvPr/>
+        </p:nvSpPr>
+        <p:spPr>
+          <a:xfrm>
+            <a:off x="7436815" y="2066543"/>
+            <a:ext cx="3840480" cy="292608"/>
+          </a:xfrm>
+          <a:prstGeom prst="rect">
+            <a:avLst/>
+          </a:prstGeom>
+          <a:noFill/>
+        </p:spPr>
+        <p:txBody>
+          <a:bodyPr wrap="square" anchor="ctr" lIns="0" tIns="0" rIns="0" bIns="0">
+            <a:noAutofit/>
+          </a:bodyPr>
+          <a:lstStyle/>
+          <a:p>
+            <a:pPr algn="l" latinLnBrk="0">
+              <a:lnSpc>
+                <a:spcPct val="100000"/>
+              </a:lnSpc>
+              <a:spcBef>
+                <a:spcPts val="0"/>
+              </a:spcBef>
+              <a:spcAft>
+                <a:spcPts val="0"/>
+              </a:spcAft>
+            </a:pPr>
+            <a:r>
+              <a:rPr sz="1100" b="1">
+                <a:solidFill>
+                  <a:srgbClr val="16202A"/>
+                </a:solidFill>
+                <a:latin typeface="Microsoft YaHei"/>
+                <a:ea typeface="Microsoft YaHei"/>
+                <a:cs typeface="Microsoft YaHei"/>
+              </a:rPr>
+              <a:t>送进验收</a:t>
+            </a:r>
+            <a:r>
+              <a:rPr sz="1000" b="0">
+                <a:solidFill>
+                  <a:srgbClr val="66727F"/>
+                </a:solidFill>
+                <a:latin typeface="Microsoft YaHei"/>
+                <a:ea typeface="Microsoft YaHei"/>
+                <a:cs typeface="Microsoft YaHei"/>
+              </a:rPr>
+              <a:t>　五组候选，由便宜到贵逐道验</a:t>
+            </a:r>
+          </a:p>
+        </p:txBody>
+      </p:sp>
+      <p:sp>
+        <p:nvSpPr>
+          <p:cNvPr id="35" name="Oval 34"/>
+          <p:cNvSpPr/>
+          <p:nvPr/>
+        </p:nvSpPr>
+        <p:spPr>
+          <a:xfrm>
+            <a:off x="7308799" y="2459736"/>
+            <a:ext cx="274320" cy="274320"/>
+          </a:xfrm>
+          <a:prstGeom prst="ellipse">
+            <a:avLst/>
+          </a:prstGeom>
+          <a:solidFill>
+            <a:srgbClr val="C0612C"/>
+          </a:solidFill>
+          <a:ln>
+            <a:noFill/>
+          </a:ln>
+        </p:spPr>
+        <p:txBody>
+          <a:bodyPr rtlCol="0" anchor="ctr" wrap="square" lIns="0" tIns="0" rIns="0" bIns="0">
             <a:noAutofit/>
           </a:bodyPr>
           <a:lstStyle/>
@@ -16960,7 +17133,294 @@
               </a:spcAft>
             </a:pPr>
             <a:r>
-              <a:rPr sz="1300" b="1">
+              <a:rPr sz="1100" b="1">
+                <a:solidFill>
+                  <a:srgbClr val="FFFFFF"/>
+                </a:solidFill>
+                <a:latin typeface="Arial"/>
+                <a:ea typeface="Microsoft YaHei"/>
+                <a:cs typeface="Microsoft YaHei"/>
+              </a:rPr>
+              <a:t>①</a:t>
+            </a:r>
+          </a:p>
+        </p:txBody>
+      </p:sp>
+      <p:sp>
+        <p:nvSpPr>
+          <p:cNvPr id="36" name="TextBox 35"/>
+          <p:cNvSpPr txBox="1"/>
+          <p:nvPr/>
+        </p:nvSpPr>
+        <p:spPr>
+          <a:xfrm>
+            <a:off x="7674559" y="2432304"/>
+            <a:ext cx="1188720" cy="256032"/>
+          </a:xfrm>
+          <a:prstGeom prst="rect">
+            <a:avLst/>
+          </a:prstGeom>
+          <a:noFill/>
+        </p:spPr>
+        <p:txBody>
+          <a:bodyPr wrap="square" anchor="ctr" lIns="0" tIns="0" rIns="0" bIns="0">
+            <a:noAutofit/>
+          </a:bodyPr>
+          <a:lstStyle/>
+          <a:p>
+            <a:pPr algn="l" latinLnBrk="0">
+              <a:lnSpc>
+                <a:spcPct val="100000"/>
+              </a:lnSpc>
+              <a:spcBef>
+                <a:spcPts val="0"/>
+              </a:spcBef>
+              <a:spcAft>
+                <a:spcPts val="0"/>
+              </a:spcAft>
+            </a:pPr>
+            <a:r>
+              <a:rPr sz="1150" b="1">
+                <a:solidFill>
+                  <a:srgbClr val="16202A"/>
+                </a:solidFill>
+                <a:latin typeface="Microsoft YaHei"/>
+                <a:ea typeface="Microsoft YaHei"/>
+                <a:cs typeface="Microsoft YaHei"/>
+              </a:rPr>
+              <a:t>输出未变</a:t>
+            </a:r>
+          </a:p>
+        </p:txBody>
+      </p:sp>
+      <p:sp>
+        <p:nvSpPr>
+          <p:cNvPr id="37" name="TextBox 36"/>
+          <p:cNvSpPr txBox="1"/>
+          <p:nvPr/>
+        </p:nvSpPr>
+        <p:spPr>
+          <a:xfrm>
+            <a:off x="10070287" y="2432304"/>
+            <a:ext cx="1371600" cy="256032"/>
+          </a:xfrm>
+          <a:prstGeom prst="rect">
+            <a:avLst/>
+          </a:prstGeom>
+          <a:noFill/>
+        </p:spPr>
+        <p:txBody>
+          <a:bodyPr wrap="square" anchor="ctr" lIns="0" tIns="0" rIns="0" bIns="0">
+            <a:noAutofit/>
+          </a:bodyPr>
+          <a:lstStyle/>
+          <a:p>
+            <a:pPr algn="r" latinLnBrk="0">
+              <a:lnSpc>
+                <a:spcPct val="100000"/>
+              </a:lnSpc>
+              <a:spcBef>
+                <a:spcPts val="0"/>
+              </a:spcBef>
+              <a:spcAft>
+                <a:spcPts val="0"/>
+              </a:spcAft>
+            </a:pPr>
+            <a:r>
+              <a:rPr sz="1100" b="1">
+                <a:solidFill>
+                  <a:srgbClr val="B4382F"/>
+                </a:solidFill>
+                <a:latin typeface="Microsoft YaHei"/>
+                <a:ea typeface="Microsoft YaHei"/>
+                <a:cs typeface="Microsoft YaHei"/>
+              </a:rPr>
+              <a:t>挡掉 1 个模式</a:t>
+            </a:r>
+          </a:p>
+        </p:txBody>
+      </p:sp>
+      <p:sp>
+        <p:nvSpPr>
+          <p:cNvPr id="38" name="TextBox 37"/>
+          <p:cNvSpPr txBox="1"/>
+          <p:nvPr/>
+        </p:nvSpPr>
+        <p:spPr>
+          <a:xfrm>
+            <a:off x="7674559" y="2688336"/>
+            <a:ext cx="3767328" cy="365760"/>
+          </a:xfrm>
+          <a:prstGeom prst="rect">
+            <a:avLst/>
+          </a:prstGeom>
+          <a:noFill/>
+        </p:spPr>
+        <p:txBody>
+          <a:bodyPr wrap="square" anchor="ctr" lIns="0" tIns="0" rIns="0" bIns="0">
+            <a:noAutofit/>
+          </a:bodyPr>
+          <a:lstStyle/>
+          <a:p>
+            <a:pPr algn="l" latinLnBrk="0">
+              <a:lnSpc>
+                <a:spcPct val="100000"/>
+              </a:lnSpc>
+              <a:spcBef>
+                <a:spcPts val="0"/>
+              </a:spcBef>
+              <a:spcAft>
+                <a:spcPts val="0"/>
+              </a:spcAft>
+            </a:pPr>
+            <a:r>
+              <a:rPr sz="1000" b="0">
+                <a:solidFill>
+                  <a:srgbClr val="35424F"/>
+                </a:solidFill>
+                <a:latin typeface="Microsoft YaHei"/>
+                <a:ea typeface="Microsoft YaHei"/>
+                <a:cs typeface="Microsoft YaHei"/>
+              </a:rPr>
+              <a:t>分组关掉后 cos 0.000，算出来直接是错的</a:t>
+            </a:r>
+          </a:p>
+        </p:txBody>
+      </p:sp>
+      <p:sp>
+        <p:nvSpPr>
+          <p:cNvPr id="39" name="Oval 38"/>
+          <p:cNvSpPr/>
+          <p:nvPr/>
+        </p:nvSpPr>
+        <p:spPr>
+          <a:xfrm>
+            <a:off x="7308799" y="3118103"/>
+            <a:ext cx="274320" cy="274320"/>
+          </a:xfrm>
+          <a:prstGeom prst="ellipse">
+            <a:avLst/>
+          </a:prstGeom>
+          <a:solidFill>
+            <a:srgbClr val="C0612C"/>
+          </a:solidFill>
+          <a:ln>
+            <a:noFill/>
+          </a:ln>
+        </p:spPr>
+        <p:txBody>
+          <a:bodyPr rtlCol="0" anchor="ctr" wrap="square" lIns="0" tIns="0" rIns="0" bIns="0">
+            <a:noAutofit/>
+          </a:bodyPr>
+          <a:lstStyle/>
+          <a:p>
+            <a:pPr algn="ctr" latinLnBrk="0">
+              <a:lnSpc>
+                <a:spcPct val="100000"/>
+              </a:lnSpc>
+              <a:spcBef>
+                <a:spcPts val="0"/>
+              </a:spcBef>
+              <a:spcAft>
+                <a:spcPts val="0"/>
+              </a:spcAft>
+            </a:pPr>
+            <a:r>
+              <a:rPr sz="1100" b="1">
+                <a:solidFill>
+                  <a:srgbClr val="FFFFFF"/>
+                </a:solidFill>
+                <a:latin typeface="Arial"/>
+                <a:ea typeface="Microsoft YaHei"/>
+                <a:cs typeface="Microsoft YaHei"/>
+              </a:rPr>
+              <a:t>②</a:t>
+            </a:r>
+          </a:p>
+        </p:txBody>
+      </p:sp>
+      <p:sp>
+        <p:nvSpPr>
+          <p:cNvPr id="40" name="TextBox 39"/>
+          <p:cNvSpPr txBox="1"/>
+          <p:nvPr/>
+        </p:nvSpPr>
+        <p:spPr>
+          <a:xfrm>
+            <a:off x="7674559" y="3090672"/>
+            <a:ext cx="1188720" cy="256032"/>
+          </a:xfrm>
+          <a:prstGeom prst="rect">
+            <a:avLst/>
+          </a:prstGeom>
+          <a:noFill/>
+        </p:spPr>
+        <p:txBody>
+          <a:bodyPr wrap="square" anchor="ctr" lIns="0" tIns="0" rIns="0" bIns="0">
+            <a:noAutofit/>
+          </a:bodyPr>
+          <a:lstStyle/>
+          <a:p>
+            <a:pPr algn="l" latinLnBrk="0">
+              <a:lnSpc>
+                <a:spcPct val="100000"/>
+              </a:lnSpc>
+              <a:spcBef>
+                <a:spcPts val="0"/>
+              </a:spcBef>
+              <a:spcAft>
+                <a:spcPts val="0"/>
+              </a:spcAft>
+            </a:pPr>
+            <a:r>
+              <a:rPr sz="1150" b="1">
+                <a:solidFill>
+                  <a:srgbClr val="16202A"/>
+                </a:solidFill>
+                <a:latin typeface="Microsoft YaHei"/>
+                <a:ea typeface="Microsoft YaHei"/>
+                <a:cs typeface="Microsoft YaHei"/>
+              </a:rPr>
+              <a:t>质量达标</a:t>
+            </a:r>
+          </a:p>
+        </p:txBody>
+      </p:sp>
+      <p:sp>
+        <p:nvSpPr>
+          <p:cNvPr id="41" name="TextBox 40"/>
+          <p:cNvSpPr txBox="1"/>
+          <p:nvPr/>
+        </p:nvSpPr>
+        <p:spPr>
+          <a:xfrm>
+            <a:off x="10070287" y="3090672"/>
+            <a:ext cx="1371600" cy="256032"/>
+          </a:xfrm>
+          <a:prstGeom prst="rect">
+            <a:avLst/>
+          </a:prstGeom>
+          <a:noFill/>
+        </p:spPr>
+        <p:txBody>
+          <a:bodyPr wrap="square" anchor="ctr" lIns="0" tIns="0" rIns="0" bIns="0">
+            <a:noAutofit/>
+          </a:bodyPr>
+          <a:lstStyle/>
+          <a:p>
+            <a:pPr algn="r" latinLnBrk="0">
+              <a:lnSpc>
+                <a:spcPct val="100000"/>
+              </a:lnSpc>
+              <a:spcBef>
+                <a:spcPts val="0"/>
+              </a:spcBef>
+              <a:spcAft>
+                <a:spcPts val="0"/>
+              </a:spcAft>
+            </a:pPr>
+            <a:r>
+              <a:rPr sz="1100" b="0">
                 <a:solidFill>
                   <a:srgbClr val="66727F"/>
                 </a:solidFill>
@@ -16968,9 +17428,84 @@
                 <a:ea typeface="Microsoft YaHei"/>
                 <a:cs typeface="Microsoft YaHei"/>
               </a:rPr>
-              <a:t>待补充实际效果</a:t>
-            </a:r>
-          </a:p>
+              <a:t>本轮没拦下</a:t>
+            </a:r>
+          </a:p>
+        </p:txBody>
+      </p:sp>
+      <p:sp>
+        <p:nvSpPr>
+          <p:cNvPr id="42" name="TextBox 41"/>
+          <p:cNvSpPr txBox="1"/>
+          <p:nvPr/>
+        </p:nvSpPr>
+        <p:spPr>
+          <a:xfrm>
+            <a:off x="7674559" y="3346704"/>
+            <a:ext cx="3767328" cy="365760"/>
+          </a:xfrm>
+          <a:prstGeom prst="rect">
+            <a:avLst/>
+          </a:prstGeom>
+          <a:noFill/>
+        </p:spPr>
+        <p:txBody>
+          <a:bodyPr wrap="square" anchor="ctr" lIns="0" tIns="0" rIns="0" bIns="0">
+            <a:noAutofit/>
+          </a:bodyPr>
+          <a:lstStyle/>
+          <a:p>
+            <a:pPr algn="l" latinLnBrk="0">
+              <a:lnSpc>
+                <a:spcPct val="100000"/>
+              </a:lnSpc>
+              <a:spcBef>
+                <a:spcPts val="0"/>
+              </a:spcBef>
+              <a:spcAft>
+                <a:spcPts val="0"/>
+              </a:spcAft>
+            </a:pPr>
+            <a:r>
+              <a:rPr sz="1000" b="0">
+                <a:solidFill>
+                  <a:srgbClr val="66727F"/>
+                </a:solidFill>
+                <a:latin typeface="Microsoft YaHei"/>
+                <a:ea typeface="Microsoft YaHei"/>
+                <a:cs typeface="Microsoft YaHei"/>
+              </a:rPr>
+              <a:t>过了 ① 的候选输出逐位一致，不必再看质量</a:t>
+            </a:r>
+          </a:p>
+        </p:txBody>
+      </p:sp>
+      <p:sp>
+        <p:nvSpPr>
+          <p:cNvPr id="43" name="Oval 42"/>
+          <p:cNvSpPr/>
+          <p:nvPr/>
+        </p:nvSpPr>
+        <p:spPr>
+          <a:xfrm>
+            <a:off x="7308799" y="3776472"/>
+            <a:ext cx="274320" cy="274320"/>
+          </a:xfrm>
+          <a:prstGeom prst="ellipse">
+            <a:avLst/>
+          </a:prstGeom>
+          <a:solidFill>
+            <a:srgbClr val="C0612C"/>
+          </a:solidFill>
+          <a:ln>
+            <a:noFill/>
+          </a:ln>
+        </p:spPr>
+        <p:txBody>
+          <a:bodyPr rtlCol="0" anchor="ctr" wrap="square" lIns="0" tIns="0" rIns="0" bIns="0">
+            <a:noAutofit/>
+          </a:bodyPr>
+          <a:lstStyle/>
           <a:p>
             <a:pPr algn="ctr" latinLnBrk="0">
               <a:lnSpc>
@@ -16984,77 +17519,194 @@
               </a:spcAft>
             </a:pPr>
             <a:r>
-              <a:rPr sz="1050" b="0">
-                <a:solidFill>
-                  <a:srgbClr val="8C96A1"/>
-                </a:solidFill>
-                <a:latin typeface="Microsoft YaHei"/>
-                <a:ea typeface="Microsoft YaHei"/>
-                <a:cs typeface="Microsoft YaHei"/>
-              </a:rPr>
-              <a:t>建议：优化收益曲线</a:t>
-            </a:r>
-          </a:p>
-          <a:p>
-            <a:pPr algn="ctr" latinLnBrk="0">
-              <a:lnSpc>
-                <a:spcPct val="100000"/>
-              </a:lnSpc>
-              <a:spcBef>
-                <a:spcPts val="0"/>
-              </a:spcBef>
-              <a:spcAft>
-                <a:spcPts val="0"/>
-              </a:spcAft>
-            </a:pPr>
-            <a:r>
-              <a:rPr sz="1050" b="0">
-                <a:solidFill>
-                  <a:srgbClr val="8C96A1"/>
-                </a:solidFill>
-                <a:latin typeface="Microsoft YaHei"/>
-                <a:ea typeface="Microsoft YaHei"/>
-                <a:cs typeface="Microsoft YaHei"/>
-              </a:rPr>
-              <a:t>横轴为候选轮次，纵轴为收益；复验通过者单独标注</a:t>
-            </a:r>
-          </a:p>
-          <a:p>
-            <a:pPr algn="ctr" latinLnBrk="0">
-              <a:lnSpc>
-                <a:spcPct val="100000"/>
-              </a:lnSpc>
-              <a:spcBef>
-                <a:spcPts val="0"/>
-              </a:spcBef>
-              <a:spcAft>
-                <a:spcPts val="0"/>
-              </a:spcAft>
-            </a:pPr>
-            <a:r>
-              <a:rPr sz="950" b="0">
-                <a:solidFill>
-                  <a:srgbClr val="8C96A1"/>
-                </a:solidFill>
-                <a:latin typeface="Consolas"/>
-                <a:ea typeface="Microsoft YaHei"/>
-                <a:cs typeface="Microsoft YaHei"/>
-              </a:rPr>
-              <a:t>5.0 × 4.18 in</a:t>
-            </a:r>
-          </a:p>
-        </p:txBody>
-      </p:sp>
-      <p:sp>
-        <p:nvSpPr>
-          <p:cNvPr id="32" name="Rectangle 31"/>
+              <a:rPr sz="1100" b="1">
+                <a:solidFill>
+                  <a:srgbClr val="FFFFFF"/>
+                </a:solidFill>
+                <a:latin typeface="Arial"/>
+                <a:ea typeface="Microsoft YaHei"/>
+                <a:cs typeface="Microsoft YaHei"/>
+              </a:rPr>
+              <a:t>③</a:t>
+            </a:r>
+          </a:p>
+        </p:txBody>
+      </p:sp>
+      <p:sp>
+        <p:nvSpPr>
+          <p:cNvPr id="44" name="TextBox 43"/>
+          <p:cNvSpPr txBox="1"/>
+          <p:nvPr/>
+        </p:nvSpPr>
+        <p:spPr>
+          <a:xfrm>
+            <a:off x="7674559" y="3749039"/>
+            <a:ext cx="1188720" cy="256032"/>
+          </a:xfrm>
+          <a:prstGeom prst="rect">
+            <a:avLst/>
+          </a:prstGeom>
+          <a:noFill/>
+        </p:spPr>
+        <p:txBody>
+          <a:bodyPr wrap="square" anchor="ctr" lIns="0" tIns="0" rIns="0" bIns="0">
+            <a:noAutofit/>
+          </a:bodyPr>
+          <a:lstStyle/>
+          <a:p>
+            <a:pPr algn="l" latinLnBrk="0">
+              <a:lnSpc>
+                <a:spcPct val="100000"/>
+              </a:lnSpc>
+              <a:spcBef>
+                <a:spcPts val="0"/>
+              </a:spcBef>
+              <a:spcAft>
+                <a:spcPts val="0"/>
+              </a:spcAft>
+            </a:pPr>
+            <a:r>
+              <a:rPr sz="1150" b="1">
+                <a:solidFill>
+                  <a:srgbClr val="16202A"/>
+                </a:solidFill>
+                <a:latin typeface="Microsoft YaHei"/>
+                <a:ea typeface="Microsoft YaHei"/>
+                <a:cs typeface="Microsoft YaHei"/>
+              </a:rPr>
+              <a:t>确实更快</a:t>
+            </a:r>
+          </a:p>
+        </p:txBody>
+      </p:sp>
+      <p:sp>
+        <p:nvSpPr>
+          <p:cNvPr id="45" name="TextBox 44"/>
+          <p:cNvSpPr txBox="1"/>
+          <p:nvPr/>
+        </p:nvSpPr>
+        <p:spPr>
+          <a:xfrm>
+            <a:off x="10070287" y="3749039"/>
+            <a:ext cx="1371600" cy="256032"/>
+          </a:xfrm>
+          <a:prstGeom prst="rect">
+            <a:avLst/>
+          </a:prstGeom>
+          <a:noFill/>
+        </p:spPr>
+        <p:txBody>
+          <a:bodyPr wrap="square" anchor="ctr" lIns="0" tIns="0" rIns="0" bIns="0">
+            <a:noAutofit/>
+          </a:bodyPr>
+          <a:lstStyle/>
+          <a:p>
+            <a:pPr algn="r" latinLnBrk="0">
+              <a:lnSpc>
+                <a:spcPct val="100000"/>
+              </a:lnSpc>
+              <a:spcBef>
+                <a:spcPts val="0"/>
+              </a:spcBef>
+              <a:spcAft>
+                <a:spcPts val="0"/>
+              </a:spcAft>
+            </a:pPr>
+            <a:r>
+              <a:rPr sz="1100" b="1">
+                <a:solidFill>
+                  <a:srgbClr val="B4382F"/>
+                </a:solidFill>
+                <a:latin typeface="Microsoft YaHei"/>
+                <a:ea typeface="Microsoft YaHei"/>
+                <a:cs typeface="Microsoft YaHei"/>
+              </a:rPr>
+              <a:t>挡掉 3 组</a:t>
+            </a:r>
+          </a:p>
+        </p:txBody>
+      </p:sp>
+      <p:sp>
+        <p:nvSpPr>
+          <p:cNvPr id="46" name="TextBox 45"/>
+          <p:cNvSpPr txBox="1"/>
+          <p:nvPr/>
+        </p:nvSpPr>
+        <p:spPr>
+          <a:xfrm>
+            <a:off x="7674559" y="4005072"/>
+            <a:ext cx="3767328" cy="365760"/>
+          </a:xfrm>
+          <a:prstGeom prst="rect">
+            <a:avLst/>
+          </a:prstGeom>
+          <a:noFill/>
+        </p:spPr>
+        <p:txBody>
+          <a:bodyPr wrap="square" anchor="ctr" lIns="0" tIns="0" rIns="0" bIns="0">
+            <a:noAutofit/>
+          </a:bodyPr>
+          <a:lstStyle/>
+          <a:p>
+            <a:pPr algn="l" latinLnBrk="0">
+              <a:lnSpc>
+                <a:spcPct val="100000"/>
+              </a:lnSpc>
+              <a:spcBef>
+                <a:spcPts val="0"/>
+              </a:spcBef>
+              <a:spcAft>
+                <a:spcPts val="0"/>
+              </a:spcAft>
+            </a:pPr>
+            <a:r>
+              <a:rPr sz="1000" b="0">
+                <a:solidFill>
+                  <a:srgbClr val="35424F"/>
+                </a:solidFill>
+                <a:latin typeface="Microsoft YaHei"/>
+                <a:ea typeface="Microsoft YaHei"/>
+                <a:cs typeface="Microsoft YaHei"/>
+              </a:rPr>
+              <a:t>强制不分组 −20%；换现成核 0.61× 更慢；</a:t>
+            </a:r>
+          </a:p>
+          <a:p>
+            <a:pPr algn="l" latinLnBrk="0">
+              <a:lnSpc>
+                <a:spcPct val="100000"/>
+              </a:lnSpc>
+              <a:spcBef>
+                <a:spcPts val="0"/>
+              </a:spcBef>
+              <a:spcAft>
+                <a:spcPts val="0"/>
+              </a:spcAft>
+            </a:pPr>
+            <a:r>
+              <a:rPr sz="1000" b="0">
+                <a:solidFill>
+                  <a:srgbClr val="35424F"/>
+                </a:solidFill>
+                <a:latin typeface="Microsoft YaHei"/>
+                <a:ea typeface="Microsoft YaHei"/>
+                <a:cs typeface="Microsoft YaHei"/>
+              </a:rPr>
+              <a:t>路由融合最多只值 0.9%，够不着 3% 的门槛</a:t>
+            </a:r>
+          </a:p>
+        </p:txBody>
+      </p:sp>
+      <p:sp>
+        <p:nvSpPr>
+          <p:cNvPr id="47" name="Rectangle 46"/>
           <p:cNvSpPr/>
           <p:nvPr/>
         </p:nvSpPr>
         <p:spPr>
           <a:xfrm>
-            <a:off x="548640" y="5632704"/>
-            <a:ext cx="11094415" cy="475488"/>
+            <a:off x="7272223" y="4425696"/>
+            <a:ext cx="4169663" cy="713232"/>
           </a:xfrm>
           <a:prstGeom prst="rect">
             <a:avLst/>
@@ -17076,7 +17728,257 @@
       </p:sp>
       <p:sp>
         <p:nvSpPr>
-          <p:cNvPr id="33" name="Rectangle 32"/>
+          <p:cNvPr id="48" name="TextBox 47"/>
+          <p:cNvSpPr txBox="1"/>
+          <p:nvPr/>
+        </p:nvSpPr>
+        <p:spPr>
+          <a:xfrm>
+            <a:off x="7436815" y="4462272"/>
+            <a:ext cx="3840480" cy="237744"/>
+          </a:xfrm>
+          <a:prstGeom prst="rect">
+            <a:avLst/>
+          </a:prstGeom>
+          <a:noFill/>
+        </p:spPr>
+        <p:txBody>
+          <a:bodyPr wrap="square" anchor="ctr" lIns="0" tIns="0" rIns="0" bIns="0">
+            <a:noAutofit/>
+          </a:bodyPr>
+          <a:lstStyle/>
+          <a:p>
+            <a:pPr algn="l" latinLnBrk="0">
+              <a:lnSpc>
+                <a:spcPct val="100000"/>
+              </a:lnSpc>
+              <a:spcBef>
+                <a:spcPts val="0"/>
+              </a:spcBef>
+              <a:spcAft>
+                <a:spcPts val="0"/>
+              </a:spcAft>
+            </a:pPr>
+            <a:r>
+              <a:rPr sz="1100" b="1">
+                <a:solidFill>
+                  <a:srgbClr val="16202A"/>
+                </a:solidFill>
+                <a:latin typeface="Microsoft YaHei"/>
+                <a:ea typeface="Microsoft YaHei"/>
+                <a:cs typeface="Microsoft YaHei"/>
+              </a:rPr>
+              <a:t>三道全过</a:t>
+            </a:r>
+            <a:r>
+              <a:rPr sz="1100" b="1">
+                <a:solidFill>
+                  <a:srgbClr val="3F63A8"/>
+                </a:solidFill>
+                <a:latin typeface="Microsoft YaHei"/>
+                <a:ea typeface="Microsoft YaHei"/>
+                <a:cs typeface="Microsoft YaHei"/>
+              </a:rPr>
+              <a:t>　2 组 · 交付</a:t>
+            </a:r>
+          </a:p>
+        </p:txBody>
+      </p:sp>
+      <p:sp>
+        <p:nvSpPr>
+          <p:cNvPr id="49" name="TextBox 48"/>
+          <p:cNvSpPr txBox="1"/>
+          <p:nvPr/>
+        </p:nvSpPr>
+        <p:spPr>
+          <a:xfrm>
+            <a:off x="7436815" y="4700016"/>
+            <a:ext cx="3840480" cy="201168"/>
+          </a:xfrm>
+          <a:prstGeom prst="rect">
+            <a:avLst/>
+          </a:prstGeom>
+          <a:noFill/>
+        </p:spPr>
+        <p:txBody>
+          <a:bodyPr wrap="square" anchor="ctr" lIns="0" tIns="0" rIns="0" bIns="0">
+            <a:noAutofit/>
+          </a:bodyPr>
+          <a:lstStyle/>
+          <a:p>
+            <a:pPr algn="l" latinLnBrk="0">
+              <a:lnSpc>
+                <a:spcPct val="100000"/>
+              </a:lnSpc>
+              <a:spcBef>
+                <a:spcPts val="0"/>
+              </a:spcBef>
+              <a:spcAft>
+                <a:spcPts val="0"/>
+              </a:spcAft>
+            </a:pPr>
+            <a:r>
+              <a:rPr sz="1000" b="0">
+                <a:solidFill>
+                  <a:srgbClr val="35424F"/>
+                </a:solidFill>
+                <a:latin typeface="Microsoft YaHei"/>
+                <a:ea typeface="Microsoft YaHei"/>
+                <a:cs typeface="Microsoft YaHei"/>
+              </a:rPr>
+              <a:t>· 激活与量化合成一个核</a:t>
+            </a:r>
+          </a:p>
+        </p:txBody>
+      </p:sp>
+      <p:sp>
+        <p:nvSpPr>
+          <p:cNvPr id="50" name="TextBox 49"/>
+          <p:cNvSpPr txBox="1"/>
+          <p:nvPr/>
+        </p:nvSpPr>
+        <p:spPr>
+          <a:xfrm>
+            <a:off x="7436815" y="4901183"/>
+            <a:ext cx="3840480" cy="201168"/>
+          </a:xfrm>
+          <a:prstGeom prst="rect">
+            <a:avLst/>
+          </a:prstGeom>
+          <a:noFill/>
+        </p:spPr>
+        <p:txBody>
+          <a:bodyPr wrap="square" anchor="ctr" lIns="0" tIns="0" rIns="0" bIns="0">
+            <a:noAutofit/>
+          </a:bodyPr>
+          <a:lstStyle/>
+          <a:p>
+            <a:pPr algn="l" latinLnBrk="0">
+              <a:lnSpc>
+                <a:spcPct val="100000"/>
+              </a:lnSpc>
+              <a:spcBef>
+                <a:spcPts val="0"/>
+              </a:spcBef>
+              <a:spcAft>
+                <a:spcPts val="0"/>
+              </a:spcAft>
+            </a:pPr>
+            <a:r>
+              <a:rPr sz="1000" b="0">
+                <a:solidFill>
+                  <a:srgbClr val="35424F"/>
+                </a:solidFill>
+                <a:latin typeface="Microsoft YaHei"/>
+                <a:ea typeface="Microsoft YaHei"/>
+                <a:cs typeface="Microsoft YaHei"/>
+              </a:rPr>
+              <a:t>· 换成耗时不随规模涨的核</a:t>
+            </a:r>
+          </a:p>
+        </p:txBody>
+      </p:sp>
+      <p:sp>
+        <p:nvSpPr>
+          <p:cNvPr id="51" name="TextBox 50"/>
+          <p:cNvSpPr txBox="1"/>
+          <p:nvPr/>
+        </p:nvSpPr>
+        <p:spPr>
+          <a:xfrm>
+            <a:off x="7272223" y="5212079"/>
+            <a:ext cx="4169663" cy="237744"/>
+          </a:xfrm>
+          <a:prstGeom prst="rect">
+            <a:avLst/>
+          </a:prstGeom>
+          <a:noFill/>
+        </p:spPr>
+        <p:txBody>
+          <a:bodyPr wrap="square" anchor="ctr" lIns="0" tIns="0" rIns="0" bIns="0">
+            <a:noAutofit/>
+          </a:bodyPr>
+          <a:lstStyle/>
+          <a:p>
+            <a:pPr algn="l" latinLnBrk="0">
+              <a:lnSpc>
+                <a:spcPct val="100000"/>
+              </a:lnSpc>
+              <a:spcBef>
+                <a:spcPts val="0"/>
+              </a:spcBef>
+              <a:spcAft>
+                <a:spcPts val="0"/>
+              </a:spcAft>
+            </a:pPr>
+            <a:r>
+              <a:rPr sz="1000" b="0">
+                <a:solidFill>
+                  <a:srgbClr val="66727F"/>
+                </a:solidFill>
+                <a:latin typeface="Microsoft YaHei"/>
+                <a:ea typeface="Microsoft YaHei"/>
+                <a:cs typeface="Microsoft YaHei"/>
+              </a:rPr>
+              <a:t>峰值吞吐 </a:t>
+            </a:r>
+            <a:r>
+              <a:rPr sz="1000" b="1">
+                <a:solidFill>
+                  <a:srgbClr val="16202A"/>
+                </a:solidFill>
+                <a:latin typeface="Consolas"/>
+                <a:ea typeface="Microsoft YaHei"/>
+                <a:cs typeface="Microsoft YaHei"/>
+              </a:rPr>
+              <a:t>1370 → 1883 tok/s</a:t>
+            </a:r>
+            <a:r>
+              <a:rPr sz="1100" b="1">
+                <a:solidFill>
+                  <a:srgbClr val="3F63A8"/>
+                </a:solidFill>
+                <a:latin typeface="Consolas"/>
+                <a:ea typeface="Microsoft YaHei"/>
+                <a:cs typeface="Microsoft YaHei"/>
+              </a:rPr>
+              <a:t>　+37%</a:t>
+            </a:r>
+          </a:p>
+        </p:txBody>
+      </p:sp>
+      <p:sp>
+        <p:nvSpPr>
+          <p:cNvPr id="52" name="Rectangle 51"/>
+          <p:cNvSpPr/>
+          <p:nvPr/>
+        </p:nvSpPr>
+        <p:spPr>
+          <a:xfrm>
+            <a:off x="548640" y="5632704"/>
+            <a:ext cx="11094415" cy="475488"/>
+          </a:xfrm>
+          <a:prstGeom prst="rect">
+            <a:avLst/>
+          </a:prstGeom>
+          <a:solidFill>
+            <a:srgbClr val="F8EADF"/>
+          </a:solidFill>
+          <a:ln>
+            <a:noFill/>
+          </a:ln>
+        </p:spPr>
+        <p:txBody>
+          <a:bodyPr rtlCol="0" anchor="ctr"/>
+          <a:lstStyle/>
+          <a:p>
+            <a:pPr algn="ctr"/>
+          </a:p>
+        </p:txBody>
+      </p:sp>
+      <p:sp>
+        <p:nvSpPr>
+          <p:cNvPr id="53" name="Rectangle 52"/>
           <p:cNvSpPr/>
           <p:nvPr/>
         </p:nvSpPr>
@@ -17105,7 +18007,7 @@
       </p:sp>
       <p:sp>
         <p:nvSpPr>
-          <p:cNvPr id="34" name="TextBox 33"/>
+          <p:cNvPr id="54" name="TextBox 53"/>
           <p:cNvSpPr txBox="1"/>
           <p:nvPr/>
         </p:nvSpPr>
@@ -17163,7 +18065,7 @@
       </p:sp>
       <p:sp>
         <p:nvSpPr>
-          <p:cNvPr id="35" name="TextBox 34"/>
+          <p:cNvPr id="55" name="TextBox 54"/>
           <p:cNvSpPr txBox="1"/>
           <p:nvPr/>
         </p:nvSpPr>
@@ -17210,7 +18112,7 @@
       </p:sp>
       <p:sp>
         <p:nvSpPr>
-          <p:cNvPr id="36" name="TextBox 35"/>
+          <p:cNvPr id="56" name="TextBox 55"/>
           <p:cNvSpPr txBox="1"/>
           <p:nvPr/>
         </p:nvSpPr>

</xml_diff>